<commit_message>
model+deck: 가동률 85%/82%(DC수요) 반영 — run-rate EBITDA·시나리오 갱신
- eff 토글 0.80→1.00(히든 해구트 제거 → util곡선=실효 가동률)
- util plateau: BA 85% / OT 82% (run-rate)
  → run-rate ex-AMPC EBITDA $442→$554mm, DCF EV $4.0→$5.0bn, FCFE +2.4bn
  마진 9%·pre-SOP 기저 floor $0.2bn·2026 $200mm 유지
- 역산 시나리오(분모 $554mm): BASE 19.3→15.4x, ①/② 14.1x, ①+② 13.3x
  = peer 상단(13x) 사실상 안착(잔여 +0.3x)
- 덱 S2(가동률/매출/EBITDA/EV KPI)·S4(가정·표·밴드바·결론) 동기화
- CLAUDE.md·펀딩구조_v2 검산표/역산표 갱신

Co-Authored-By: Claude Opus 4.8 <noreply@anthropic.com>
Claude-Session: https://claude.ai/code/session_019MWAFoC5mEReHSPt6vQXor
</commit_message>
<xml_diff>
--- a/sk_valuation_project/output/SK_Funding_v3_editable.pptx
+++ b/sk_valuation_project/output/SK_Funding_v3_editable.pptx
@@ -2025,7 +2025,7 @@
                           <a:ea typeface="IBM Plex Sans KR" pitchFamily="34" charset="-122"/>
                           <a:cs typeface="IBM Plex Sans KR" pitchFamily="34" charset="-120"/>
                         </a:rPr>
-                        <a:t>명판 / 가동(COD)</a:t>
+                        <a:t>명판 / 가동률(run-rate)</a:t>
                       </a:r>
                       <a:endParaRPr lang="en-US" sz="950" dirty="0">
                         <a:latin typeface="IBM Plex Sans KR" charset="0"/>
@@ -2087,13 +2087,13 @@
                       <a:r>
                         <a:rPr lang="en-US" sz="950" b="1" dirty="0">
                           <a:solidFill>
-                            <a:srgbClr val="1B1714"/>
+                            <a:srgbClr val="1E7A4D"/>
                           </a:solidFill>
                           <a:latin typeface="IBM Plex Mono" pitchFamily="34" charset="0"/>
                           <a:ea typeface="IBM Plex Mono" pitchFamily="34" charset="-122"/>
                           <a:cs typeface="IBM Plex Mono" pitchFamily="34" charset="-120"/>
                         </a:rPr>
-                        <a:t>21.2 GWh / 2027~28</a:t>
+                        <a:t>21.2 GWh / 85%</a:t>
                       </a:r>
                       <a:endParaRPr lang="en-US" sz="950" dirty="0">
                         <a:latin typeface="IBM Plex Mono" charset="0"/>
@@ -2369,7 +2369,7 @@
                           <a:ea typeface="IBM Plex Mono" pitchFamily="34" charset="-122"/>
                           <a:cs typeface="IBM Plex Mono" pitchFamily="34" charset="-120"/>
                         </a:rPr>
-                        <a:t>~$2.2bn</a:t>
+                        <a:t>~$2.7bn</a:t>
                       </a:r>
                       <a:endParaRPr lang="en-US" sz="950" dirty="0">
                         <a:latin typeface="IBM Plex Mono" charset="0"/>
@@ -3003,7 +3003,7 @@
                           <a:ea typeface="IBM Plex Sans KR" pitchFamily="34" charset="-122"/>
                           <a:cs typeface="IBM Plex Sans KR" pitchFamily="34" charset="-120"/>
                         </a:rPr>
-                        <a:t>명판 / 가동(COD)</a:t>
+                        <a:t>명판 / 가동률(run-rate)</a:t>
                       </a:r>
                       <a:endParaRPr lang="en-US" sz="950" dirty="0">
                         <a:latin typeface="IBM Plex Sans KR" charset="0"/>
@@ -3065,13 +3065,13 @@
                       <a:r>
                         <a:rPr lang="en-US" sz="950" b="1" dirty="0">
                           <a:solidFill>
-                            <a:srgbClr val="1B1714"/>
+                            <a:srgbClr val="1E7A4D"/>
                           </a:solidFill>
                           <a:latin typeface="IBM Plex Mono" pitchFamily="34" charset="0"/>
                           <a:ea typeface="IBM Plex Mono" pitchFamily="34" charset="-122"/>
                           <a:cs typeface="IBM Plex Mono" pitchFamily="34" charset="-120"/>
                         </a:rPr>
-                        <a:t>29.7 GWh / 2028</a:t>
+                        <a:t>29.7 GWh / 82%</a:t>
                       </a:r>
                       <a:endParaRPr lang="en-US" sz="950" dirty="0">
                         <a:latin typeface="IBM Plex Mono" charset="0"/>
@@ -3347,7 +3347,7 @@
                           <a:ea typeface="IBM Plex Mono" pitchFamily="34" charset="-122"/>
                           <a:cs typeface="IBM Plex Mono" pitchFamily="34" charset="-120"/>
                         </a:rPr>
-                        <a:t>~$2.7bn</a:t>
+                        <a:t>~$3.5bn</a:t>
                       </a:r>
                       <a:endParaRPr lang="en-US" sz="950" dirty="0">
                         <a:latin typeface="IBM Plex Mono" charset="0"/>
@@ -4108,7 +4108,7 @@
                 <a:ea typeface="IBM Plex Sans KR" pitchFamily="34" charset="-122"/>
                 <a:cs typeface="IBM Plex Sans KR" pitchFamily="34" charset="-120"/>
               </a:rPr>
-              <a:t>DC블록 ASP $155/kWh 사업화 — 셀+모듈+컨테이너</a:t>
+              <a:t>DC센터 수요 확보 → 가동률 85% (BA)·82% (OT) run-rate</a:t>
             </a:r>
             <a:endParaRPr lang="en-US" sz="1050" dirty="0"/>
           </a:p>
@@ -4186,7 +4186,7 @@
                 <a:ea typeface="IBM Plex Sans KR" pitchFamily="34" charset="-122"/>
                 <a:cs typeface="IBM Plex Sans KR" pitchFamily="34" charset="-120"/>
               </a:rPr>
-              <a:t>SKBA pre-SOP 기저 $0.2bn(2026~) · run-rate ex-AMPC $442mm 유지</a:t>
+              <a:t>run-rate ex-AMPC EBITDA $554mm (BA 241 + OT 313, 9% 마진)</a:t>
             </a:r>
             <a:endParaRPr lang="en-US" sz="1050" dirty="0"/>
           </a:p>
@@ -4264,7 +4264,7 @@
                 <a:ea typeface="IBM Plex Sans KR" pitchFamily="34" charset="-122"/>
                 <a:cs typeface="IBM Plex Sans KR" pitchFamily="34" charset="-120"/>
               </a:rPr>
-              <a:t>DCF EV ≈ $4.0bn (기저 조기현금 반영·밴드 $3.5~4.5bn)</a:t>
+              <a:t>DCF EV ≈ $5.0bn (가동률 상향 반영·pre-SOP 기저 $0.2bn 포함)</a:t>
             </a:r>
             <a:endParaRPr lang="en-US" sz="1050" dirty="0"/>
           </a:p>
@@ -4558,7 +4558,7 @@
                 <a:ea typeface="Space Grotesk" pitchFamily="34" charset="-122"/>
                 <a:cs typeface="Space Grotesk" pitchFamily="34" charset="-120"/>
               </a:rPr>
-              <a:t>442</a:t>
+              <a:t>554</a:t>
             </a:r>
             <a:pPr indent="0" marL="0">
               <a:buNone/>
@@ -4788,7 +4788,7 @@
                 <a:ea typeface="Space Grotesk" pitchFamily="34" charset="-122"/>
                 <a:cs typeface="Space Grotesk" pitchFamily="34" charset="-120"/>
               </a:rPr>
-              <a:t>4.0</a:t>
+              <a:t>5.0</a:t>
             </a:r>
             <a:pPr indent="0" marL="0">
               <a:buNone/>
@@ -7122,7 +7122,7 @@
                 <a:ea typeface="IBM Plex Sans KR" pitchFamily="34" charset="-122"/>
                 <a:cs typeface="IBM Plex Sans KR" pitchFamily="34" charset="-120"/>
               </a:rPr>
-              <a:t>공급 셀 (개조 후)</a:t>
+              <a:t>가동률 (run-rate) ★</a:t>
             </a:r>
             <a:endParaRPr lang="en-US" sz="950" dirty="0"/>
           </a:p>
@@ -7155,13 +7155,13 @@
             <a:r>
               <a:rPr lang="en-US" sz="1000" b="1" dirty="0">
                 <a:solidFill>
-                  <a:srgbClr val="1B1714"/>
+                  <a:srgbClr val="1E7A4D"/>
                 </a:solidFill>
                 <a:latin typeface="IBM Plex Mono" pitchFamily="34" charset="0"/>
                 <a:ea typeface="IBM Plex Mono" pitchFamily="34" charset="-122"/>
                 <a:cs typeface="IBM Plex Mono" pitchFamily="34" charset="-120"/>
               </a:rPr>
-              <a:t>파우치+각형</a:t>
+              <a:t>85%/82% DC수요</a:t>
             </a:r>
             <a:endParaRPr lang="en-US" sz="1000" dirty="0"/>
           </a:p>
@@ -7357,13 +7357,13 @@
             <a:r>
               <a:rPr lang="en-US" sz="1000" b="1" dirty="0">
                 <a:solidFill>
-                  <a:srgbClr val="1B1714"/>
+                  <a:srgbClr val="1E7A4D"/>
                 </a:solidFill>
                 <a:latin typeface="IBM Plex Mono" pitchFamily="34" charset="0"/>
                 <a:ea typeface="IBM Plex Mono" pitchFamily="34" charset="-122"/>
                 <a:cs typeface="IBM Plex Mono" pitchFamily="34" charset="-120"/>
               </a:rPr>
-              <a:t>$442mm</a:t>
+              <a:t>$554mm</a:t>
             </a:r>
             <a:endParaRPr lang="en-US" sz="1000" dirty="0"/>
           </a:p>
@@ -8654,7 +8654,7 @@
                           <a:ea typeface="Space Grotesk" pitchFamily="34" charset="-122"/>
                           <a:cs typeface="Space Grotesk" pitchFamily="34" charset="-120"/>
                         </a:rPr>
-                        <a:t>19.3x</a:t>
+                        <a:t>15.4x</a:t>
                       </a:r>
                       <a:endParaRPr lang="en-US" sz="1200" dirty="0">
                         <a:latin typeface="Space Grotesk" charset="0"/>
@@ -8722,7 +8722,7 @@
                           <a:ea typeface="IBM Plex Mono" pitchFamily="34" charset="-122"/>
                           <a:cs typeface="IBM Plex Mono" pitchFamily="34" charset="-120"/>
                         </a:rPr>
-                        <a:t>+6.3x</a:t>
+                        <a:t>+2.4x</a:t>
                       </a:r>
                       <a:endParaRPr lang="en-US" sz="800" dirty="0">
                         <a:latin typeface="IBM Plex Mono" charset="0"/>
@@ -9064,7 +9064,7 @@
                           <a:ea typeface="Space Grotesk" pitchFamily="34" charset="-122"/>
                           <a:cs typeface="Space Grotesk" pitchFamily="34" charset="-120"/>
                         </a:rPr>
-                        <a:t>17.7x</a:t>
+                        <a:t>14.1x</a:t>
                       </a:r>
                       <a:endParaRPr lang="en-US" sz="1200" dirty="0">
                         <a:latin typeface="Space Grotesk" charset="0"/>
@@ -9132,7 +9132,7 @@
                           <a:ea typeface="IBM Plex Mono" pitchFamily="34" charset="-122"/>
                           <a:cs typeface="IBM Plex Mono" pitchFamily="34" charset="-120"/>
                         </a:rPr>
-                        <a:t>+4.7x</a:t>
+                        <a:t>+1.1x</a:t>
                       </a:r>
                       <a:endParaRPr lang="en-US" sz="800" dirty="0">
                         <a:latin typeface="IBM Plex Mono" charset="0"/>
@@ -9474,7 +9474,7 @@
                           <a:ea typeface="Space Grotesk" pitchFamily="34" charset="-122"/>
                           <a:cs typeface="Space Grotesk" pitchFamily="34" charset="-120"/>
                         </a:rPr>
-                        <a:t>17.7x</a:t>
+                        <a:t>14.1x</a:t>
                       </a:r>
                       <a:endParaRPr lang="en-US" sz="1200" dirty="0">
                         <a:latin typeface="Space Grotesk" charset="0"/>
@@ -9542,7 +9542,7 @@
                           <a:ea typeface="IBM Plex Mono" pitchFamily="34" charset="-122"/>
                           <a:cs typeface="IBM Plex Mono" pitchFamily="34" charset="-120"/>
                         </a:rPr>
-                        <a:t>+4.7x</a:t>
+                        <a:t>+1.1x</a:t>
                       </a:r>
                       <a:endParaRPr lang="en-US" sz="800" dirty="0">
                         <a:latin typeface="IBM Plex Mono" charset="0"/>
@@ -9878,13 +9878,13 @@
                       <a:r>
                         <a:rPr lang="en-US" sz="1200" b="1" dirty="0">
                           <a:solidFill>
-                            <a:srgbClr val="C1121F"/>
+                            <a:srgbClr val="1E7A4D"/>
                           </a:solidFill>
                           <a:latin typeface="Space Grotesk" pitchFamily="34" charset="0"/>
                           <a:ea typeface="Space Grotesk" pitchFamily="34" charset="-122"/>
                           <a:cs typeface="Space Grotesk" pitchFamily="34" charset="-120"/>
                         </a:rPr>
-                        <a:t>16.6x</a:t>
+                        <a:t>13.3x</a:t>
                       </a:r>
                       <a:endParaRPr lang="en-US" sz="1200" dirty="0">
                         <a:latin typeface="Space Grotesk" charset="0"/>
@@ -9946,13 +9946,13 @@
                       <a:r>
                         <a:rPr lang="en-US" sz="800" b="1" dirty="0">
                           <a:solidFill>
-                            <a:srgbClr val="6F6960"/>
+                            <a:srgbClr val="1E7A4D"/>
                           </a:solidFill>
                           <a:latin typeface="IBM Plex Mono" pitchFamily="34" charset="0"/>
                           <a:ea typeface="IBM Plex Mono" pitchFamily="34" charset="-122"/>
                           <a:cs typeface="IBM Plex Mono" pitchFamily="34" charset="-120"/>
                         </a:rPr>
-                        <a:t>+3.6x</a:t>
+                        <a:t>+0.3x</a:t>
                       </a:r>
                       <a:endParaRPr lang="en-US" sz="800" dirty="0">
                         <a:latin typeface="IBM Plex Mono" charset="0"/>
@@ -10079,7 +10079,7 @@
         <p:spPr>
           <a:xfrm>
             <a:off x="4178808" y="4992624"/>
-            <a:ext cx="2228850" cy="164592"/>
+            <a:ext cx="2971800" cy="164592"/>
           </a:xfrm>
           <a:prstGeom prst="rect">
             <a:avLst/>
@@ -10104,7 +10104,7 @@
         <p:spPr>
           <a:xfrm>
             <a:off x="4178808" y="4764024"/>
-            <a:ext cx="2228850" cy="182880"/>
+            <a:ext cx="2971800" cy="182880"/>
           </a:xfrm>
           <a:prstGeom prst="rect">
             <a:avLst/>
@@ -10142,8 +10142,8 @@
         </p:nvSpPr>
         <p:spPr>
           <a:xfrm>
-            <a:off x="8012430" y="4855464"/>
-            <a:ext cx="1203579" cy="0"/>
+            <a:off x="7328916" y="4855464"/>
+            <a:ext cx="1248156" cy="0"/>
           </a:xfrm>
           <a:prstGeom prst="line">
             <a:avLst/>
@@ -10167,8 +10167,8 @@
         </p:nvSpPr>
         <p:spPr>
           <a:xfrm>
-            <a:off x="7738110" y="4672584"/>
-            <a:ext cx="1752219" cy="164592"/>
+            <a:off x="7054596" y="4672584"/>
+            <a:ext cx="1796796" cy="164592"/>
           </a:xfrm>
           <a:prstGeom prst="rect">
             <a:avLst/>
@@ -10192,7 +10192,7 @@
                 <a:ea typeface="IBM Plex Mono" pitchFamily="34" charset="-122"/>
                 <a:cs typeface="IBM Plex Mono" pitchFamily="34" charset="-120"/>
               </a:rPr>
-              <a:t>조달 레버 −2.7x</a:t>
+              <a:t>조달 레버 −2.1x</a:t>
             </a:r>
             <a:endParaRPr lang="en-US" sz="700" dirty="0"/>
           </a:p>
@@ -10206,7 +10206,7 @@
         </p:nvSpPr>
         <p:spPr>
           <a:xfrm>
-            <a:off x="9170289" y="5029200"/>
+            <a:off x="8531352" y="5029200"/>
             <a:ext cx="91440" cy="91440"/>
           </a:xfrm>
           <a:prstGeom prst="ellipse">
@@ -10226,7 +10226,7 @@
         </p:nvSpPr>
         <p:spPr>
           <a:xfrm>
-            <a:off x="8758809" y="5166360"/>
+            <a:off x="8119872" y="5166360"/>
             <a:ext cx="914400" cy="182880"/>
           </a:xfrm>
           <a:prstGeom prst="rect">
@@ -10265,7 +10265,7 @@
         </p:nvSpPr>
         <p:spPr>
           <a:xfrm>
-            <a:off x="8758809" y="5056632"/>
+            <a:off x="8119872" y="5056632"/>
             <a:ext cx="914400" cy="182880"/>
           </a:xfrm>
           <a:prstGeom prst="rect">
@@ -10290,7 +10290,7 @@
                 <a:ea typeface="IBM Plex Mono" pitchFamily="34" charset="-122"/>
                 <a:cs typeface="IBM Plex Mono" pitchFamily="34" charset="-120"/>
               </a:rPr>
-              <a:t>19.3x</a:t>
+              <a:t>15.4x</a:t>
             </a:r>
             <a:endParaRPr lang="en-US" sz="800" dirty="0"/>
           </a:p>
@@ -10304,7 +10304,7 @@
         </p:nvSpPr>
         <p:spPr>
           <a:xfrm>
-            <a:off x="8457057" y="5029200"/>
+            <a:off x="7758684" y="5029200"/>
             <a:ext cx="91440" cy="91440"/>
           </a:xfrm>
           <a:prstGeom prst="ellipse">
@@ -10324,7 +10324,7 @@
         </p:nvSpPr>
         <p:spPr>
           <a:xfrm>
-            <a:off x="8045577" y="5166360"/>
+            <a:off x="7347204" y="5166360"/>
             <a:ext cx="914400" cy="182880"/>
           </a:xfrm>
           <a:prstGeom prst="rect">
@@ -10363,7 +10363,7 @@
         </p:nvSpPr>
         <p:spPr>
           <a:xfrm>
-            <a:off x="8045577" y="5056632"/>
+            <a:off x="7347204" y="5056632"/>
             <a:ext cx="914400" cy="182880"/>
           </a:xfrm>
           <a:prstGeom prst="rect">
@@ -10388,7 +10388,7 @@
                 <a:ea typeface="IBM Plex Mono" pitchFamily="34" charset="-122"/>
                 <a:cs typeface="IBM Plex Mono" pitchFamily="34" charset="-120"/>
               </a:rPr>
-              <a:t>17.7x</a:t>
+              <a:t>14.1x</a:t>
             </a:r>
             <a:endParaRPr lang="en-US" sz="800" dirty="0"/>
           </a:p>
@@ -10402,14 +10402,14 @@
         </p:nvSpPr>
         <p:spPr>
           <a:xfrm>
-            <a:off x="7966710" y="5029200"/>
+            <a:off x="7283196" y="5029200"/>
             <a:ext cx="91440" cy="91440"/>
           </a:xfrm>
           <a:prstGeom prst="ellipse">
             <a:avLst/>
           </a:prstGeom>
           <a:solidFill>
-            <a:srgbClr val="8A5A55"/>
+            <a:srgbClr val="1E7A4D"/>
           </a:solidFill>
           <a:ln/>
         </p:spPr>
@@ -10422,7 +10422,7 @@
         </p:nvSpPr>
         <p:spPr>
           <a:xfrm>
-            <a:off x="7555230" y="5166360"/>
+            <a:off x="6871716" y="5166360"/>
             <a:ext cx="914400" cy="182880"/>
           </a:xfrm>
           <a:prstGeom prst="rect">
@@ -10441,7 +10441,7 @@
             <a:r>
               <a:rPr lang="en-US" sz="750" b="1" dirty="0">
                 <a:solidFill>
-                  <a:srgbClr val="8A5A55"/>
+                  <a:srgbClr val="1E7A4D"/>
                 </a:solidFill>
                 <a:latin typeface="IBM Plex Mono" pitchFamily="34" charset="0"/>
                 <a:ea typeface="IBM Plex Mono" pitchFamily="34" charset="-122"/>
@@ -10461,7 +10461,7 @@
         </p:nvSpPr>
         <p:spPr>
           <a:xfrm>
-            <a:off x="7555230" y="5056632"/>
+            <a:off x="6871716" y="5056632"/>
             <a:ext cx="914400" cy="182880"/>
           </a:xfrm>
           <a:prstGeom prst="rect">
@@ -10480,13 +10480,13 @@
             <a:r>
               <a:rPr lang="en-US" sz="800" b="1" dirty="0">
                 <a:solidFill>
-                  <a:srgbClr val="8A5A55"/>
+                  <a:srgbClr val="1E7A4D"/>
                 </a:solidFill>
                 <a:latin typeface="IBM Plex Mono" pitchFamily="34" charset="0"/>
                 <a:ea typeface="IBM Plex Mono" pitchFamily="34" charset="-122"/>
                 <a:cs typeface="IBM Plex Mono" pitchFamily="34" charset="-120"/>
               </a:rPr>
-              <a:t>16.6x</a:t>
+              <a:t>13.3x</a:t>
             </a:r>
             <a:endParaRPr lang="en-US" sz="800" dirty="0"/>
           </a:p>
@@ -10539,7 +10539,7 @@
         </p:nvSpPr>
         <p:spPr>
           <a:xfrm>
-            <a:off x="6133338" y="5330952"/>
+            <a:off x="5687568" y="5330952"/>
             <a:ext cx="548640" cy="164592"/>
           </a:xfrm>
           <a:prstGeom prst="rect">
@@ -10564,7 +10564,7 @@
                 <a:ea typeface="IBM Plex Mono" pitchFamily="34" charset="-122"/>
                 <a:cs typeface="IBM Plex Mono" pitchFamily="34" charset="-120"/>
               </a:rPr>
-              <a:t>13x</a:t>
+              <a:t>11x</a:t>
             </a:r>
             <a:endParaRPr lang="en-US" sz="700" dirty="0"/>
           </a:p>
@@ -10578,7 +10578,7 @@
         </p:nvSpPr>
         <p:spPr>
           <a:xfrm>
-            <a:off x="7470648" y="5330952"/>
+            <a:off x="6876288" y="5330952"/>
             <a:ext cx="548640" cy="164592"/>
           </a:xfrm>
           <a:prstGeom prst="rect">
@@ -10603,7 +10603,7 @@
                 <a:ea typeface="IBM Plex Mono" pitchFamily="34" charset="-122"/>
                 <a:cs typeface="IBM Plex Mono" pitchFamily="34" charset="-120"/>
               </a:rPr>
-              <a:t>16x</a:t>
+              <a:t>13x</a:t>
             </a:r>
             <a:endParaRPr lang="en-US" sz="700" dirty="0"/>
           </a:p>
@@ -10617,7 +10617,7 @@
         </p:nvSpPr>
         <p:spPr>
           <a:xfrm>
-            <a:off x="9253728" y="5330952"/>
+            <a:off x="8065008" y="5330952"/>
             <a:ext cx="548640" cy="164592"/>
           </a:xfrm>
           <a:prstGeom prst="rect">
@@ -10642,7 +10642,7 @@
                 <a:ea typeface="IBM Plex Mono" pitchFamily="34" charset="-122"/>
                 <a:cs typeface="IBM Plex Mono" pitchFamily="34" charset="-120"/>
               </a:rPr>
-              <a:t>20x</a:t>
+              <a:t>15x</a:t>
             </a:r>
             <a:endParaRPr lang="en-US" sz="700" dirty="0"/>
           </a:p>
@@ -10650,7 +10650,46 @@
       </p:sp>
       <p:sp>
         <p:nvSpPr>
-          <p:cNvPr id="53" name="Shape 50"/>
+          <p:cNvPr id="53" name="Text 50"/>
+          <p:cNvSpPr/>
+          <p:nvPr/>
+        </p:nvSpPr>
+        <p:spPr>
+          <a:xfrm>
+            <a:off x="9253728" y="5330952"/>
+            <a:ext cx="548640" cy="164592"/>
+          </a:xfrm>
+          <a:prstGeom prst="rect">
+            <a:avLst/>
+          </a:prstGeom>
+          <a:noFill/>
+          <a:ln/>
+        </p:spPr>
+        <p:txBody>
+          <a:bodyPr wrap="square" lIns="0" tIns="0" rIns="0" bIns="0" rtlCol="0" anchor="ctr"/>
+          <a:lstStyle/>
+          <a:p>
+            <a:pPr algn="ctr" indent="0" marL="0">
+              <a:buNone/>
+            </a:pPr>
+            <a:r>
+              <a:rPr lang="en-US" sz="700" dirty="0">
+                <a:solidFill>
+                  <a:srgbClr val="9A847C"/>
+                </a:solidFill>
+                <a:latin typeface="IBM Plex Mono" pitchFamily="34" charset="0"/>
+                <a:ea typeface="IBM Plex Mono" pitchFamily="34" charset="-122"/>
+                <a:cs typeface="IBM Plex Mono" pitchFamily="34" charset="-120"/>
+              </a:rPr>
+              <a:t>17x</a:t>
+            </a:r>
+            <a:endParaRPr lang="en-US" sz="700" dirty="0"/>
+          </a:p>
+        </p:txBody>
+      </p:sp>
+      <p:sp>
+        <p:nvSpPr>
+          <p:cNvPr id="54" name="Shape 51"/>
           <p:cNvSpPr/>
           <p:nvPr/>
         </p:nvSpPr>
@@ -10672,7 +10711,7 @@
       </p:sp>
       <p:sp>
         <p:nvSpPr>
-          <p:cNvPr id="54" name="Text 51"/>
+          <p:cNvPr id="55" name="Text 52"/>
           <p:cNvSpPr/>
           <p:nvPr/>
         </p:nvSpPr>
@@ -10703,7 +10742,7 @@
                 <a:ea typeface="Noto Serif KR" pitchFamily="34" charset="-122"/>
                 <a:cs typeface="Noto Serif KR" pitchFamily="34" charset="-120"/>
               </a:rPr>
-              <a:t>결론 — 조달 레버는 갭을 좁히지만, 밴드 진입은 마진이 결정한다</a:t>
+              <a:t>결론 — 가동률 85%가 멀티플을 peer 상단까지 끌어내린다</a:t>
             </a:r>
             <a:endParaRPr lang="en-US" sz="1300" dirty="0"/>
           </a:p>
@@ -10711,7 +10750,7 @@
       </p:sp>
       <p:sp>
         <p:nvSpPr>
-          <p:cNvPr id="55" name="Text 52"/>
+          <p:cNvPr id="56" name="Text 53"/>
           <p:cNvSpPr/>
           <p:nvPr/>
         </p:nvSpPr>
@@ -10745,7 +10784,7 @@
                 <a:ea typeface="IBM Plex Sans KR" pitchFamily="34" charset="-122"/>
                 <a:cs typeface="IBM Plex Sans KR" pitchFamily="34" charset="-120"/>
               </a:rPr>
-              <a:t>run-rate ex-AMPC EBITDA </a:t>
+              <a:t>DC센터 수요로 </a:t>
             </a:r>
             <a:pPr indent="0" marL="0">
               <a:lnSpc>
@@ -10762,7 +10801,7 @@
                 <a:ea typeface="IBM Plex Sans KR" pitchFamily="34" charset="-122"/>
                 <a:cs typeface="IBM Plex Sans KR" pitchFamily="34" charset="-120"/>
               </a:rPr>
-              <a:t>$442mm 유지</a:t>
+              <a:t>가동률 85%/82%</a:t>
             </a:r>
             <a:pPr indent="0" marL="0">
               <a:lnSpc>
@@ -10779,7 +10818,7 @@
                 <a:ea typeface="IBM Plex Sans KR" pitchFamily="34" charset="-122"/>
                 <a:cs typeface="IBM Plex Sans KR" pitchFamily="34" charset="-120"/>
               </a:rPr>
-              <a:t> 기준(기저 $0.2bn은 pre-SOP 조기현금·EV 방어용, run-rate 불변). </a:t>
+              <a:t> 확보 시 run-rate ex-AMPC EBITDA가 </a:t>
             </a:r>
             <a:pPr indent="0" marL="0">
               <a:lnSpc>
@@ -10796,7 +10835,7 @@
                 <a:ea typeface="IBM Plex Sans KR" pitchFamily="34" charset="-122"/>
                 <a:cs typeface="IBM Plex Sans KR" pitchFamily="34" charset="-120"/>
               </a:rPr>
-              <a:t>그랜트 20%(①)</a:t>
+              <a:t>$442→$554mm</a:t>
             </a:r>
             <a:pPr indent="0" marL="0">
               <a:lnSpc>
@@ -10813,7 +10852,7 @@
                 <a:ea typeface="IBM Plex Sans KR" pitchFamily="34" charset="-122"/>
                 <a:cs typeface="IBM Plex Sans KR" pitchFamily="34" charset="-120"/>
               </a:rPr>
-              <a:t>·</a:t>
+              <a:t>로 올라 BASE 멀티플이 </a:t>
             </a:r>
             <a:pPr indent="0" marL="0">
               <a:lnSpc>
@@ -10824,13 +10863,13 @@
             <a:r>
               <a:rPr lang="en-US" sz="950" b="1" dirty="0">
                 <a:solidFill>
-                  <a:srgbClr val="86D6A6"/>
+                  <a:srgbClr val="FF8E84"/>
                 </a:solidFill>
                 <a:latin typeface="IBM Plex Sans KR" pitchFamily="34" charset="0"/>
                 <a:ea typeface="IBM Plex Sans KR" pitchFamily="34" charset="-122"/>
                 <a:cs typeface="IBM Plex Sans KR" pitchFamily="34" charset="-120"/>
               </a:rPr>
-              <a:t>CoC 해제 30% 희석(②)</a:t>
+              <a:t>19.3x→15.4x</a:t>
             </a:r>
             <a:pPr indent="0" marL="0">
               <a:lnSpc>
@@ -10847,7 +10886,7 @@
                 <a:ea typeface="IBM Plex Sans KR" pitchFamily="34" charset="-122"/>
                 <a:cs typeface="IBM Plex Sans KR" pitchFamily="34" charset="-120"/>
               </a:rPr>
-              <a:t>은 각각 implied 멀티플을 </a:t>
+              <a:t>. 여기에 </a:t>
             </a:r>
             <a:pPr indent="0" marL="0">
               <a:lnSpc>
@@ -10858,13 +10897,13 @@
             <a:r>
               <a:rPr lang="en-US" sz="950" b="1" dirty="0">
                 <a:solidFill>
-                  <a:srgbClr val="FF8E84"/>
+                  <a:srgbClr val="86D6A6"/>
                 </a:solidFill>
                 <a:latin typeface="IBM Plex Sans KR" pitchFamily="34" charset="0"/>
                 <a:ea typeface="IBM Plex Sans KR" pitchFamily="34" charset="-122"/>
                 <a:cs typeface="IBM Plex Sans KR" pitchFamily="34" charset="-120"/>
               </a:rPr>
-              <a:t>19.3x→17.7x</a:t>
+              <a:t>그랜트 20%(①)</a:t>
             </a:r>
             <a:pPr indent="0" marL="0">
               <a:lnSpc>
@@ -10881,7 +10920,7 @@
                 <a:ea typeface="IBM Plex Sans KR" pitchFamily="34" charset="-122"/>
                 <a:cs typeface="IBM Plex Sans KR" pitchFamily="34" charset="-120"/>
               </a:rPr>
-              <a:t>, 둘 다면 </a:t>
+              <a:t> 또는 </a:t>
             </a:r>
             <a:pPr indent="0" marL="0">
               <a:lnSpc>
@@ -10892,13 +10931,13 @@
             <a:r>
               <a:rPr lang="en-US" sz="950" b="1" dirty="0">
                 <a:solidFill>
-                  <a:srgbClr val="FF8E84"/>
+                  <a:srgbClr val="86D6A6"/>
                 </a:solidFill>
                 <a:latin typeface="IBM Plex Sans KR" pitchFamily="34" charset="0"/>
                 <a:ea typeface="IBM Plex Sans KR" pitchFamily="34" charset="-122"/>
                 <a:cs typeface="IBM Plex Sans KR" pitchFamily="34" charset="-120"/>
               </a:rPr>
-              <a:t>16.6x</a:t>
+              <a:t>CoC 해제 30% 희석(②)</a:t>
             </a:r>
             <a:pPr indent="0" marL="0">
               <a:lnSpc>
@@ -10915,7 +10954,7 @@
                 <a:ea typeface="IBM Plex Sans KR" pitchFamily="34" charset="-122"/>
                 <a:cs typeface="IBM Plex Sans KR" pitchFamily="34" charset="-120"/>
               </a:rPr>
-              <a:t>로 낮춰 peer(8~13x)에 근접시키나 밴드까진 못 미친다. 잔여 갭(~3.6x)은 </a:t>
+              <a:t>은 각각 14.1x, 둘 다면 </a:t>
             </a:r>
             <a:pPr indent="0" marL="0">
               <a:lnSpc>
@@ -10932,7 +10971,7 @@
                 <a:ea typeface="IBM Plex Sans KR" pitchFamily="34" charset="-122"/>
                 <a:cs typeface="IBM Plex Sans KR" pitchFamily="34" charset="-120"/>
               </a:rPr>
-              <a:t>ex-AMPC EBITDA를 ~22%로</a:t>
+              <a:t>13.3x — peer 상단(13x)에 사실상 안착</a:t>
             </a:r>
             <a:pPr indent="0" marL="0">
               <a:lnSpc>
@@ -10949,7 +10988,7 @@
                 <a:ea typeface="IBM Plex Sans KR" pitchFamily="34" charset="-122"/>
                 <a:cs typeface="IBM Plex Sans KR" pitchFamily="34" charset="-120"/>
               </a:rPr>
-              <a:t> 올리거나 시장이 프리미엄 멀티플을 줄 때 닫힌다. ★ 순차입금 $6.4bn·부채비중 60% 고정</a:t>
+              <a:t> (잔여 +0.3x). 남는 미세 갭은 마진(ex-AMPC EBITDA)이나 시장 프리미엄이 닫는다. ★ 순차입금 $6.4bn·부채비중 60% 고정</a:t>
             </a:r>
             <a:endParaRPr lang="en-US" sz="950" dirty="0"/>
           </a:p>
@@ -10957,7 +10996,7 @@
       </p:sp>
       <p:sp>
         <p:nvSpPr>
-          <p:cNvPr id="56" name="Shape 53"/>
+          <p:cNvPr id="57" name="Shape 54"/>
           <p:cNvSpPr/>
           <p:nvPr/>
         </p:nvSpPr>
@@ -10980,7 +11019,7 @@
       </p:sp>
       <p:sp>
         <p:nvSpPr>
-          <p:cNvPr id="57" name="Text 54"/>
+          <p:cNvPr id="58" name="Text 55"/>
           <p:cNvSpPr/>
           <p:nvPr/>
         </p:nvSpPr>
@@ -11019,7 +11058,7 @@
       </p:sp>
       <p:sp>
         <p:nvSpPr>
-          <p:cNvPr id="58" name="Text 55"/>
+          <p:cNvPr id="59" name="Text 56"/>
           <p:cNvSpPr/>
           <p:nvPr/>
         </p:nvSpPr>

</xml_diff>

<commit_message>
model+deck: OT SOP '28H2 + 시나리오 필요EBITDA% 열 + AMPC 밸류 기여 별도표시
- OT SOP를 '28 하반기로 조정: ot_util_28 2028 .35→.18(반년)
  → run-rate $554mm·멀티플 불변, EV $5.0→$4.8bn, PV(AMPC) $3.8→$3.6bn
- S4 조달 시나리오 표에 '필요 EBITDA%(→13x)' 열 추가(민감도):
  10.7/9.8/9.8/9.1/8.7% (현 9% 대비 — 최대결합만 충족)
- S2에 AMPC 밸류 분해 박스 추가: DCF EV $4.8bn = ex-AMPC $1.2bn
  + AMPC PV $3.6bn(75%, 2033 소멸) → 멀티플엔 ex-AMPC만
- S2 OT SOP '28 하반기 표기, EV KPI 4.8
- CLAUDE.md·펀딩구조_v2 검산표(AMPC 분해)·역산표 동기화

Co-Authored-By: Claude Opus 4.8 <noreply@anthropic.com>
Claude-Session: https://claude.ai/code/session_019MWAFoC5mEReHSPt6vQXor
</commit_message>
<xml_diff>
--- a/sk_valuation_project/output/SK_Funding_v3_editable.pptx
+++ b/sk_valuation_project/output/SK_Funding_v3_editable.pptx
@@ -2927,7 +2927,7 @@
                           <a:ea typeface="IBM Plex Mono" pitchFamily="34" charset="-122"/>
                           <a:cs typeface="IBM Plex Mono" pitchFamily="34" charset="-120"/>
                         </a:rPr>
-                        <a:t>BA 완전자회사 100%</a:t>
+                        <a:t>BA 100% · SOP ′28 하반기</a:t>
                       </a:r>
                       <a:endParaRPr lang="en-US" sz="800" dirty="0">
                         <a:latin typeface="IBM Plex Mono" charset="0"/>
@@ -4044,7 +4044,7 @@
         </p:nvSpPr>
         <p:spPr>
           <a:xfrm>
-            <a:off x="6007608" y="3730752"/>
+            <a:off x="6007608" y="3712464"/>
             <a:ext cx="228600" cy="274320"/>
           </a:xfrm>
           <a:prstGeom prst="rect">
@@ -4083,7 +4083,7 @@
         </p:nvSpPr>
         <p:spPr>
           <a:xfrm>
-            <a:off x="6263640" y="3730752"/>
+            <a:off x="6263640" y="3712464"/>
             <a:ext cx="3858768" cy="365760"/>
           </a:xfrm>
           <a:prstGeom prst="rect">
@@ -4122,7 +4122,7 @@
         </p:nvSpPr>
         <p:spPr>
           <a:xfrm>
-            <a:off x="6007608" y="4133088"/>
+            <a:off x="6007608" y="4096512"/>
             <a:ext cx="228600" cy="274320"/>
           </a:xfrm>
           <a:prstGeom prst="rect">
@@ -4161,7 +4161,7 @@
         </p:nvSpPr>
         <p:spPr>
           <a:xfrm>
-            <a:off x="6263640" y="4133088"/>
+            <a:off x="6263640" y="4096512"/>
             <a:ext cx="3858768" cy="365760"/>
           </a:xfrm>
           <a:prstGeom prst="rect">
@@ -4194,77 +4194,74 @@
       </p:sp>
       <p:sp>
         <p:nvSpPr>
-          <p:cNvPr id="26" name="Text 20"/>
-          <p:cNvSpPr/>
-          <p:nvPr/>
-        </p:nvSpPr>
-        <p:spPr>
-          <a:xfrm>
-            <a:off x="6007608" y="4535424"/>
-            <a:ext cx="228600" cy="274320"/>
-          </a:xfrm>
-          <a:prstGeom prst="rect">
-            <a:avLst/>
-          </a:prstGeom>
-          <a:noFill/>
-          <a:ln/>
-        </p:spPr>
-        <p:txBody>
-          <a:bodyPr wrap="square" lIns="0" tIns="0" rIns="0" bIns="0" rtlCol="0" anchor="t"/>
+          <p:cNvPr id="26" name="Shape 20"/>
+          <p:cNvSpPr/>
+          <p:nvPr/>
+        </p:nvSpPr>
+        <p:spPr>
+          <a:xfrm>
+            <a:off x="6007608" y="4526280"/>
+            <a:ext cx="4114800" cy="914400"/>
+          </a:xfrm>
+          <a:prstGeom prst="roundRect">
+            <a:avLst>
+              <a:gd name="adj" fmla="val 6000"/>
+            </a:avLst>
+          </a:prstGeom>
+          <a:solidFill>
+            <a:srgbClr val="211C18"/>
+          </a:solidFill>
+          <a:ln/>
+        </p:spPr>
+      </p:sp>
+      <p:sp>
+        <p:nvSpPr>
+          <p:cNvPr id="27" name="Text 21"/>
+          <p:cNvSpPr/>
+          <p:nvPr/>
+        </p:nvSpPr>
+        <p:spPr>
+          <a:xfrm>
+            <a:off x="6208776" y="4617720"/>
+            <a:ext cx="3749040" cy="219456"/>
+          </a:xfrm>
+          <a:prstGeom prst="rect">
+            <a:avLst/>
+          </a:prstGeom>
+          <a:noFill/>
+          <a:ln/>
+        </p:spPr>
+        <p:txBody>
+          <a:bodyPr wrap="square" lIns="0" tIns="0" rIns="0" bIns="0" rtlCol="0" anchor="ctr"/>
           <a:lstStyle/>
           <a:p>
             <a:pPr indent="0" marL="0">
               <a:buNone/>
             </a:pPr>
             <a:r>
-              <a:rPr lang="en-US" sz="1100" dirty="0">
-                <a:solidFill>
-                  <a:srgbClr val="C1121F"/>
+              <a:rPr lang="en-US" sz="1050" b="1" dirty="0">
+                <a:solidFill>
+                  <a:srgbClr val="FFFFFF"/>
                 </a:solidFill>
                 <a:latin typeface="IBM Plex Sans KR" pitchFamily="34" charset="0"/>
                 <a:ea typeface="IBM Plex Sans KR" pitchFamily="34" charset="-122"/>
                 <a:cs typeface="IBM Plex Sans KR" pitchFamily="34" charset="-120"/>
               </a:rPr>
-              <a:t>●</a:t>
-            </a:r>
-            <a:endParaRPr lang="en-US" sz="1100" dirty="0"/>
-          </a:p>
-        </p:txBody>
-      </p:sp>
-      <p:sp>
-        <p:nvSpPr>
-          <p:cNvPr id="27" name="Text 21"/>
-          <p:cNvSpPr/>
-          <p:nvPr/>
-        </p:nvSpPr>
-        <p:spPr>
-          <a:xfrm>
-            <a:off x="6263640" y="4535424"/>
-            <a:ext cx="3858768" cy="365760"/>
-          </a:xfrm>
-          <a:prstGeom prst="rect">
-            <a:avLst/>
-          </a:prstGeom>
-          <a:noFill/>
-          <a:ln/>
-        </p:spPr>
-        <p:txBody>
-          <a:bodyPr wrap="square" lIns="0" tIns="0" rIns="0" bIns="0" rtlCol="0" anchor="t"/>
-          <a:lstStyle/>
-          <a:p>
+              <a:t>밸류에이션 분해 — AMPC(45X) 기여</a:t>
+            </a:r>
             <a:pPr indent="0" marL="0">
               <a:buNone/>
             </a:pPr>
             <a:r>
               <a:rPr lang="en-US" sz="1050" dirty="0">
                 <a:solidFill>
-                  <a:srgbClr val="1B1714"/>
+                  <a:srgbClr val="9A847C"/>
                 </a:solidFill>
                 <a:latin typeface="IBM Plex Sans KR" pitchFamily="34" charset="0"/>
                 <a:ea typeface="IBM Plex Sans KR" pitchFamily="34" charset="-122"/>
                 <a:cs typeface="IBM Plex Sans KR" pitchFamily="34" charset="-120"/>
               </a:rPr>
-              <a:t>DCF EV ≈ $5.0bn · WACC 10.5% / 영구성장(TGR) 2.0% / Ke 13%</a:t>
+              <a:t>   한시보조금·2033 소멸</a:t>
             </a:r>
             <a:endParaRPr lang="en-US" sz="1050" dirty="0"/>
           </a:p>
@@ -4272,85 +4269,178 @@
       </p:sp>
       <p:sp>
         <p:nvSpPr>
-          <p:cNvPr id="28" name="Text 22"/>
-          <p:cNvSpPr/>
-          <p:nvPr/>
-        </p:nvSpPr>
-        <p:spPr>
-          <a:xfrm>
-            <a:off x="6007608" y="4937760"/>
-            <a:ext cx="228600" cy="274320"/>
-          </a:xfrm>
-          <a:prstGeom prst="rect">
-            <a:avLst/>
-          </a:prstGeom>
-          <a:noFill/>
-          <a:ln/>
-        </p:spPr>
-        <p:txBody>
-          <a:bodyPr wrap="square" lIns="0" tIns="0" rIns="0" bIns="0" rtlCol="0" anchor="t"/>
+          <p:cNvPr id="28" name="Shape 22"/>
+          <p:cNvSpPr/>
+          <p:nvPr/>
+        </p:nvSpPr>
+        <p:spPr>
+          <a:xfrm>
+            <a:off x="6208776" y="4928616"/>
+            <a:ext cx="928116" cy="219456"/>
+          </a:xfrm>
+          <a:prstGeom prst="rect">
+            <a:avLst/>
+          </a:prstGeom>
+          <a:solidFill>
+            <a:srgbClr val="1E7A4D"/>
+          </a:solidFill>
+          <a:ln/>
+        </p:spPr>
+      </p:sp>
+      <p:sp>
+        <p:nvSpPr>
+          <p:cNvPr id="29" name="Shape 23"/>
+          <p:cNvSpPr/>
+          <p:nvPr/>
+        </p:nvSpPr>
+        <p:spPr>
+          <a:xfrm>
+            <a:off x="7136892" y="4928616"/>
+            <a:ext cx="2784348" cy="219456"/>
+          </a:xfrm>
+          <a:prstGeom prst="rect">
+            <a:avLst/>
+          </a:prstGeom>
+          <a:solidFill>
+            <a:srgbClr val="FF8E84"/>
+          </a:solidFill>
+          <a:ln/>
+        </p:spPr>
+      </p:sp>
+      <p:sp>
+        <p:nvSpPr>
+          <p:cNvPr id="30" name="Text 24"/>
+          <p:cNvSpPr/>
+          <p:nvPr/>
+        </p:nvSpPr>
+        <p:spPr>
+          <a:xfrm>
+            <a:off x="6208776" y="4928616"/>
+            <a:ext cx="928116" cy="219456"/>
+          </a:xfrm>
+          <a:prstGeom prst="rect">
+            <a:avLst/>
+          </a:prstGeom>
+          <a:noFill/>
+          <a:ln/>
+        </p:spPr>
+        <p:txBody>
+          <a:bodyPr wrap="square" lIns="0" tIns="0" rIns="0" bIns="0" rtlCol="0" anchor="ctr"/>
+          <a:lstStyle/>
+          <a:p>
+            <a:pPr algn="ctr" indent="0" marL="0">
+              <a:buNone/>
+            </a:pPr>
+            <a:r>
+              <a:rPr lang="en-US" sz="750" b="1" dirty="0">
+                <a:solidFill>
+                  <a:srgbClr val="FFFFFF"/>
+                </a:solidFill>
+                <a:latin typeface="IBM Plex Mono" pitchFamily="34" charset="0"/>
+                <a:ea typeface="IBM Plex Mono" pitchFamily="34" charset="-122"/>
+                <a:cs typeface="IBM Plex Mono" pitchFamily="34" charset="-120"/>
+              </a:rPr>
+              <a:t>ex-AMPC $1.2bn</a:t>
+            </a:r>
+            <a:endParaRPr lang="en-US" sz="750" dirty="0"/>
+          </a:p>
+        </p:txBody>
+      </p:sp>
+      <p:sp>
+        <p:nvSpPr>
+          <p:cNvPr id="31" name="Text 25"/>
+          <p:cNvSpPr/>
+          <p:nvPr/>
+        </p:nvSpPr>
+        <p:spPr>
+          <a:xfrm>
+            <a:off x="7136892" y="4928616"/>
+            <a:ext cx="2784348" cy="219456"/>
+          </a:xfrm>
+          <a:prstGeom prst="rect">
+            <a:avLst/>
+          </a:prstGeom>
+          <a:noFill/>
+          <a:ln/>
+        </p:spPr>
+        <p:txBody>
+          <a:bodyPr wrap="square" lIns="0" tIns="0" rIns="0" bIns="0" rtlCol="0" anchor="ctr"/>
+          <a:lstStyle/>
+          <a:p>
+            <a:pPr algn="ctr" indent="0" marL="0">
+              <a:buNone/>
+            </a:pPr>
+            <a:r>
+              <a:rPr lang="en-US" sz="800" b="1" dirty="0">
+                <a:solidFill>
+                  <a:srgbClr val="211C18"/>
+                </a:solidFill>
+                <a:latin typeface="IBM Plex Mono" pitchFamily="34" charset="0"/>
+                <a:ea typeface="IBM Plex Mono" pitchFamily="34" charset="-122"/>
+                <a:cs typeface="IBM Plex Mono" pitchFamily="34" charset="-120"/>
+              </a:rPr>
+              <a:t>AMPC PV $3.6bn (75%)</a:t>
+            </a:r>
+            <a:endParaRPr lang="en-US" sz="800" dirty="0"/>
+          </a:p>
+        </p:txBody>
+      </p:sp>
+      <p:sp>
+        <p:nvSpPr>
+          <p:cNvPr id="32" name="Text 26"/>
+          <p:cNvSpPr/>
+          <p:nvPr/>
+        </p:nvSpPr>
+        <p:spPr>
+          <a:xfrm>
+            <a:off x="6208776" y="5202936"/>
+            <a:ext cx="3749040" cy="201168"/>
+          </a:xfrm>
+          <a:prstGeom prst="rect">
+            <a:avLst/>
+          </a:prstGeom>
+          <a:noFill/>
+          <a:ln/>
+        </p:spPr>
+        <p:txBody>
+          <a:bodyPr wrap="square" lIns="0" tIns="0" rIns="0" bIns="0" rtlCol="0" anchor="ctr"/>
           <a:lstStyle/>
           <a:p>
             <a:pPr indent="0" marL="0">
               <a:buNone/>
             </a:pPr>
             <a:r>
-              <a:rPr lang="en-US" sz="1100" dirty="0">
-                <a:solidFill>
-                  <a:srgbClr val="C1121F"/>
+              <a:rPr lang="en-US" sz="800" b="1" dirty="0">
+                <a:solidFill>
+                  <a:srgbClr val="FFFFFF"/>
                 </a:solidFill>
                 <a:latin typeface="IBM Plex Sans KR" pitchFamily="34" charset="0"/>
                 <a:ea typeface="IBM Plex Sans KR" pitchFamily="34" charset="-122"/>
                 <a:cs typeface="IBM Plex Sans KR" pitchFamily="34" charset="-120"/>
               </a:rPr>
-              <a:t>●</a:t>
-            </a:r>
-            <a:endParaRPr lang="en-US" sz="1100" dirty="0"/>
-          </a:p>
-        </p:txBody>
-      </p:sp>
-      <p:sp>
-        <p:nvSpPr>
-          <p:cNvPr id="29" name="Text 23"/>
-          <p:cNvSpPr/>
-          <p:nvPr/>
-        </p:nvSpPr>
-        <p:spPr>
-          <a:xfrm>
-            <a:off x="6263640" y="4937760"/>
-            <a:ext cx="3858768" cy="365760"/>
-          </a:xfrm>
-          <a:prstGeom prst="rect">
-            <a:avLst/>
-          </a:prstGeom>
-          <a:noFill/>
-          <a:ln/>
-        </p:spPr>
-        <p:txBody>
-          <a:bodyPr wrap="square" lIns="0" tIns="0" rIns="0" bIns="0" rtlCol="0" anchor="t"/>
-          <a:lstStyle/>
-          <a:p>
+              <a:t>DCF EV $4.8bn</a:t>
+            </a:r>
             <a:pPr indent="0" marL="0">
               <a:buNone/>
             </a:pPr>
             <a:r>
-              <a:rPr lang="en-US" sz="1050" dirty="0">
-                <a:solidFill>
-                  <a:srgbClr val="1B1714"/>
+              <a:rPr lang="en-US" sz="800" dirty="0">
+                <a:solidFill>
+                  <a:srgbClr val="D8CFC2"/>
                 </a:solidFill>
                 <a:latin typeface="IBM Plex Sans KR" pitchFamily="34" charset="0"/>
                 <a:ea typeface="IBM Plex Sans KR" pitchFamily="34" charset="-122"/>
                 <a:cs typeface="IBM Plex Sans KR" pitchFamily="34" charset="-120"/>
               </a:rPr>
-              <a:t>NAV(SOTP) ≈ $5.0bn ★</a:t>
-            </a:r>
-            <a:endParaRPr lang="en-US" sz="1050" dirty="0"/>
-          </a:p>
-        </p:txBody>
-      </p:sp>
-      <p:sp>
-        <p:nvSpPr>
-          <p:cNvPr id="30" name="Shape 24"/>
+              <a:t> 의 75%가 한시 AMPC → 멀티플엔 ex-AMPC만. WACC 10.5%·TGR 2%·Ke 13%</a:t>
+            </a:r>
+            <a:endParaRPr lang="en-US" sz="800" dirty="0"/>
+          </a:p>
+        </p:txBody>
+      </p:sp>
+      <p:sp>
+        <p:nvSpPr>
+          <p:cNvPr id="33" name="Shape 27"/>
           <p:cNvSpPr/>
           <p:nvPr/>
         </p:nvSpPr>
@@ -4373,7 +4463,7 @@
       </p:sp>
       <p:sp>
         <p:nvSpPr>
-          <p:cNvPr id="31" name="Text 25"/>
+          <p:cNvPr id="34" name="Text 28"/>
           <p:cNvSpPr/>
           <p:nvPr/>
         </p:nvSpPr>
@@ -4412,7 +4502,7 @@
       </p:sp>
       <p:sp>
         <p:nvSpPr>
-          <p:cNvPr id="32" name="Text 26"/>
+          <p:cNvPr id="35" name="Text 29"/>
           <p:cNvSpPr/>
           <p:nvPr/>
         </p:nvSpPr>
@@ -4465,7 +4555,7 @@
       </p:sp>
       <p:sp>
         <p:nvSpPr>
-          <p:cNvPr id="33" name="Shape 27"/>
+          <p:cNvPr id="36" name="Shape 30"/>
           <p:cNvSpPr/>
           <p:nvPr/>
         </p:nvSpPr>
@@ -4488,7 +4578,7 @@
       </p:sp>
       <p:sp>
         <p:nvSpPr>
-          <p:cNvPr id="34" name="Text 28"/>
+          <p:cNvPr id="37" name="Text 31"/>
           <p:cNvSpPr/>
           <p:nvPr/>
         </p:nvSpPr>
@@ -4527,7 +4617,7 @@
       </p:sp>
       <p:sp>
         <p:nvSpPr>
-          <p:cNvPr id="35" name="Text 29"/>
+          <p:cNvPr id="38" name="Text 32"/>
           <p:cNvSpPr/>
           <p:nvPr/>
         </p:nvSpPr>
@@ -4580,7 +4670,7 @@
       </p:sp>
       <p:sp>
         <p:nvSpPr>
-          <p:cNvPr id="36" name="Shape 30"/>
+          <p:cNvPr id="39" name="Shape 33"/>
           <p:cNvSpPr/>
           <p:nvPr/>
         </p:nvSpPr>
@@ -4603,7 +4693,7 @@
       </p:sp>
       <p:sp>
         <p:nvSpPr>
-          <p:cNvPr id="37" name="Text 31"/>
+          <p:cNvPr id="40" name="Text 34"/>
           <p:cNvSpPr/>
           <p:nvPr/>
         </p:nvSpPr>
@@ -4642,7 +4732,7 @@
       </p:sp>
       <p:sp>
         <p:nvSpPr>
-          <p:cNvPr id="38" name="Text 32"/>
+          <p:cNvPr id="41" name="Text 35"/>
           <p:cNvSpPr/>
           <p:nvPr/>
         </p:nvSpPr>
@@ -4695,7 +4785,7 @@
       </p:sp>
       <p:sp>
         <p:nvSpPr>
-          <p:cNvPr id="39" name="Shape 33"/>
+          <p:cNvPr id="42" name="Shape 36"/>
           <p:cNvSpPr/>
           <p:nvPr/>
         </p:nvSpPr>
@@ -4718,7 +4808,7 @@
       </p:sp>
       <p:sp>
         <p:nvSpPr>
-          <p:cNvPr id="40" name="Text 34"/>
+          <p:cNvPr id="43" name="Text 37"/>
           <p:cNvSpPr/>
           <p:nvPr/>
         </p:nvSpPr>
@@ -4757,7 +4847,7 @@
       </p:sp>
       <p:sp>
         <p:nvSpPr>
-          <p:cNvPr id="41" name="Text 35"/>
+          <p:cNvPr id="44" name="Text 38"/>
           <p:cNvSpPr/>
           <p:nvPr/>
         </p:nvSpPr>
@@ -4788,7 +4878,7 @@
                 <a:ea typeface="Space Grotesk" pitchFamily="34" charset="-122"/>
                 <a:cs typeface="Space Grotesk" pitchFamily="34" charset="-120"/>
               </a:rPr>
-              <a:t>5.0</a:t>
+              <a:t>4.8</a:t>
             </a:r>
             <a:pPr indent="0" marL="0">
               <a:buNone/>
@@ -4810,7 +4900,7 @@
       </p:sp>
       <p:sp>
         <p:nvSpPr>
-          <p:cNvPr id="42" name="Shape 36"/>
+          <p:cNvPr id="45" name="Shape 39"/>
           <p:cNvSpPr/>
           <p:nvPr/>
         </p:nvSpPr>
@@ -4833,7 +4923,7 @@
       </p:sp>
       <p:sp>
         <p:nvSpPr>
-          <p:cNvPr id="43" name="Text 37"/>
+          <p:cNvPr id="46" name="Text 40"/>
           <p:cNvSpPr/>
           <p:nvPr/>
         </p:nvSpPr>
@@ -4872,7 +4962,7 @@
       </p:sp>
       <p:sp>
         <p:nvSpPr>
-          <p:cNvPr id="44" name="Text 38"/>
+          <p:cNvPr id="47" name="Text 41"/>
           <p:cNvSpPr/>
           <p:nvPr/>
         </p:nvSpPr>
@@ -8149,14 +8239,14 @@
             <a:tbl>
               <a:tblPr/>
               <a:tblGrid>
-                <a:gridCol w="2148840"/>
-                <a:gridCol w="658368"/>
-                <a:gridCol w="658368"/>
-                <a:gridCol w="868680"/>
-                <a:gridCol w="777240"/>
-                <a:gridCol w="786384"/>
+                <a:gridCol w="2103120"/>
+                <a:gridCol w="640080"/>
+                <a:gridCol w="640080"/>
+                <a:gridCol w="822960"/>
+                <a:gridCol w="795528"/>
+                <a:gridCol w="896112"/>
               </a:tblGrid>
-              <a:tr h="292608">
+              <a:tr h="365760">
                 <a:tc>
                   <a:txBody>
                     <a:bodyPr/>
@@ -8454,6 +8544,27 @@
                         <a:cs typeface="IBM Plex Sans KR" charset="0"/>
                       </a:endParaRPr>
                     </a:p>
+                    <a:p>
+                      <a:pPr algn="ctr" indent="0" marL="0">
+                        <a:buNone/>
+                      </a:pPr>
+                      <a:r>
+                        <a:rPr lang="en-US" sz="900" b="1" dirty="0">
+                          <a:solidFill>
+                            <a:srgbClr val="FFFFFF"/>
+                          </a:solidFill>
+                          <a:latin typeface="IBM Plex Sans KR" pitchFamily="34" charset="0"/>
+                          <a:ea typeface="IBM Plex Sans KR" pitchFamily="34" charset="-122"/>
+                          <a:cs typeface="IBM Plex Sans KR" pitchFamily="34" charset="-120"/>
+                        </a:rPr>
+                        <a:t>(9%)</a:t>
+                      </a:r>
+                      <a:endParaRPr lang="en-US" sz="900" dirty="0">
+                        <a:latin typeface="IBM Plex Sans KR" charset="0"/>
+                        <a:ea typeface="IBM Plex Sans KR" charset="0"/>
+                        <a:cs typeface="IBM Plex Sans KR" charset="0"/>
+                      </a:endParaRPr>
+                    </a:p>
                   </a:txBody>
                   <a:tcPr marL="63500" marR="63500" marT="25400" marB="25400" anchor="ctr">
                     <a:lnL w="6350" cap="flat" cmpd="sng" algn="ctr">
@@ -8514,7 +8625,28 @@
                           <a:ea typeface="IBM Plex Sans KR" pitchFamily="34" charset="-122"/>
                           <a:cs typeface="IBM Plex Sans KR" pitchFamily="34" charset="-120"/>
                         </a:rPr>
-                        <a:t>peer초과</a:t>
+                        <a:t>필요EBITDA%</a:t>
+                      </a:r>
+                      <a:endParaRPr lang="en-US" sz="900" dirty="0">
+                        <a:latin typeface="IBM Plex Sans KR" charset="0"/>
+                        <a:ea typeface="IBM Plex Sans KR" charset="0"/>
+                        <a:cs typeface="IBM Plex Sans KR" charset="0"/>
+                      </a:endParaRPr>
+                    </a:p>
+                    <a:p>
+                      <a:pPr algn="ctr" indent="0" marL="0">
+                        <a:buNone/>
+                      </a:pPr>
+                      <a:r>
+                        <a:rPr lang="en-US" sz="900" b="1" dirty="0">
+                          <a:solidFill>
+                            <a:srgbClr val="FFFFFF"/>
+                          </a:solidFill>
+                          <a:latin typeface="IBM Plex Sans KR" pitchFamily="34" charset="0"/>
+                          <a:ea typeface="IBM Plex Sans KR" pitchFamily="34" charset="-122"/>
+                          <a:cs typeface="IBM Plex Sans KR" pitchFamily="34" charset="-120"/>
+                        </a:rPr>
+                        <a:t>(→13x)</a:t>
                       </a:r>
                       <a:endParaRPr lang="en-US" sz="900" dirty="0">
                         <a:latin typeface="IBM Plex Sans KR" charset="0"/>
@@ -8566,7 +8698,7 @@
                   </a:tcPr>
                 </a:tc>
               </a:tr>
-              <a:tr h="429768">
+              <a:tr h="402336">
                 <a:tc>
                   <a:txBody>
                     <a:bodyPr/>
@@ -8924,7 +9056,7 @@
                           <a:ea typeface="IBM Plex Mono" pitchFamily="34" charset="-122"/>
                           <a:cs typeface="IBM Plex Mono" pitchFamily="34" charset="-120"/>
                         </a:rPr>
-                        <a:t>+2.4x</a:t>
+                        <a:t>10.7%</a:t>
                       </a:r>
                       <a:endParaRPr lang="en-US" sz="800" dirty="0">
                         <a:latin typeface="IBM Plex Mono" charset="0"/>
@@ -8976,7 +9108,7 @@
                   </a:tcPr>
                 </a:tc>
               </a:tr>
-              <a:tr h="429768">
+              <a:tr h="402336">
                 <a:tc>
                   <a:txBody>
                     <a:bodyPr/>
@@ -9328,13 +9460,13 @@
                       <a:r>
                         <a:rPr lang="en-US" sz="800" b="1" dirty="0">
                           <a:solidFill>
-                            <a:srgbClr val="6F6960"/>
+                            <a:srgbClr val="C1121F"/>
                           </a:solidFill>
                           <a:latin typeface="IBM Plex Mono" pitchFamily="34" charset="0"/>
                           <a:ea typeface="IBM Plex Mono" pitchFamily="34" charset="-122"/>
                           <a:cs typeface="IBM Plex Mono" pitchFamily="34" charset="-120"/>
                         </a:rPr>
-                        <a:t>+1.1x</a:t>
+                        <a:t>9.8%</a:t>
                       </a:r>
                       <a:endParaRPr lang="en-US" sz="800" dirty="0">
                         <a:latin typeface="IBM Plex Mono" charset="0"/>
@@ -9386,7 +9518,7 @@
                   </a:tcPr>
                 </a:tc>
               </a:tr>
-              <a:tr h="429768">
+              <a:tr h="402336">
                 <a:tc>
                   <a:txBody>
                     <a:bodyPr/>
@@ -9738,13 +9870,13 @@
                       <a:r>
                         <a:rPr lang="en-US" sz="800" b="1" dirty="0">
                           <a:solidFill>
-                            <a:srgbClr val="6F6960"/>
+                            <a:srgbClr val="C1121F"/>
                           </a:solidFill>
                           <a:latin typeface="IBM Plex Mono" pitchFamily="34" charset="0"/>
                           <a:ea typeface="IBM Plex Mono" pitchFamily="34" charset="-122"/>
                           <a:cs typeface="IBM Plex Mono" pitchFamily="34" charset="-120"/>
                         </a:rPr>
-                        <a:t>+1.1x</a:t>
+                        <a:t>9.8%</a:t>
                       </a:r>
                       <a:endParaRPr lang="en-US" sz="800" dirty="0">
                         <a:latin typeface="IBM Plex Mono" charset="0"/>
@@ -9796,7 +9928,7 @@
                   </a:tcPr>
                 </a:tc>
               </a:tr>
-              <a:tr h="429768">
+              <a:tr h="402336">
                 <a:tc>
                   <a:txBody>
                     <a:bodyPr/>
@@ -10148,13 +10280,13 @@
                       <a:r>
                         <a:rPr lang="en-US" sz="800" b="1" dirty="0">
                           <a:solidFill>
-                            <a:srgbClr val="6F6960"/>
+                            <a:srgbClr val="C1121F"/>
                           </a:solidFill>
                           <a:latin typeface="IBM Plex Mono" pitchFamily="34" charset="0"/>
                           <a:ea typeface="IBM Plex Mono" pitchFamily="34" charset="-122"/>
                           <a:cs typeface="IBM Plex Mono" pitchFamily="34" charset="-120"/>
                         </a:rPr>
-                        <a:t>+0.1x</a:t>
+                        <a:t>9.1%</a:t>
                       </a:r>
                       <a:endParaRPr lang="en-US" sz="800" dirty="0">
                         <a:latin typeface="IBM Plex Mono" charset="0"/>
@@ -10206,7 +10338,7 @@
                   </a:tcPr>
                 </a:tc>
               </a:tr>
-              <a:tr h="429768">
+              <a:tr h="402336">
                 <a:tc>
                   <a:txBody>
                     <a:bodyPr/>
@@ -10564,7 +10696,7 @@
                           <a:ea typeface="IBM Plex Mono" pitchFamily="34" charset="-122"/>
                           <a:cs typeface="IBM Plex Mono" pitchFamily="34" charset="-120"/>
                         </a:rPr>
-                        <a:t>−0.4x</a:t>
+                        <a:t>8.7%</a:t>
                       </a:r>
                       <a:endParaRPr lang="en-US" sz="800" dirty="0">
                         <a:latin typeface="IBM Plex Mono" charset="0"/>
@@ -10628,6 +10760,45 @@
         </p:nvSpPr>
         <p:spPr>
           <a:xfrm>
+            <a:off x="4133088" y="4279392"/>
+            <a:ext cx="5989320" cy="182880"/>
+          </a:xfrm>
+          <a:prstGeom prst="rect">
+            <a:avLst/>
+          </a:prstGeom>
+          <a:noFill/>
+          <a:ln/>
+        </p:spPr>
+        <p:txBody>
+          <a:bodyPr wrap="square" lIns="0" tIns="0" rIns="0" bIns="0" rtlCol="0" anchor="ctr"/>
+          <a:lstStyle/>
+          <a:p>
+            <a:pPr indent="0" marL="0">
+              <a:buNone/>
+            </a:pPr>
+            <a:r>
+              <a:rPr lang="en-US" sz="750" i="1" dirty="0">
+                <a:solidFill>
+                  <a:srgbClr val="9A847C"/>
+                </a:solidFill>
+                <a:latin typeface="IBM Plex Sans KR" pitchFamily="34" charset="0"/>
+                <a:ea typeface="IBM Plex Sans KR" pitchFamily="34" charset="-122"/>
+                <a:cs typeface="IBM Plex Sans KR" pitchFamily="34" charset="-120"/>
+              </a:rPr>
+              <a:t>필요EBITDA% = 현 9%에서 딜을 peer 상단(13x)에 맞추는 데 필요한 ex-AMPC 마진 · 8.7% ≤ 현 9%면 이미 충족</a:t>
+            </a:r>
+            <a:endParaRPr lang="en-US" sz="750" dirty="0"/>
+          </a:p>
+        </p:txBody>
+      </p:sp>
+      <p:sp>
+        <p:nvSpPr>
+          <p:cNvPr id="41" name="Text 38"/>
+          <p:cNvSpPr/>
+          <p:nvPr/>
+        </p:nvSpPr>
+        <p:spPr>
+          <a:xfrm>
             <a:off x="4133088" y="4480560"/>
             <a:ext cx="5989320" cy="219456"/>
           </a:xfrm>
@@ -10661,7 +10832,7 @@
       </p:sp>
       <p:sp>
         <p:nvSpPr>
-          <p:cNvPr id="41" name="Shape 38"/>
+          <p:cNvPr id="42" name="Shape 39"/>
           <p:cNvSpPr/>
           <p:nvPr/>
         </p:nvSpPr>
@@ -10684,7 +10855,7 @@
       </p:sp>
       <p:sp>
         <p:nvSpPr>
-          <p:cNvPr id="42" name="Shape 39"/>
+          <p:cNvPr id="43" name="Shape 40"/>
           <p:cNvSpPr/>
           <p:nvPr/>
         </p:nvSpPr>
@@ -10709,7 +10880,7 @@
       </p:sp>
       <p:sp>
         <p:nvSpPr>
-          <p:cNvPr id="43" name="Text 40"/>
+          <p:cNvPr id="44" name="Text 41"/>
           <p:cNvSpPr/>
           <p:nvPr/>
         </p:nvSpPr>
@@ -10748,7 +10919,7 @@
       </p:sp>
       <p:sp>
         <p:nvSpPr>
-          <p:cNvPr id="44" name="Shape 41"/>
+          <p:cNvPr id="45" name="Shape 42"/>
           <p:cNvSpPr/>
           <p:nvPr/>
         </p:nvSpPr>
@@ -10773,7 +10944,7 @@
       </p:sp>
       <p:sp>
         <p:nvSpPr>
-          <p:cNvPr id="45" name="Text 42"/>
+          <p:cNvPr id="46" name="Text 43"/>
           <p:cNvSpPr/>
           <p:nvPr/>
         </p:nvSpPr>
@@ -10812,7 +10983,7 @@
       </p:sp>
       <p:sp>
         <p:nvSpPr>
-          <p:cNvPr id="46" name="Shape 43"/>
+          <p:cNvPr id="47" name="Shape 44"/>
           <p:cNvSpPr/>
           <p:nvPr/>
         </p:nvSpPr>
@@ -10832,7 +11003,7 @@
       </p:sp>
       <p:sp>
         <p:nvSpPr>
-          <p:cNvPr id="47" name="Text 44"/>
+          <p:cNvPr id="48" name="Text 45"/>
           <p:cNvSpPr/>
           <p:nvPr/>
         </p:nvSpPr>
@@ -10871,7 +11042,7 @@
       </p:sp>
       <p:sp>
         <p:nvSpPr>
-          <p:cNvPr id="48" name="Text 45"/>
+          <p:cNvPr id="49" name="Text 46"/>
           <p:cNvSpPr/>
           <p:nvPr/>
         </p:nvSpPr>
@@ -10910,7 +11081,7 @@
       </p:sp>
       <p:sp>
         <p:nvSpPr>
-          <p:cNvPr id="49" name="Shape 46"/>
+          <p:cNvPr id="50" name="Shape 47"/>
           <p:cNvSpPr/>
           <p:nvPr/>
         </p:nvSpPr>
@@ -10930,7 +11101,7 @@
       </p:sp>
       <p:sp>
         <p:nvSpPr>
-          <p:cNvPr id="50" name="Text 47"/>
+          <p:cNvPr id="51" name="Text 48"/>
           <p:cNvSpPr/>
           <p:nvPr/>
         </p:nvSpPr>
@@ -10969,7 +11140,7 @@
       </p:sp>
       <p:sp>
         <p:nvSpPr>
-          <p:cNvPr id="51" name="Text 48"/>
+          <p:cNvPr id="52" name="Text 49"/>
           <p:cNvSpPr/>
           <p:nvPr/>
         </p:nvSpPr>
@@ -11008,7 +11179,7 @@
       </p:sp>
       <p:sp>
         <p:nvSpPr>
-          <p:cNvPr id="52" name="Shape 49"/>
+          <p:cNvPr id="53" name="Shape 50"/>
           <p:cNvSpPr/>
           <p:nvPr/>
         </p:nvSpPr>
@@ -11028,7 +11199,7 @@
       </p:sp>
       <p:sp>
         <p:nvSpPr>
-          <p:cNvPr id="53" name="Text 50"/>
+          <p:cNvPr id="54" name="Text 51"/>
           <p:cNvSpPr/>
           <p:nvPr/>
         </p:nvSpPr>
@@ -11067,7 +11238,7 @@
       </p:sp>
       <p:sp>
         <p:nvSpPr>
-          <p:cNvPr id="54" name="Text 51"/>
+          <p:cNvPr id="55" name="Text 52"/>
           <p:cNvSpPr/>
           <p:nvPr/>
         </p:nvSpPr>
@@ -11106,7 +11277,7 @@
       </p:sp>
       <p:sp>
         <p:nvSpPr>
-          <p:cNvPr id="55" name="Shape 52"/>
+          <p:cNvPr id="56" name="Shape 53"/>
           <p:cNvSpPr/>
           <p:nvPr/>
         </p:nvSpPr>
@@ -11126,7 +11297,7 @@
       </p:sp>
       <p:sp>
         <p:nvSpPr>
-          <p:cNvPr id="56" name="Text 53"/>
+          <p:cNvPr id="57" name="Text 54"/>
           <p:cNvSpPr/>
           <p:nvPr/>
         </p:nvSpPr>
@@ -11165,7 +11336,7 @@
       </p:sp>
       <p:sp>
         <p:nvSpPr>
-          <p:cNvPr id="57" name="Text 54"/>
+          <p:cNvPr id="58" name="Text 55"/>
           <p:cNvSpPr/>
           <p:nvPr/>
         </p:nvSpPr>
@@ -11204,7 +11375,7 @@
       </p:sp>
       <p:sp>
         <p:nvSpPr>
-          <p:cNvPr id="58" name="Text 55"/>
+          <p:cNvPr id="59" name="Text 56"/>
           <p:cNvSpPr/>
           <p:nvPr/>
         </p:nvSpPr>
@@ -11243,7 +11414,7 @@
       </p:sp>
       <p:sp>
         <p:nvSpPr>
-          <p:cNvPr id="59" name="Text 56"/>
+          <p:cNvPr id="60" name="Text 57"/>
           <p:cNvSpPr/>
           <p:nvPr/>
         </p:nvSpPr>
@@ -11282,7 +11453,7 @@
       </p:sp>
       <p:sp>
         <p:nvSpPr>
-          <p:cNvPr id="60" name="Text 57"/>
+          <p:cNvPr id="61" name="Text 58"/>
           <p:cNvSpPr/>
           <p:nvPr/>
         </p:nvSpPr>
@@ -11321,7 +11492,7 @@
       </p:sp>
       <p:sp>
         <p:nvSpPr>
-          <p:cNvPr id="61" name="Text 58"/>
+          <p:cNvPr id="62" name="Text 59"/>
           <p:cNvSpPr/>
           <p:nvPr/>
         </p:nvSpPr>
@@ -11360,7 +11531,7 @@
       </p:sp>
       <p:sp>
         <p:nvSpPr>
-          <p:cNvPr id="62" name="Text 59"/>
+          <p:cNvPr id="63" name="Text 60"/>
           <p:cNvSpPr/>
           <p:nvPr/>
         </p:nvSpPr>
@@ -11399,7 +11570,7 @@
       </p:sp>
       <p:sp>
         <p:nvSpPr>
-          <p:cNvPr id="63" name="Shape 60"/>
+          <p:cNvPr id="64" name="Shape 61"/>
           <p:cNvSpPr/>
           <p:nvPr/>
         </p:nvSpPr>
@@ -11421,7 +11592,7 @@
       </p:sp>
       <p:sp>
         <p:nvSpPr>
-          <p:cNvPr id="64" name="Text 61"/>
+          <p:cNvPr id="65" name="Text 62"/>
           <p:cNvSpPr/>
           <p:nvPr/>
         </p:nvSpPr>
@@ -11460,7 +11631,7 @@
       </p:sp>
       <p:sp>
         <p:nvSpPr>
-          <p:cNvPr id="65" name="Text 62"/>
+          <p:cNvPr id="66" name="Text 63"/>
           <p:cNvSpPr/>
           <p:nvPr/>
         </p:nvSpPr>
@@ -11664,7 +11835,7 @@
                 <a:ea typeface="IBM Plex Sans KR" pitchFamily="34" charset="-122"/>
                 <a:cs typeface="IBM Plex Sans KR" pitchFamily="34" charset="-120"/>
               </a:rPr>
-              <a:t> 기준 EV $5.0bn. 단 49% 희석은 지배력 약화(경영권·연결 이슈) 트레이드오프 — 협상 상한으로만. ★ 순차입금 $6.4bn·부채비중 60% 고정</a:t>
+              <a:t> 기준 EV $4.8bn(그중 AMPC PV $3.6bn·75%). OT SOP ′28 하반기. 단 49% 희석은 지배력 약화 트레이드오프 — 협상 상한으로만. ★ 순차입금 $6.4bn·부채비중 60% 고정</a:t>
             </a:r>
             <a:endParaRPr lang="en-US" sz="950" dirty="0"/>
           </a:p>
@@ -11672,7 +11843,7 @@
       </p:sp>
       <p:sp>
         <p:nvSpPr>
-          <p:cNvPr id="66" name="Shape 63"/>
+          <p:cNvPr id="67" name="Shape 64"/>
           <p:cNvSpPr/>
           <p:nvPr/>
         </p:nvSpPr>
@@ -11695,7 +11866,7 @@
       </p:sp>
       <p:sp>
         <p:nvSpPr>
-          <p:cNvPr id="67" name="Text 64"/>
+          <p:cNvPr id="68" name="Text 65"/>
           <p:cNvSpPr/>
           <p:nvPr/>
         </p:nvSpPr>
@@ -11734,7 +11905,7 @@
       </p:sp>
       <p:sp>
         <p:nvSpPr>
-          <p:cNvPr id="68" name="Text 65"/>
+          <p:cNvPr id="69" name="Text 66"/>
           <p:cNvSpPr/>
           <p:nvPr/>
         </p:nvSpPr>

</xml_diff>

<commit_message>
BA 개조 규모 11 → 18 GWh (개조비 $1.4bn 유지)
- BA 4라인 2.75×4 → 4.5×4 = 18.0 GWh, 개조 capex $0.4bn 그대로
- run-rate ex-AMPC EBITDA $438→$518mm (BA 205 + OT 313)
- EV $3.5→$4.4bn · AMPC PV $3.3bn(76%) · ex-AMPC EV $1.1bn · FCFE +$1.9bn
- 역산 필요 BASE 16.5x → 최대결합 13.5x (2029E 20.3~16.6x)
  최대결합(13.5x)만 정상화 peer(13~15x) 하단 진입, BASE는 초과
  필요EBITDA%(→13x) 11.4~9.3% · DCF 내재 8.5x(run)/10.5x(2029E)
- 덱 S2/S4/S5 전 수치·peer 밴드바·결론 갱신 · Multiples 자동 · 문서 동기화

Co-Authored-By: Claude Opus 4.8 <noreply@anthropic.com>
Claude-Session: https://claude.ai/code/session_019MWAFoC5mEReHSPt6vQXor
</commit_message>
<xml_diff>
--- a/sk_valuation_project/output/SK_Funding_v3_editable.pptx
+++ b/sk_valuation_project/output/SK_Funding_v3_editable.pptx
@@ -2182,7 +2182,7 @@
                           <a:ea typeface="IBM Plex Mono" pitchFamily="34" charset="-122"/>
                           <a:cs typeface="IBM Plex Mono" pitchFamily="34" charset="-120"/>
                         </a:rPr>
-                        <a:t>11.0 GWh / 85%</a:t>
+                        <a:t>18.0 GWh / 85%</a:t>
                       </a:r>
                       <a:endParaRPr lang="en-US" sz="950" dirty="0">
                         <a:latin typeface="IBM Plex Mono" charset="0"/>
@@ -2458,7 +2458,7 @@
                           <a:ea typeface="IBM Plex Mono" pitchFamily="34" charset="-122"/>
                           <a:cs typeface="IBM Plex Mono" pitchFamily="34" charset="-120"/>
                         </a:rPr>
-                        <a:t>~$1.4bn</a:t>
+                        <a:t>~$2.3bn</a:t>
                       </a:r>
                       <a:endParaRPr lang="en-US" sz="950" dirty="0">
                         <a:latin typeface="IBM Plex Mono" charset="0"/>
@@ -4413,7 +4413,7 @@
                 <a:ea typeface="IBM Plex Sans KR" pitchFamily="34" charset="-122"/>
                 <a:cs typeface="IBM Plex Sans KR" pitchFamily="34" charset="-120"/>
               </a:rPr>
-              <a:t>run-rate ex-AMPC EBITDA $438mm (BA 125 + OT 313, 9% 마진)</a:t>
+              <a:t>run-rate ex-AMPC EBITDA $518mm (BA 205 + OT 313, 9% 마진)</a:t>
             </a:r>
             <a:endParaRPr lang="en-US" sz="1050" dirty="0"/>
           </a:p>
@@ -4503,7 +4503,7 @@
         <p:spPr>
           <a:xfrm>
             <a:off x="6208776" y="4928616"/>
-            <a:ext cx="848563" cy="219456"/>
+            <a:ext cx="928116" cy="219456"/>
           </a:xfrm>
           <a:prstGeom prst="rect">
             <a:avLst/>
@@ -4522,8 +4522,8 @@
         </p:nvSpPr>
         <p:spPr>
           <a:xfrm>
-            <a:off x="7057339" y="4928616"/>
-            <a:ext cx="2863901" cy="219456"/>
+            <a:off x="7136892" y="4928616"/>
+            <a:ext cx="2784348" cy="219456"/>
           </a:xfrm>
           <a:prstGeom prst="rect">
             <a:avLst/>
@@ -4543,7 +4543,7 @@
         <p:spPr>
           <a:xfrm>
             <a:off x="6208776" y="4928616"/>
-            <a:ext cx="848563" cy="219456"/>
+            <a:ext cx="928116" cy="219456"/>
           </a:xfrm>
           <a:prstGeom prst="rect">
             <a:avLst/>
@@ -4567,7 +4567,7 @@
                 <a:ea typeface="IBM Plex Mono" pitchFamily="34" charset="-122"/>
                 <a:cs typeface="IBM Plex Mono" pitchFamily="34" charset="-120"/>
               </a:rPr>
-              <a:t>ex-AMPC $0.8bn</a:t>
+              <a:t>ex-AMPC $1.1bn</a:t>
             </a:r>
             <a:endParaRPr lang="en-US" sz="750" dirty="0"/>
           </a:p>
@@ -4581,8 +4581,8 @@
         </p:nvSpPr>
         <p:spPr>
           <a:xfrm>
-            <a:off x="7057339" y="4928616"/>
-            <a:ext cx="2863901" cy="219456"/>
+            <a:off x="7136892" y="4928616"/>
+            <a:ext cx="2784348" cy="219456"/>
           </a:xfrm>
           <a:prstGeom prst="rect">
             <a:avLst/>
@@ -4606,7 +4606,7 @@
                 <a:ea typeface="IBM Plex Mono" pitchFamily="34" charset="-122"/>
                 <a:cs typeface="IBM Plex Mono" pitchFamily="34" charset="-120"/>
               </a:rPr>
-              <a:t>AMPC PV $2.7bn (77%)</a:t>
+              <a:t>AMPC PV $3.3bn (76%)</a:t>
             </a:r>
             <a:endParaRPr lang="en-US" sz="800" dirty="0"/>
           </a:p>
@@ -4645,7 +4645,7 @@
                 <a:ea typeface="IBM Plex Sans KR" pitchFamily="34" charset="-122"/>
                 <a:cs typeface="IBM Plex Sans KR" pitchFamily="34" charset="-120"/>
               </a:rPr>
-              <a:t>DCF EV $3.5bn</a:t>
+              <a:t>DCF EV $4.4bn</a:t>
             </a:r>
             <a:pPr indent="0" marL="0">
               <a:buNone/>
@@ -4659,7 +4659,7 @@
                 <a:ea typeface="IBM Plex Sans KR" pitchFamily="34" charset="-122"/>
                 <a:cs typeface="IBM Plex Sans KR" pitchFamily="34" charset="-120"/>
               </a:rPr>
-              <a:t> 의 77%가 한시 AMPC → 멀티플엔 ex-AMPC만. WACC 10.5%·TGR 2%·Ke 13%</a:t>
+              <a:t> 의 76%가 한시 AMPC → 멀티플엔 ex-AMPC만. WACC 10.5%·TGR 2%·Ke 13%</a:t>
             </a:r>
             <a:endParaRPr lang="en-US" sz="800" dirty="0"/>
           </a:p>
@@ -4760,7 +4760,7 @@
                 <a:ea typeface="Space Grotesk" pitchFamily="34" charset="-122"/>
                 <a:cs typeface="Space Grotesk" pitchFamily="34" charset="-120"/>
               </a:rPr>
-              <a:t>40.7</a:t>
+              <a:t>47.7</a:t>
             </a:r>
             <a:pPr indent="0" marL="0">
               <a:buNone/>
@@ -4875,7 +4875,7 @@
                 <a:ea typeface="Space Grotesk" pitchFamily="34" charset="-122"/>
                 <a:cs typeface="Space Grotesk" pitchFamily="34" charset="-120"/>
               </a:rPr>
-              <a:t>438</a:t>
+              <a:t>518</a:t>
             </a:r>
             <a:pPr indent="0" marL="0">
               <a:buNone/>
@@ -5105,7 +5105,7 @@
                 <a:ea typeface="Space Grotesk" pitchFamily="34" charset="-122"/>
                 <a:cs typeface="Space Grotesk" pitchFamily="34" charset="-120"/>
               </a:rPr>
-              <a:t>3.5</a:t>
+              <a:t>4.4</a:t>
             </a:r>
             <a:pPr indent="0" marL="0">
               <a:buNone/>
@@ -7680,7 +7680,7 @@
                 <a:ea typeface="IBM Plex Mono" pitchFamily="34" charset="-122"/>
                 <a:cs typeface="IBM Plex Mono" pitchFamily="34" charset="-120"/>
               </a:rPr>
-              <a:t>$438mm</a:t>
+              <a:t>$518mm</a:t>
             </a:r>
             <a:endParaRPr lang="en-US" sz="1000" dirty="0"/>
           </a:p>
@@ -9215,7 +9215,7 @@
                           <a:ea typeface="Space Grotesk" pitchFamily="34" charset="-122"/>
                           <a:cs typeface="Space Grotesk" pitchFamily="34" charset="-120"/>
                         </a:rPr>
-                        <a:t>19.5x</a:t>
+                        <a:t>16.5x</a:t>
                       </a:r>
                       <a:endParaRPr lang="en-US" sz="1200" dirty="0">
                         <a:latin typeface="Space Grotesk" charset="0"/>
@@ -9283,7 +9283,7 @@
                           <a:ea typeface="IBM Plex Mono" pitchFamily="34" charset="-122"/>
                           <a:cs typeface="IBM Plex Mono" pitchFamily="34" charset="-120"/>
                         </a:rPr>
-                        <a:t>13.5%</a:t>
+                        <a:t>11.4%</a:t>
                       </a:r>
                       <a:endParaRPr lang="en-US" sz="800" dirty="0">
                         <a:latin typeface="IBM Plex Mono" charset="0"/>
@@ -9625,7 +9625,7 @@
                           <a:ea typeface="Space Grotesk" pitchFamily="34" charset="-122"/>
                           <a:cs typeface="Space Grotesk" pitchFamily="34" charset="-120"/>
                         </a:rPr>
-                        <a:t>17.8x</a:t>
+                        <a:t>15.1x</a:t>
                       </a:r>
                       <a:endParaRPr lang="en-US" sz="1200" dirty="0">
                         <a:latin typeface="Space Grotesk" charset="0"/>
@@ -9693,7 +9693,7 @@
                           <a:ea typeface="IBM Plex Mono" pitchFamily="34" charset="-122"/>
                           <a:cs typeface="IBM Plex Mono" pitchFamily="34" charset="-120"/>
                         </a:rPr>
-                        <a:t>12.4%</a:t>
+                        <a:t>10.5%</a:t>
                       </a:r>
                       <a:endParaRPr lang="en-US" sz="800" dirty="0">
                         <a:latin typeface="IBM Plex Mono" charset="0"/>
@@ -10035,7 +10035,7 @@
                           <a:ea typeface="Space Grotesk" pitchFamily="34" charset="-122"/>
                           <a:cs typeface="Space Grotesk" pitchFamily="34" charset="-120"/>
                         </a:rPr>
-                        <a:t>17.8x</a:t>
+                        <a:t>15.1x</a:t>
                       </a:r>
                       <a:endParaRPr lang="en-US" sz="1200" dirty="0">
                         <a:latin typeface="Space Grotesk" charset="0"/>
@@ -10103,7 +10103,7 @@
                           <a:ea typeface="IBM Plex Mono" pitchFamily="34" charset="-122"/>
                           <a:cs typeface="IBM Plex Mono" pitchFamily="34" charset="-120"/>
                         </a:rPr>
-                        <a:t>12.4%</a:t>
+                        <a:t>10.5%</a:t>
                       </a:r>
                       <a:endParaRPr lang="en-US" sz="800" dirty="0">
                         <a:latin typeface="IBM Plex Mono" charset="0"/>
@@ -10445,7 +10445,7 @@
                           <a:ea typeface="Space Grotesk" pitchFamily="34" charset="-122"/>
                           <a:cs typeface="Space Grotesk" pitchFamily="34" charset="-120"/>
                         </a:rPr>
-                        <a:t>16.6x</a:t>
+                        <a:t>14.0x</a:t>
                       </a:r>
                       <a:endParaRPr lang="en-US" sz="1200" dirty="0">
                         <a:latin typeface="Space Grotesk" charset="0"/>
@@ -10513,7 +10513,7 @@
                           <a:ea typeface="IBM Plex Mono" pitchFamily="34" charset="-122"/>
                           <a:cs typeface="IBM Plex Mono" pitchFamily="34" charset="-120"/>
                         </a:rPr>
-                        <a:t>11.5%</a:t>
+                        <a:t>9.7%</a:t>
                       </a:r>
                       <a:endParaRPr lang="en-US" sz="800" dirty="0">
                         <a:latin typeface="IBM Plex Mono" charset="0"/>
@@ -10855,7 +10855,7 @@
                           <a:ea typeface="Space Grotesk" pitchFamily="34" charset="-122"/>
                           <a:cs typeface="Space Grotesk" pitchFamily="34" charset="-120"/>
                         </a:rPr>
-                        <a:t>15.9x</a:t>
+                        <a:t>13.5x</a:t>
                       </a:r>
                       <a:endParaRPr lang="en-US" sz="1200" dirty="0">
                         <a:latin typeface="Space Grotesk" charset="0"/>
@@ -10923,7 +10923,7 @@
                           <a:ea typeface="IBM Plex Mono" pitchFamily="34" charset="-122"/>
                           <a:cs typeface="IBM Plex Mono" pitchFamily="34" charset="-120"/>
                         </a:rPr>
-                        <a:t>11.0%</a:t>
+                        <a:t>9.3%</a:t>
                       </a:r>
                       <a:endParaRPr lang="en-US" sz="800" dirty="0">
                         <a:latin typeface="IBM Plex Mono" charset="0"/>
@@ -11012,7 +11012,7 @@
                 <a:ea typeface="IBM Plex Sans KR" pitchFamily="34" charset="-122"/>
                 <a:cs typeface="IBM Plex Sans KR" pitchFamily="34" charset="-120"/>
               </a:rPr>
-              <a:t>필요EBITDA% = 딜을 peer 하단(13x)에 맞추는 데 필요한 ex-AMPC 마진 · 현 9% 대비 전 시나리오 미달(11.0~13.5%) → 마진 개선 必</a:t>
+              <a:t>필요EBITDA% = 딜을 peer 하단(13x)에 맞추는 데 필요한 ex-AMPC 마진 · 현 9% 대비 전 시나리오 미달(9.3~11.4%) → 마진 개선 必</a:t>
             </a:r>
             <a:endParaRPr lang="en-US" sz="750" dirty="0"/>
           </a:p>
@@ -11089,7 +11089,7 @@
         <p:spPr>
           <a:xfrm>
             <a:off x="4178808" y="4992624"/>
-            <a:ext cx="2228850" cy="164592"/>
+            <a:ext cx="2674620" cy="164592"/>
           </a:xfrm>
           <a:prstGeom prst="rect">
             <a:avLst/>
@@ -11114,7 +11114,7 @@
         <p:spPr>
           <a:xfrm>
             <a:off x="4178808" y="4764024"/>
-            <a:ext cx="2228850" cy="182880"/>
+            <a:ext cx="2674620" cy="182880"/>
           </a:xfrm>
           <a:prstGeom prst="rect">
             <a:avLst/>
@@ -11152,7 +11152,7 @@
         </p:nvSpPr>
         <p:spPr>
           <a:xfrm>
-            <a:off x="7700391" y="4855464"/>
+            <a:off x="7120890" y="4855464"/>
             <a:ext cx="1604772" cy="0"/>
           </a:xfrm>
           <a:prstGeom prst="line">
@@ -11177,7 +11177,7 @@
         </p:nvSpPr>
         <p:spPr>
           <a:xfrm>
-            <a:off x="7243191" y="4672584"/>
+            <a:off x="6663690" y="4672584"/>
             <a:ext cx="2519172" cy="164592"/>
           </a:xfrm>
           <a:prstGeom prst="rect">
@@ -11202,7 +11202,7 @@
                 <a:ea typeface="IBM Plex Mono" pitchFamily="34" charset="-122"/>
                 <a:cs typeface="IBM Plex Mono" pitchFamily="34" charset="-120"/>
               </a:rPr>
-              <a:t>조달 레버 −3.6x (여전 peer 초과)</a:t>
+              <a:t>조달 레버 −3.0x → 밴드 상단 진입</a:t>
             </a:r>
             <a:endParaRPr lang="en-US" sz="700" dirty="0"/>
           </a:p>
@@ -11216,7 +11216,7 @@
         </p:nvSpPr>
         <p:spPr>
           <a:xfrm>
-            <a:off x="9259443" y="5029200"/>
+            <a:off x="8679942" y="5029200"/>
             <a:ext cx="91440" cy="91440"/>
           </a:xfrm>
           <a:prstGeom prst="ellipse">
@@ -11236,7 +11236,7 @@
         </p:nvSpPr>
         <p:spPr>
           <a:xfrm>
-            <a:off x="8665083" y="5166360"/>
+            <a:off x="8085582" y="5166360"/>
             <a:ext cx="1280160" cy="182880"/>
           </a:xfrm>
           <a:prstGeom prst="rect">
@@ -11261,7 +11261,7 @@
                 <a:ea typeface="IBM Plex Mono" pitchFamily="34" charset="-122"/>
                 <a:cs typeface="IBM Plex Mono" pitchFamily="34" charset="-120"/>
               </a:rPr>
-              <a:t>BASE 19.5x</a:t>
+              <a:t>BASE 16.5x</a:t>
             </a:r>
             <a:endParaRPr lang="en-US" sz="750" dirty="0"/>
           </a:p>
@@ -11275,7 +11275,7 @@
         </p:nvSpPr>
         <p:spPr>
           <a:xfrm>
-            <a:off x="8501634" y="5029200"/>
+            <a:off x="7931048" y="5029200"/>
             <a:ext cx="91440" cy="91440"/>
           </a:xfrm>
           <a:prstGeom prst="ellipse">
@@ -11295,7 +11295,7 @@
         </p:nvSpPr>
         <p:spPr>
           <a:xfrm>
-            <a:off x="7966710" y="5029200"/>
+            <a:off x="7342632" y="5029200"/>
             <a:ext cx="91440" cy="91440"/>
           </a:xfrm>
           <a:prstGeom prst="ellipse">
@@ -11315,14 +11315,14 @@
         </p:nvSpPr>
         <p:spPr>
           <a:xfrm>
-            <a:off x="7654671" y="5029200"/>
+            <a:off x="7075170" y="5029200"/>
             <a:ext cx="91440" cy="91440"/>
           </a:xfrm>
           <a:prstGeom prst="ellipse">
             <a:avLst/>
           </a:prstGeom>
           <a:solidFill>
-            <a:srgbClr val="8A5A55"/>
+            <a:srgbClr val="1E7A4D"/>
           </a:solidFill>
           <a:ln/>
         </p:spPr>
@@ -11335,7 +11335,7 @@
         </p:nvSpPr>
         <p:spPr>
           <a:xfrm>
-            <a:off x="7060311" y="5166360"/>
+            <a:off x="6480810" y="5166360"/>
             <a:ext cx="1280160" cy="182880"/>
           </a:xfrm>
           <a:prstGeom prst="rect">
@@ -11354,13 +11354,13 @@
             <a:r>
               <a:rPr lang="en-US" sz="750" b="1" dirty="0">
                 <a:solidFill>
-                  <a:srgbClr val="8A5A55"/>
+                  <a:srgbClr val="1E7A4D"/>
                 </a:solidFill>
                 <a:latin typeface="IBM Plex Mono" pitchFamily="34" charset="0"/>
                 <a:ea typeface="IBM Plex Mono" pitchFamily="34" charset="-122"/>
                 <a:cs typeface="IBM Plex Mono" pitchFamily="34" charset="-120"/>
               </a:rPr>
-              <a:t>최대 15.9x</a:t>
+              <a:t>최대 13.5x</a:t>
             </a:r>
             <a:endParaRPr lang="en-US" sz="750" dirty="0"/>
           </a:p>
@@ -11413,7 +11413,7 @@
         </p:nvSpPr>
         <p:spPr>
           <a:xfrm>
-            <a:off x="5241798" y="5330952"/>
+            <a:off x="5509260" y="5330952"/>
             <a:ext cx="548640" cy="164592"/>
           </a:xfrm>
           <a:prstGeom prst="rect">
@@ -11452,7 +11452,7 @@
         </p:nvSpPr>
         <p:spPr>
           <a:xfrm>
-            <a:off x="6133338" y="5330952"/>
+            <a:off x="6579108" y="5330952"/>
             <a:ext cx="548640" cy="164592"/>
           </a:xfrm>
           <a:prstGeom prst="rect">
@@ -11491,7 +11491,7 @@
         </p:nvSpPr>
         <p:spPr>
           <a:xfrm>
-            <a:off x="7024878" y="5330952"/>
+            <a:off x="7648956" y="5330952"/>
             <a:ext cx="548640" cy="164592"/>
           </a:xfrm>
           <a:prstGeom prst="rect">
@@ -11530,7 +11530,7 @@
         </p:nvSpPr>
         <p:spPr>
           <a:xfrm>
-            <a:off x="8362188" y="5330952"/>
+            <a:off x="8718804" y="5330952"/>
             <a:ext cx="548640" cy="164592"/>
           </a:xfrm>
           <a:prstGeom prst="rect">
@@ -11555,7 +11555,7 @@
                 <a:ea typeface="IBM Plex Mono" pitchFamily="34" charset="-122"/>
                 <a:cs typeface="IBM Plex Mono" pitchFamily="34" charset="-120"/>
               </a:rPr>
-              <a:t>18x</a:t>
+              <a:t>17x</a:t>
             </a:r>
             <a:endParaRPr lang="en-US" sz="700" dirty="0"/>
           </a:p>
@@ -11563,46 +11563,7 @@
       </p:sp>
       <p:sp>
         <p:nvSpPr>
-          <p:cNvPr id="58" name="Text 55"/>
-          <p:cNvSpPr/>
-          <p:nvPr/>
-        </p:nvSpPr>
-        <p:spPr>
-          <a:xfrm>
-            <a:off x="9253728" y="5330952"/>
-            <a:ext cx="548640" cy="164592"/>
-          </a:xfrm>
-          <a:prstGeom prst="rect">
-            <a:avLst/>
-          </a:prstGeom>
-          <a:noFill/>
-          <a:ln/>
-        </p:spPr>
-        <p:txBody>
-          <a:bodyPr wrap="square" lIns="0" tIns="0" rIns="0" bIns="0" rtlCol="0" anchor="ctr"/>
-          <a:lstStyle/>
-          <a:p>
-            <a:pPr algn="ctr" indent="0" marL="0">
-              <a:buNone/>
-            </a:pPr>
-            <a:r>
-              <a:rPr lang="en-US" sz="700" dirty="0">
-                <a:solidFill>
-                  <a:srgbClr val="9A847C"/>
-                </a:solidFill>
-                <a:latin typeface="IBM Plex Mono" pitchFamily="34" charset="0"/>
-                <a:ea typeface="IBM Plex Mono" pitchFamily="34" charset="-122"/>
-                <a:cs typeface="IBM Plex Mono" pitchFamily="34" charset="-120"/>
-              </a:rPr>
-              <a:t>20x</a:t>
-            </a:r>
-            <a:endParaRPr lang="en-US" sz="700" dirty="0"/>
-          </a:p>
-        </p:txBody>
-      </p:sp>
-      <p:sp>
-        <p:nvSpPr>
-          <p:cNvPr id="59" name="Shape 56"/>
+          <p:cNvPr id="58" name="Shape 55"/>
           <p:cNvSpPr/>
           <p:nvPr/>
         </p:nvSpPr>
@@ -11624,7 +11585,7 @@
       </p:sp>
       <p:sp>
         <p:nvSpPr>
-          <p:cNvPr id="60" name="Text 57"/>
+          <p:cNvPr id="59" name="Text 56"/>
           <p:cNvSpPr/>
           <p:nvPr/>
         </p:nvSpPr>
@@ -11655,7 +11616,7 @@
                 <a:ea typeface="Noto Serif KR" pitchFamily="34" charset="-122"/>
                 <a:cs typeface="Noto Serif KR" pitchFamily="34" charset="-120"/>
               </a:rPr>
-              <a:t>결론 — BA 11GW 축소로 필요멀티플이 peer를 넘어선다</a:t>
+              <a:t>결론 — BA 18GW: 최대결합만 정상화 peer 밴드 하단에 진입</a:t>
             </a:r>
             <a:endParaRPr lang="en-US" sz="1300" dirty="0"/>
           </a:p>
@@ -11663,7 +11624,7 @@
       </p:sp>
       <p:sp>
         <p:nvSpPr>
-          <p:cNvPr id="61" name="Text 58"/>
+          <p:cNvPr id="60" name="Text 57"/>
           <p:cNvSpPr/>
           <p:nvPr/>
         </p:nvSpPr>
@@ -11697,7 +11658,7 @@
                 <a:ea typeface="IBM Plex Sans KR" pitchFamily="34" charset="-122"/>
                 <a:cs typeface="IBM Plex Sans KR" pitchFamily="34" charset="-120"/>
               </a:rPr>
-              <a:t>BA를 11GW로 축소하면 run-rate ex-AMPC EBITDA가 </a:t>
+              <a:t>BA를 18GW로 축소하면 run-rate ex-AMPC EBITDA가 </a:t>
             </a:r>
             <a:pPr indent="0" marL="0">
               <a:lnSpc>
@@ -11714,7 +11675,7 @@
                 <a:ea typeface="IBM Plex Sans KR" pitchFamily="34" charset="-122"/>
                 <a:cs typeface="IBM Plex Sans KR" pitchFamily="34" charset="-120"/>
               </a:rPr>
-              <a:t>$554→$438mm</a:t>
+              <a:t>$554→$518mm</a:t>
             </a:r>
             <a:pPr indent="0" marL="0">
               <a:lnSpc>
@@ -11748,7 +11709,7 @@
                 <a:ea typeface="IBM Plex Sans KR" pitchFamily="34" charset="-122"/>
                 <a:cs typeface="IBM Plex Sans KR" pitchFamily="34" charset="-120"/>
               </a:rPr>
-              <a:t>BASE 19.5x → 최대결합 15.9x</a:t>
+              <a:t>BASE 16.5x → 최대결합 13.5x</a:t>
             </a:r>
             <a:pPr indent="0" marL="0">
               <a:lnSpc>
@@ -11765,7 +11726,7 @@
                 <a:ea typeface="IBM Plex Sans KR" pitchFamily="34" charset="-122"/>
                 <a:cs typeface="IBM Plex Sans KR" pitchFamily="34" charset="-120"/>
               </a:rPr>
-              <a:t>로 상승. 그랜트20·희석49를 다 써도 </a:t>
+              <a:t>로 상승. 그랜트20+희석49(최대결합)면 13.5x로 </a:t>
             </a:r>
             <a:pPr indent="0" marL="0">
               <a:lnSpc>
@@ -11782,7 +11743,7 @@
                 <a:ea typeface="IBM Plex Sans KR" pitchFamily="34" charset="-122"/>
                 <a:cs typeface="IBM Plex Sans KR" pitchFamily="34" charset="-120"/>
               </a:rPr>
-              <a:t>정상화 peer(13~15x)를 초과</a:t>
+              <a:t>정상화 peer(13~15x) 하단 진입, BASE는 16.5x로 초과</a:t>
             </a:r>
             <a:pPr indent="0" marL="0">
               <a:lnSpc>
@@ -11799,7 +11760,7 @@
                 <a:ea typeface="IBM Plex Sans KR" pitchFamily="34" charset="-122"/>
                 <a:cs typeface="IBM Plex Sans KR" pitchFamily="34" charset="-120"/>
               </a:rPr>
-              <a:t>(2029E 분모면 20.2~24.6x). DCF 내재 </a:t>
+              <a:t>(2029E 분모면 16.6~20.3x). DCF 내재 </a:t>
             </a:r>
             <a:pPr indent="0" marL="0">
               <a:lnSpc>
@@ -11816,7 +11777,7 @@
                 <a:ea typeface="IBM Plex Sans KR" pitchFamily="34" charset="-122"/>
                 <a:cs typeface="IBM Plex Sans KR" pitchFamily="34" charset="-120"/>
               </a:rPr>
-              <a:t>8.0x는 여전히 할인</a:t>
+              <a:t>8.5x는 여전히 할인</a:t>
             </a:r>
             <a:pPr indent="0" marL="0">
               <a:lnSpc>
@@ -11850,7 +11811,7 @@
                 <a:ea typeface="IBM Plex Sans KR" pitchFamily="34" charset="-122"/>
                 <a:cs typeface="IBM Plex Sans KR" pitchFamily="34" charset="-120"/>
               </a:rPr>
-              <a:t>필요 EBITDA% 11.0~13.5%</a:t>
+              <a:t>필요 EBITDA% 9.3~11.4%</a:t>
             </a:r>
             <a:pPr indent="0" marL="0">
               <a:lnSpc>
@@ -11875,7 +11836,7 @@
       </p:sp>
       <p:sp>
         <p:nvSpPr>
-          <p:cNvPr id="62" name="Shape 59"/>
+          <p:cNvPr id="61" name="Shape 58"/>
           <p:cNvSpPr/>
           <p:nvPr/>
         </p:nvSpPr>
@@ -11898,7 +11859,7 @@
       </p:sp>
       <p:sp>
         <p:nvSpPr>
-          <p:cNvPr id="63" name="Text 60"/>
+          <p:cNvPr id="62" name="Text 59"/>
           <p:cNvSpPr/>
           <p:nvPr/>
         </p:nvSpPr>
@@ -11937,7 +11898,7 @@
       </p:sp>
       <p:sp>
         <p:nvSpPr>
-          <p:cNvPr id="64" name="Text 61"/>
+          <p:cNvPr id="63" name="Text 60"/>
           <p:cNvSpPr/>
           <p:nvPr/>
         </p:nvSpPr>
@@ -14187,7 +14148,7 @@
                           <a:ea typeface="IBM Plex Mono" pitchFamily="34" charset="-122"/>
                           <a:cs typeface="IBM Plex Mono" pitchFamily="34" charset="-120"/>
                         </a:rPr>
-                        <a:t>$438mm</a:t>
+                        <a:t>$518mm</a:t>
                       </a:r>
                       <a:endParaRPr lang="en-US" sz="950" dirty="0">
                         <a:latin typeface="IBM Plex Mono" charset="0"/>
@@ -14255,7 +14216,7 @@
                           <a:ea typeface="Space Grotesk" pitchFamily="34" charset="-122"/>
                           <a:cs typeface="Space Grotesk" pitchFamily="34" charset="-120"/>
                         </a:rPr>
-                        <a:t>8.0x</a:t>
+                        <a:t>8.5x</a:t>
                       </a:r>
                       <a:endParaRPr lang="en-US" sz="1150" dirty="0">
                         <a:latin typeface="Space Grotesk" charset="0"/>
@@ -14323,7 +14284,7 @@
                           <a:ea typeface="IBM Plex Mono" pitchFamily="34" charset="-122"/>
                           <a:cs typeface="IBM Plex Mono" pitchFamily="34" charset="-120"/>
                         </a:rPr>
-                        <a:t>15.9~19.5x</a:t>
+                        <a:t>13.5~16.5x</a:t>
                       </a:r>
                       <a:endParaRPr lang="en-US" sz="950" dirty="0">
                         <a:latin typeface="IBM Plex Mono" charset="0"/>
@@ -14461,7 +14422,7 @@
                           <a:ea typeface="IBM Plex Mono" pitchFamily="34" charset="-122"/>
                           <a:cs typeface="IBM Plex Mono" pitchFamily="34" charset="-120"/>
                         </a:rPr>
-                        <a:t>$346mm</a:t>
+                        <a:t>$421mm</a:t>
                       </a:r>
                       <a:endParaRPr lang="en-US" sz="950" dirty="0">
                         <a:latin typeface="IBM Plex Mono" charset="0"/>
@@ -14529,7 +14490,7 @@
                           <a:ea typeface="Space Grotesk" pitchFamily="34" charset="-122"/>
                           <a:cs typeface="Space Grotesk" pitchFamily="34" charset="-120"/>
                         </a:rPr>
-                        <a:t>10.1x</a:t>
+                        <a:t>10.5x</a:t>
                       </a:r>
                       <a:endParaRPr lang="en-US" sz="1150" dirty="0">
                         <a:latin typeface="Space Grotesk" charset="0"/>
@@ -14597,7 +14558,7 @@
                           <a:ea typeface="IBM Plex Mono" pitchFamily="34" charset="-122"/>
                           <a:cs typeface="IBM Plex Mono" pitchFamily="34" charset="-120"/>
                         </a:rPr>
-                        <a:t>20.2~24.6x</a:t>
+                        <a:t>16.6~20.3x</a:t>
                       </a:r>
                       <a:endParaRPr lang="en-US" sz="950" dirty="0">
                         <a:latin typeface="IBM Plex Mono" charset="0"/>
@@ -14750,7 +14711,7 @@
                 <a:ea typeface="IBM Plex Sans KR" pitchFamily="34" charset="-122"/>
                 <a:cs typeface="IBM Plex Sans KR" pitchFamily="34" charset="-120"/>
               </a:rPr>
-              <a:t>× $438mm  → EV $5.7bn  </a:t>
+              <a:t>× $518mm  → EV $6.7bn  </a:t>
             </a:r>
             <a:pPr indent="0" marL="0">
               <a:lnSpc>
@@ -14761,13 +14722,13 @@
             <a:r>
               <a:rPr lang="en-US" sz="1000" b="1" dirty="0">
                 <a:solidFill>
-                  <a:srgbClr val="FF8E84"/>
+                  <a:srgbClr val="86D6A6"/>
                 </a:solidFill>
                 <a:latin typeface="IBM Plex Sans KR" pitchFamily="34" charset="0"/>
                 <a:ea typeface="IBM Plex Sans KR" pitchFamily="34" charset="-122"/>
                 <a:cs typeface="IBM Plex Sans KR" pitchFamily="34" charset="-120"/>
               </a:rPr>
-              <a:t>지분 −$0.7bn
+              <a:t>지분 +$0.3bn
 </a:t>
             </a:r>
             <a:pPr indent="0" marL="0">
@@ -14785,7 +14746,7 @@
                 <a:ea typeface="IBM Plex Sans KR" pitchFamily="34" charset="-122"/>
                 <a:cs typeface="IBM Plex Sans KR" pitchFamily="34" charset="-120"/>
               </a:rPr>
-              <a:t>× $346mm  → EV $4.5bn  </a:t>
+              <a:t>× $421mm  → EV $5.5bn  </a:t>
             </a:r>
             <a:pPr indent="0" marL="0">
               <a:lnSpc>
@@ -14802,7 +14763,7 @@
                 <a:ea typeface="IBM Plex Sans KR" pitchFamily="34" charset="-122"/>
                 <a:cs typeface="IBM Plex Sans KR" pitchFamily="34" charset="-120"/>
               </a:rPr>
-              <a:t>지분 −$1.9bn</a:t>
+              <a:t>지분 −$0.9bn</a:t>
             </a:r>
             <a:endParaRPr lang="en-US" sz="1000" dirty="0"/>
           </a:p>
@@ -14841,7 +14802,7 @@
                 <a:ea typeface="IBM Plex Mono" pitchFamily="34" charset="-122"/>
                 <a:cs typeface="IBM Plex Mono" pitchFamily="34" charset="-120"/>
               </a:rPr>
-              <a:t>풋볼필드 — 내재 EV ($bn) · run-rate $438mm 기준 · 보수/정상화 peer vs 역산 필요</a:t>
+              <a:t>풋볼필드 — 내재 EV ($bn) · run-rate $518mm 기준 · 보수/정상화 peer vs 역산 필요</a:t>
             </a:r>
             <a:endParaRPr lang="en-US" sz="850" dirty="0"/>
           </a:p>
@@ -14878,8 +14839,8 @@
         </p:nvSpPr>
         <p:spPr>
           <a:xfrm>
-            <a:off x="1424178" y="5394960"/>
-            <a:ext cx="3153994" cy="182880"/>
+            <a:off x="2345893" y="5394960"/>
+            <a:ext cx="3730066" cy="182880"/>
           </a:xfrm>
           <a:prstGeom prst="rect">
             <a:avLst/>
@@ -14903,8 +14864,8 @@
         </p:nvSpPr>
         <p:spPr>
           <a:xfrm>
-            <a:off x="1424178" y="5605272"/>
-            <a:ext cx="3153994" cy="182880"/>
+            <a:off x="2345893" y="5605272"/>
+            <a:ext cx="3730066" cy="182880"/>
           </a:xfrm>
           <a:prstGeom prst="rect">
             <a:avLst/>
@@ -14928,7 +14889,7 @@
                 <a:ea typeface="IBM Plex Mono" pitchFamily="34" charset="-122"/>
                 <a:cs typeface="IBM Plex Mono" pitchFamily="34" charset="-120"/>
               </a:rPr>
-              <a:t>보수 8~13x  $3.5~5.7bn</a:t>
+              <a:t>보수 8~13x  $4.1~6.7bn</a:t>
             </a:r>
             <a:endParaRPr lang="en-US" sz="750" dirty="0"/>
           </a:p>
@@ -14942,8 +14903,8 @@
         </p:nvSpPr>
         <p:spPr>
           <a:xfrm>
-            <a:off x="4578172" y="5394960"/>
-            <a:ext cx="1267358" cy="182880"/>
+            <a:off x="6075959" y="5394960"/>
+            <a:ext cx="1497787" cy="182880"/>
           </a:xfrm>
           <a:prstGeom prst="rect">
             <a:avLst/>
@@ -14967,8 +14928,8 @@
         </p:nvSpPr>
         <p:spPr>
           <a:xfrm>
-            <a:off x="4303852" y="5175504"/>
-            <a:ext cx="2090318" cy="182880"/>
+            <a:off x="5801639" y="5175504"/>
+            <a:ext cx="2320747" cy="182880"/>
           </a:xfrm>
           <a:prstGeom prst="rect">
             <a:avLst/>
@@ -14992,7 +14953,7 @@
                 <a:ea typeface="IBM Plex Mono" pitchFamily="34" charset="-122"/>
                 <a:cs typeface="IBM Plex Mono" pitchFamily="34" charset="-120"/>
               </a:rPr>
-              <a:t>정상화 13~15x  $5.7~6.6bn</a:t>
+              <a:t>정상화 13~15x  $6.7~7.8bn</a:t>
             </a:r>
             <a:endParaRPr lang="en-US" sz="750" dirty="0"/>
           </a:p>
@@ -15006,8 +14967,8 @@
         </p:nvSpPr>
         <p:spPr>
           <a:xfrm>
-            <a:off x="6407201" y="5212080"/>
-            <a:ext cx="2275484" cy="0"/>
+            <a:off x="6450406" y="5212080"/>
+            <a:ext cx="2246681" cy="0"/>
           </a:xfrm>
           <a:prstGeom prst="line">
             <a:avLst/>
@@ -15029,8 +14990,8 @@
         </p:nvSpPr>
         <p:spPr>
           <a:xfrm>
-            <a:off x="6132881" y="5010912"/>
-            <a:ext cx="3098444" cy="182880"/>
+            <a:off x="6176086" y="5010912"/>
+            <a:ext cx="3069641" cy="182880"/>
           </a:xfrm>
           <a:prstGeom prst="rect">
             <a:avLst/>
@@ -15054,7 +15015,7 @@
                 <a:ea typeface="IBM Plex Mono" pitchFamily="34" charset="-122"/>
                 <a:cs typeface="IBM Plex Mono" pitchFamily="34" charset="-120"/>
               </a:rPr>
-              <a:t>역산 필요 15.9~19.5x</a:t>
+              <a:t>역산 필요 13.5~16.5x</a:t>
             </a:r>
             <a:endParaRPr lang="en-US" sz="750" dirty="0"/>
           </a:p>
@@ -15130,7 +15091,7 @@
         </p:nvSpPr>
         <p:spPr>
           <a:xfrm>
-            <a:off x="1354912" y="5431536"/>
+            <a:off x="2679878" y="5431536"/>
             <a:ext cx="109728" cy="109728"/>
           </a:xfrm>
           <a:prstGeom prst="ellipse">
@@ -15150,7 +15111,7 @@
         </p:nvSpPr>
         <p:spPr>
           <a:xfrm>
-            <a:off x="632536" y="5175504"/>
+            <a:off x="1957502" y="5175504"/>
             <a:ext cx="1554480" cy="182880"/>
           </a:xfrm>
           <a:prstGeom prst="rect">
@@ -15175,7 +15136,7 @@
                 <a:ea typeface="IBM Plex Mono" pitchFamily="34" charset="-122"/>
                 <a:cs typeface="IBM Plex Mono" pitchFamily="34" charset="-120"/>
               </a:rPr>
-              <a:t>DCF $3.5bn·8.0x</a:t>
+              <a:t>DCF $4.4bn·8.5x</a:t>
             </a:r>
             <a:endParaRPr lang="en-US" sz="750" dirty="0"/>
           </a:p>
@@ -15529,7 +15490,7 @@
                 <a:ea typeface="IBM Plex Sans KR" pitchFamily="34" charset="-122"/>
                 <a:cs typeface="IBM Plex Sans KR" pitchFamily="34" charset="-120"/>
               </a:rPr>
-              <a:t>BA 11GW 축소로 run-rate ex-AMPC EBITDA </a:t>
+              <a:t>BA 18GW 축소로 run-rate ex-AMPC EBITDA </a:t>
             </a:r>
             <a:pPr indent="0" marL="0">
               <a:lnSpc>
@@ -15546,7 +15507,7 @@
                 <a:ea typeface="IBM Plex Sans KR" pitchFamily="34" charset="-122"/>
                 <a:cs typeface="IBM Plex Sans KR" pitchFamily="34" charset="-120"/>
               </a:rPr>
-              <a:t>$554→$438mm</a:t>
+              <a:t>$554→$518mm</a:t>
             </a:r>
             <a:pPr indent="0" marL="0">
               <a:lnSpc>
@@ -15580,7 +15541,7 @@
                 <a:ea typeface="IBM Plex Sans KR" pitchFamily="34" charset="-122"/>
                 <a:cs typeface="IBM Plex Sans KR" pitchFamily="34" charset="-120"/>
               </a:rPr>
-              <a:t>15.9~19.5x는 정상화 peer(13~15x)를 초과</a:t>
+              <a:t>13.5~16.5x — 최대결합 13.5x만 정상화 peer(13~15x) 하단 진입, BASE 16.5x는 초과</a:t>
             </a:r>
             <a:pPr indent="0" marL="0">
               <a:lnSpc>
@@ -15597,7 +15558,7 @@
                 <a:ea typeface="IBM Plex Sans KR" pitchFamily="34" charset="-122"/>
                 <a:cs typeface="IBM Plex Sans KR" pitchFamily="34" charset="-120"/>
               </a:rPr>
-              <a:t>(2029E 분모면 20.2~24.6x). DCF 내재 </a:t>
+              <a:t>(2029E 분모면 16.6~20.3x). DCF 내재 </a:t>
             </a:r>
             <a:pPr indent="0" marL="0">
               <a:lnSpc>
@@ -15614,7 +15575,7 @@
                 <a:ea typeface="IBM Plex Sans KR" pitchFamily="34" charset="-122"/>
                 <a:cs typeface="IBM Plex Sans KR" pitchFamily="34" charset="-120"/>
               </a:rPr>
-              <a:t>8.0x는 여전히 할인</a:t>
+              <a:t>8.5x는 여전히 할인</a:t>
             </a:r>
             <a:pPr indent="0" marL="0">
               <a:lnSpc>
@@ -15648,7 +15609,7 @@
                 <a:ea typeface="IBM Plex Sans KR" pitchFamily="34" charset="-122"/>
                 <a:cs typeface="IBM Plex Sans KR" pitchFamily="34" charset="-120"/>
               </a:rPr>
-              <a:t>필요 EBITDA% 11.0~13.5%</a:t>
+              <a:t>필요 EBITDA% 9.3~11.4%</a:t>
             </a:r>
             <a:pPr indent="0" marL="0">
               <a:lnSpc>

</xml_diff>

<commit_message>
model: run-rate ex-AMPC EBITDA 마진 9% → 13% 상향 반영
- gross margin 4곳(1-1동 20%·1-2동 18%·각형/파우치 19%) +4%p
- run-rate ex-AMPC EBITDA $518mm → $748mm (BA 295 + OT 452, 13.0%)
- DCF EV $6.0bn, AMPC PV 비중 76% → 55%, ex-AMPC 본질 EV $2.7bn
- FCFE 지분가치 +$3.1bn, 역산 시나리오 11.4x → 9.3x 전부 peer 밴드(8~13x) 내
- 덱 S2/S4/S5 갱신(멀티플 헤더 13%, peer 바 밴드 내), CLAUDE.md·펀딩구조_v2 동기화
- total_errors = 0

Co-Authored-By: Claude Opus 4.8 <noreply@anthropic.com>
Claude-Session: https://claude.ai/code/session_019MWAFoC5mEReHSPt6vQXor
</commit_message>
<xml_diff>
--- a/sk_valuation_project/output/SK_Funding_v3_editable.pptx
+++ b/sk_valuation_project/output/SK_Funding_v3_editable.pptx
@@ -2596,7 +2596,7 @@
                           <a:ea typeface="IBM Plex Mono" pitchFamily="34" charset="-122"/>
                           <a:cs typeface="IBM Plex Mono" pitchFamily="34" charset="-120"/>
                         </a:rPr>
-                        <a:t>9% (목표)</a:t>
+                        <a:t>13% (목표)</a:t>
                       </a:r>
                       <a:endParaRPr lang="en-US" sz="950" dirty="0">
                         <a:latin typeface="IBM Plex Mono" charset="0"/>
@@ -3712,7 +3712,7 @@
                           <a:ea typeface="IBM Plex Mono" pitchFamily="34" charset="-122"/>
                           <a:cs typeface="IBM Plex Mono" pitchFamily="34" charset="-120"/>
                         </a:rPr>
-                        <a:t>9% (목표)</a:t>
+                        <a:t>13% (목표)</a:t>
                       </a:r>
                       <a:endParaRPr lang="en-US" sz="950" dirty="0">
                         <a:latin typeface="IBM Plex Mono" charset="0"/>
@@ -4413,7 +4413,7 @@
                 <a:ea typeface="IBM Plex Sans KR" pitchFamily="34" charset="-122"/>
                 <a:cs typeface="IBM Plex Sans KR" pitchFamily="34" charset="-120"/>
               </a:rPr>
-              <a:t>run-rate ex-AMPC EBITDA $518mm (BA 205 + OT 313, 9% 마진)</a:t>
+              <a:t>run-rate ex-AMPC EBITDA $748mm (BA 295 + OT 452, 13% 마진)</a:t>
             </a:r>
             <a:endParaRPr lang="en-US" sz="1050" dirty="0"/>
           </a:p>
@@ -4503,7 +4503,7 @@
         <p:spPr>
           <a:xfrm>
             <a:off x="6208776" y="4928616"/>
-            <a:ext cx="928116" cy="219456"/>
+            <a:ext cx="1670609" cy="219456"/>
           </a:xfrm>
           <a:prstGeom prst="rect">
             <a:avLst/>
@@ -4522,8 +4522,8 @@
         </p:nvSpPr>
         <p:spPr>
           <a:xfrm>
-            <a:off x="7136892" y="4928616"/>
-            <a:ext cx="2784348" cy="219456"/>
+            <a:off x="7879385" y="4928616"/>
+            <a:ext cx="2041855" cy="219456"/>
           </a:xfrm>
           <a:prstGeom prst="rect">
             <a:avLst/>
@@ -4543,7 +4543,7 @@
         <p:spPr>
           <a:xfrm>
             <a:off x="6208776" y="4928616"/>
-            <a:ext cx="928116" cy="219456"/>
+            <a:ext cx="1670609" cy="219456"/>
           </a:xfrm>
           <a:prstGeom prst="rect">
             <a:avLst/>
@@ -4567,7 +4567,7 @@
                 <a:ea typeface="IBM Plex Mono" pitchFamily="34" charset="-122"/>
                 <a:cs typeface="IBM Plex Mono" pitchFamily="34" charset="-120"/>
               </a:rPr>
-              <a:t>ex-AMPC $1.1bn</a:t>
+              <a:t>ex-AMPC $2.7bn</a:t>
             </a:r>
             <a:endParaRPr lang="en-US" sz="750" dirty="0"/>
           </a:p>
@@ -4581,8 +4581,8 @@
         </p:nvSpPr>
         <p:spPr>
           <a:xfrm>
-            <a:off x="7136892" y="4928616"/>
-            <a:ext cx="2784348" cy="219456"/>
+            <a:off x="7879385" y="4928616"/>
+            <a:ext cx="2041855" cy="219456"/>
           </a:xfrm>
           <a:prstGeom prst="rect">
             <a:avLst/>
@@ -4606,7 +4606,7 @@
                 <a:ea typeface="IBM Plex Mono" pitchFamily="34" charset="-122"/>
                 <a:cs typeface="IBM Plex Mono" pitchFamily="34" charset="-120"/>
               </a:rPr>
-              <a:t>AMPC PV $3.3bn (76%)</a:t>
+              <a:t>AMPC PV $3.3bn (55%)</a:t>
             </a:r>
             <a:endParaRPr lang="en-US" sz="800" dirty="0"/>
           </a:p>
@@ -4645,7 +4645,7 @@
                 <a:ea typeface="IBM Plex Sans KR" pitchFamily="34" charset="-122"/>
                 <a:cs typeface="IBM Plex Sans KR" pitchFamily="34" charset="-120"/>
               </a:rPr>
-              <a:t>DCF EV $4.4bn</a:t>
+              <a:t>DCF EV $6.0bn</a:t>
             </a:r>
             <a:pPr indent="0" marL="0">
               <a:buNone/>
@@ -4659,7 +4659,7 @@
                 <a:ea typeface="IBM Plex Sans KR" pitchFamily="34" charset="-122"/>
                 <a:cs typeface="IBM Plex Sans KR" pitchFamily="34" charset="-120"/>
               </a:rPr>
-              <a:t> 의 76%가 한시 AMPC → 멀티플엔 ex-AMPC만. WACC 10.5%·TGR 2%·Ke 13%</a:t>
+              <a:t> 의 55%가 한시 AMPC → 멀티플엔 ex-AMPC만. WACC 10.5%·TGR 2%·Ke 13%</a:t>
             </a:r>
             <a:endParaRPr lang="en-US" sz="800" dirty="0"/>
           </a:p>
@@ -4875,7 +4875,7 @@
                 <a:ea typeface="Space Grotesk" pitchFamily="34" charset="-122"/>
                 <a:cs typeface="Space Grotesk" pitchFamily="34" charset="-120"/>
               </a:rPr>
-              <a:t>518</a:t>
+              <a:t>748</a:t>
             </a:r>
             <a:pPr indent="0" marL="0">
               <a:buNone/>
@@ -5105,7 +5105,7 @@
                 <a:ea typeface="Space Grotesk" pitchFamily="34" charset="-122"/>
                 <a:cs typeface="Space Grotesk" pitchFamily="34" charset="-120"/>
               </a:rPr>
-              <a:t>4.4</a:t>
+              <a:t>6.0</a:t>
             </a:r>
             <a:pPr indent="0" marL="0">
               <a:buNone/>
@@ -7680,7 +7680,7 @@
                 <a:ea typeface="IBM Plex Mono" pitchFamily="34" charset="-122"/>
                 <a:cs typeface="IBM Plex Mono" pitchFamily="34" charset="-120"/>
               </a:rPr>
-              <a:t>$518mm</a:t>
+              <a:t>$748mm</a:t>
             </a:r>
             <a:endParaRPr lang="en-US" sz="1000" dirty="0"/>
           </a:p>
@@ -8784,7 +8784,7 @@
                           <a:ea typeface="IBM Plex Sans KR" pitchFamily="34" charset="-122"/>
                           <a:cs typeface="IBM Plex Sans KR" pitchFamily="34" charset="-120"/>
                         </a:rPr>
-                        <a:t>(9%)</a:t>
+                        <a:t>(13%)</a:t>
                       </a:r>
                       <a:endParaRPr lang="en-US" sz="900" dirty="0">
                         <a:latin typeface="IBM Plex Sans KR" charset="0"/>
@@ -8990,7 +8990,7 @@
                       <a:tailEnd type="none" w="med" len="med"/>
                     </a:lnB>
                     <a:solidFill>
-                      <a:srgbClr val="FFFFFF"/>
+                      <a:srgbClr val="E8F3EC"/>
                     </a:solidFill>
                   </a:tcPr>
                 </a:tc>
@@ -9017,1578 +9017,6 @@
                         <a:latin typeface="IBM Plex Mono" charset="0"/>
                         <a:ea typeface="IBM Plex Mono" charset="0"/>
                         <a:cs typeface="IBM Plex Mono" charset="0"/>
-                      </a:endParaRPr>
-                    </a:p>
-                  </a:txBody>
-                  <a:tcPr marL="63500" marR="63500" marT="25400" marB="25400" anchor="ctr">
-                    <a:lnL w="6350" cap="flat" cmpd="sng" algn="ctr">
-                      <a:solidFill>
-                        <a:srgbClr val="E4DED4"/>
-                      </a:solidFill>
-                      <a:prstDash val="solid"/>
-                      <a:round/>
-                      <a:headEnd type="none" w="med" len="med"/>
-                      <a:tailEnd type="none" w="med" len="med"/>
-                    </a:lnL>
-                    <a:lnR w="6350" cap="flat" cmpd="sng" algn="ctr">
-                      <a:solidFill>
-                        <a:srgbClr val="E4DED4"/>
-                      </a:solidFill>
-                      <a:prstDash val="solid"/>
-                      <a:round/>
-                      <a:headEnd type="none" w="med" len="med"/>
-                      <a:tailEnd type="none" w="med" len="med"/>
-                    </a:lnR>
-                    <a:lnT w="6350" cap="flat" cmpd="sng" algn="ctr">
-                      <a:solidFill>
-                        <a:srgbClr val="E4DED4"/>
-                      </a:solidFill>
-                      <a:prstDash val="solid"/>
-                      <a:round/>
-                      <a:headEnd type="none" w="med" len="med"/>
-                      <a:tailEnd type="none" w="med" len="med"/>
-                    </a:lnT>
-                    <a:lnB w="6350" cap="flat" cmpd="sng" algn="ctr">
-                      <a:solidFill>
-                        <a:srgbClr val="E4DED4"/>
-                      </a:solidFill>
-                      <a:prstDash val="solid"/>
-                      <a:round/>
-                      <a:headEnd type="none" w="med" len="med"/>
-                      <a:tailEnd type="none" w="med" len="med"/>
-                    </a:lnB>
-                    <a:solidFill>
-                      <a:srgbClr val="FFFFFF"/>
-                    </a:solidFill>
-                  </a:tcPr>
-                </a:tc>
-                <a:tc>
-                  <a:txBody>
-                    <a:bodyPr/>
-                    <a:lstStyle/>
-                    <a:p>
-                      <a:pPr algn="ctr" indent="0" marL="0">
-                        <a:buNone/>
-                      </a:pPr>
-                      <a:r>
-                        <a:rPr lang="en-US" sz="950" dirty="0">
-                          <a:solidFill>
-                            <a:srgbClr val="1B1714"/>
-                          </a:solidFill>
-                          <a:latin typeface="IBM Plex Mono" pitchFamily="34" charset="0"/>
-                          <a:ea typeface="IBM Plex Mono" pitchFamily="34" charset="-122"/>
-                          <a:cs typeface="IBM Plex Mono" pitchFamily="34" charset="-120"/>
-                        </a:rPr>
-                        <a:t>20%</a:t>
-                      </a:r>
-                      <a:endParaRPr lang="en-US" sz="950" dirty="0">
-                        <a:latin typeface="IBM Plex Mono" charset="0"/>
-                        <a:ea typeface="IBM Plex Mono" charset="0"/>
-                        <a:cs typeface="IBM Plex Mono" charset="0"/>
-                      </a:endParaRPr>
-                    </a:p>
-                  </a:txBody>
-                  <a:tcPr marL="63500" marR="63500" marT="25400" marB="25400" anchor="ctr">
-                    <a:lnL w="6350" cap="flat" cmpd="sng" algn="ctr">
-                      <a:solidFill>
-                        <a:srgbClr val="E4DED4"/>
-                      </a:solidFill>
-                      <a:prstDash val="solid"/>
-                      <a:round/>
-                      <a:headEnd type="none" w="med" len="med"/>
-                      <a:tailEnd type="none" w="med" len="med"/>
-                    </a:lnL>
-                    <a:lnR w="6350" cap="flat" cmpd="sng" algn="ctr">
-                      <a:solidFill>
-                        <a:srgbClr val="E4DED4"/>
-                      </a:solidFill>
-                      <a:prstDash val="solid"/>
-                      <a:round/>
-                      <a:headEnd type="none" w="med" len="med"/>
-                      <a:tailEnd type="none" w="med" len="med"/>
-                    </a:lnR>
-                    <a:lnT w="6350" cap="flat" cmpd="sng" algn="ctr">
-                      <a:solidFill>
-                        <a:srgbClr val="E4DED4"/>
-                      </a:solidFill>
-                      <a:prstDash val="solid"/>
-                      <a:round/>
-                      <a:headEnd type="none" w="med" len="med"/>
-                      <a:tailEnd type="none" w="med" len="med"/>
-                    </a:lnT>
-                    <a:lnB w="6350" cap="flat" cmpd="sng" algn="ctr">
-                      <a:solidFill>
-                        <a:srgbClr val="E4DED4"/>
-                      </a:solidFill>
-                      <a:prstDash val="solid"/>
-                      <a:round/>
-                      <a:headEnd type="none" w="med" len="med"/>
-                      <a:tailEnd type="none" w="med" len="med"/>
-                    </a:lnB>
-                    <a:solidFill>
-                      <a:srgbClr val="FFFFFF"/>
-                    </a:solidFill>
-                  </a:tcPr>
-                </a:tc>
-                <a:tc>
-                  <a:txBody>
-                    <a:bodyPr/>
-                    <a:lstStyle/>
-                    <a:p>
-                      <a:pPr algn="ctr" indent="0" marL="0">
-                        <a:buNone/>
-                      </a:pPr>
-                      <a:r>
-                        <a:rPr lang="en-US" sz="950" dirty="0">
-                          <a:solidFill>
-                            <a:srgbClr val="1B1714"/>
-                          </a:solidFill>
-                          <a:latin typeface="IBM Plex Mono" pitchFamily="34" charset="0"/>
-                          <a:ea typeface="IBM Plex Mono" pitchFamily="34" charset="-122"/>
-                          <a:cs typeface="IBM Plex Mono" pitchFamily="34" charset="-120"/>
-                        </a:rPr>
-                        <a:t>$8.5bn</a:t>
-                      </a:r>
-                      <a:endParaRPr lang="en-US" sz="950" dirty="0">
-                        <a:latin typeface="IBM Plex Mono" charset="0"/>
-                        <a:ea typeface="IBM Plex Mono" charset="0"/>
-                        <a:cs typeface="IBM Plex Mono" charset="0"/>
-                      </a:endParaRPr>
-                    </a:p>
-                  </a:txBody>
-                  <a:tcPr marL="63500" marR="63500" marT="25400" marB="25400" anchor="ctr">
-                    <a:lnL w="6350" cap="flat" cmpd="sng" algn="ctr">
-                      <a:solidFill>
-                        <a:srgbClr val="E4DED4"/>
-                      </a:solidFill>
-                      <a:prstDash val="solid"/>
-                      <a:round/>
-                      <a:headEnd type="none" w="med" len="med"/>
-                      <a:tailEnd type="none" w="med" len="med"/>
-                    </a:lnL>
-                    <a:lnR w="6350" cap="flat" cmpd="sng" algn="ctr">
-                      <a:solidFill>
-                        <a:srgbClr val="E4DED4"/>
-                      </a:solidFill>
-                      <a:prstDash val="solid"/>
-                      <a:round/>
-                      <a:headEnd type="none" w="med" len="med"/>
-                      <a:tailEnd type="none" w="med" len="med"/>
-                    </a:lnR>
-                    <a:lnT w="6350" cap="flat" cmpd="sng" algn="ctr">
-                      <a:solidFill>
-                        <a:srgbClr val="E4DED4"/>
-                      </a:solidFill>
-                      <a:prstDash val="solid"/>
-                      <a:round/>
-                      <a:headEnd type="none" w="med" len="med"/>
-                      <a:tailEnd type="none" w="med" len="med"/>
-                    </a:lnT>
-                    <a:lnB w="6350" cap="flat" cmpd="sng" algn="ctr">
-                      <a:solidFill>
-                        <a:srgbClr val="E4DED4"/>
-                      </a:solidFill>
-                      <a:prstDash val="solid"/>
-                      <a:round/>
-                      <a:headEnd type="none" w="med" len="med"/>
-                      <a:tailEnd type="none" w="med" len="med"/>
-                    </a:lnB>
-                    <a:solidFill>
-                      <a:srgbClr val="FFFFFF"/>
-                    </a:solidFill>
-                  </a:tcPr>
-                </a:tc>
-                <a:tc>
-                  <a:txBody>
-                    <a:bodyPr/>
-                    <a:lstStyle/>
-                    <a:p>
-                      <a:pPr algn="ctr" indent="0" marL="0">
-                        <a:buNone/>
-                      </a:pPr>
-                      <a:r>
-                        <a:rPr lang="en-US" sz="1200" b="1" dirty="0">
-                          <a:solidFill>
-                            <a:srgbClr val="C1121F"/>
-                          </a:solidFill>
-                          <a:latin typeface="Space Grotesk" pitchFamily="34" charset="0"/>
-                          <a:ea typeface="Space Grotesk" pitchFamily="34" charset="-122"/>
-                          <a:cs typeface="Space Grotesk" pitchFamily="34" charset="-120"/>
-                        </a:rPr>
-                        <a:t>16.5x</a:t>
-                      </a:r>
-                      <a:endParaRPr lang="en-US" sz="1200" dirty="0">
-                        <a:latin typeface="Space Grotesk" charset="0"/>
-                        <a:ea typeface="Space Grotesk" charset="0"/>
-                        <a:cs typeface="Space Grotesk" charset="0"/>
-                      </a:endParaRPr>
-                    </a:p>
-                  </a:txBody>
-                  <a:tcPr marL="63500" marR="63500" marT="25400" marB="25400" anchor="ctr">
-                    <a:lnL w="6350" cap="flat" cmpd="sng" algn="ctr">
-                      <a:solidFill>
-                        <a:srgbClr val="E4DED4"/>
-                      </a:solidFill>
-                      <a:prstDash val="solid"/>
-                      <a:round/>
-                      <a:headEnd type="none" w="med" len="med"/>
-                      <a:tailEnd type="none" w="med" len="med"/>
-                    </a:lnL>
-                    <a:lnR w="6350" cap="flat" cmpd="sng" algn="ctr">
-                      <a:solidFill>
-                        <a:srgbClr val="E4DED4"/>
-                      </a:solidFill>
-                      <a:prstDash val="solid"/>
-                      <a:round/>
-                      <a:headEnd type="none" w="med" len="med"/>
-                      <a:tailEnd type="none" w="med" len="med"/>
-                    </a:lnR>
-                    <a:lnT w="6350" cap="flat" cmpd="sng" algn="ctr">
-                      <a:solidFill>
-                        <a:srgbClr val="E4DED4"/>
-                      </a:solidFill>
-                      <a:prstDash val="solid"/>
-                      <a:round/>
-                      <a:headEnd type="none" w="med" len="med"/>
-                      <a:tailEnd type="none" w="med" len="med"/>
-                    </a:lnT>
-                    <a:lnB w="6350" cap="flat" cmpd="sng" algn="ctr">
-                      <a:solidFill>
-                        <a:srgbClr val="E4DED4"/>
-                      </a:solidFill>
-                      <a:prstDash val="solid"/>
-                      <a:round/>
-                      <a:headEnd type="none" w="med" len="med"/>
-                      <a:tailEnd type="none" w="med" len="med"/>
-                    </a:lnB>
-                    <a:solidFill>
-                      <a:srgbClr val="FFFFFF"/>
-                    </a:solidFill>
-                  </a:tcPr>
-                </a:tc>
-                <a:tc>
-                  <a:txBody>
-                    <a:bodyPr/>
-                    <a:lstStyle/>
-                    <a:p>
-                      <a:pPr algn="ctr" indent="0" marL="0">
-                        <a:buNone/>
-                      </a:pPr>
-                      <a:r>
-                        <a:rPr lang="en-US" sz="800" b="1" dirty="0">
-                          <a:solidFill>
-                            <a:srgbClr val="C1121F"/>
-                          </a:solidFill>
-                          <a:latin typeface="IBM Plex Mono" pitchFamily="34" charset="0"/>
-                          <a:ea typeface="IBM Plex Mono" pitchFamily="34" charset="-122"/>
-                          <a:cs typeface="IBM Plex Mono" pitchFamily="34" charset="-120"/>
-                        </a:rPr>
-                        <a:t>11.4%</a:t>
-                      </a:r>
-                      <a:endParaRPr lang="en-US" sz="800" dirty="0">
-                        <a:latin typeface="IBM Plex Mono" charset="0"/>
-                        <a:ea typeface="IBM Plex Mono" charset="0"/>
-                        <a:cs typeface="IBM Plex Mono" charset="0"/>
-                      </a:endParaRPr>
-                    </a:p>
-                  </a:txBody>
-                  <a:tcPr marL="63500" marR="63500" marT="25400" marB="25400" anchor="ctr">
-                    <a:lnL w="6350" cap="flat" cmpd="sng" algn="ctr">
-                      <a:solidFill>
-                        <a:srgbClr val="E4DED4"/>
-                      </a:solidFill>
-                      <a:prstDash val="solid"/>
-                      <a:round/>
-                      <a:headEnd type="none" w="med" len="med"/>
-                      <a:tailEnd type="none" w="med" len="med"/>
-                    </a:lnL>
-                    <a:lnR w="6350" cap="flat" cmpd="sng" algn="ctr">
-                      <a:solidFill>
-                        <a:srgbClr val="E4DED4"/>
-                      </a:solidFill>
-                      <a:prstDash val="solid"/>
-                      <a:round/>
-                      <a:headEnd type="none" w="med" len="med"/>
-                      <a:tailEnd type="none" w="med" len="med"/>
-                    </a:lnR>
-                    <a:lnT w="6350" cap="flat" cmpd="sng" algn="ctr">
-                      <a:solidFill>
-                        <a:srgbClr val="E4DED4"/>
-                      </a:solidFill>
-                      <a:prstDash val="solid"/>
-                      <a:round/>
-                      <a:headEnd type="none" w="med" len="med"/>
-                      <a:tailEnd type="none" w="med" len="med"/>
-                    </a:lnT>
-                    <a:lnB w="6350" cap="flat" cmpd="sng" algn="ctr">
-                      <a:solidFill>
-                        <a:srgbClr val="E4DED4"/>
-                      </a:solidFill>
-                      <a:prstDash val="solid"/>
-                      <a:round/>
-                      <a:headEnd type="none" w="med" len="med"/>
-                      <a:tailEnd type="none" w="med" len="med"/>
-                    </a:lnB>
-                    <a:solidFill>
-                      <a:srgbClr val="FFFFFF"/>
-                    </a:solidFill>
-                  </a:tcPr>
-                </a:tc>
-              </a:tr>
-              <a:tr h="402336">
-                <a:tc>
-                  <a:txBody>
-                    <a:bodyPr/>
-                    <a:lstStyle/>
-                    <a:p>
-                      <a:pPr indent="0" marL="0">
-                        <a:buNone/>
-                      </a:pPr>
-                      <a:r>
-                        <a:rPr lang="en-US" sz="950" dirty="0">
-                          <a:solidFill>
-                            <a:srgbClr val="1B1714"/>
-                          </a:solidFill>
-                          <a:latin typeface="IBM Plex Sans KR" pitchFamily="34" charset="0"/>
-                          <a:ea typeface="IBM Plex Sans KR" pitchFamily="34" charset="-122"/>
-                          <a:cs typeface="IBM Plex Sans KR" pitchFamily="34" charset="-120"/>
-                        </a:rPr>
-                        <a:t>① CoC 20% + 그랜트 20%</a:t>
-                      </a:r>
-                      <a:endParaRPr lang="en-US" sz="950" dirty="0">
-                        <a:latin typeface="IBM Plex Sans KR" charset="0"/>
-                        <a:ea typeface="IBM Plex Sans KR" charset="0"/>
-                        <a:cs typeface="IBM Plex Sans KR" charset="0"/>
-                      </a:endParaRPr>
-                    </a:p>
-                  </a:txBody>
-                  <a:tcPr marL="63500" marR="63500" marT="25400" marB="25400" anchor="ctr">
-                    <a:lnL w="6350" cap="flat" cmpd="sng" algn="ctr">
-                      <a:solidFill>
-                        <a:srgbClr val="E4DED4"/>
-                      </a:solidFill>
-                      <a:prstDash val="solid"/>
-                      <a:round/>
-                      <a:headEnd type="none" w="med" len="med"/>
-                      <a:tailEnd type="none" w="med" len="med"/>
-                    </a:lnL>
-                    <a:lnR w="6350" cap="flat" cmpd="sng" algn="ctr">
-                      <a:solidFill>
-                        <a:srgbClr val="E4DED4"/>
-                      </a:solidFill>
-                      <a:prstDash val="solid"/>
-                      <a:round/>
-                      <a:headEnd type="none" w="med" len="med"/>
-                      <a:tailEnd type="none" w="med" len="med"/>
-                    </a:lnR>
-                    <a:lnT w="6350" cap="flat" cmpd="sng" algn="ctr">
-                      <a:solidFill>
-                        <a:srgbClr val="E4DED4"/>
-                      </a:solidFill>
-                      <a:prstDash val="solid"/>
-                      <a:round/>
-                      <a:headEnd type="none" w="med" len="med"/>
-                      <a:tailEnd type="none" w="med" len="med"/>
-                    </a:lnT>
-                    <a:lnB w="6350" cap="flat" cmpd="sng" algn="ctr">
-                      <a:solidFill>
-                        <a:srgbClr val="E4DED4"/>
-                      </a:solidFill>
-                      <a:prstDash val="solid"/>
-                      <a:round/>
-                      <a:headEnd type="none" w="med" len="med"/>
-                      <a:tailEnd type="none" w="med" len="med"/>
-                    </a:lnB>
-                    <a:solidFill>
-                      <a:srgbClr val="FFFFFF"/>
-                    </a:solidFill>
-                  </a:tcPr>
-                </a:tc>
-                <a:tc>
-                  <a:txBody>
-                    <a:bodyPr/>
-                    <a:lstStyle/>
-                    <a:p>
-                      <a:pPr algn="ctr" indent="0" marL="0">
-                        <a:buNone/>
-                      </a:pPr>
-                      <a:r>
-                        <a:rPr lang="en-US" sz="950" dirty="0">
-                          <a:solidFill>
-                            <a:srgbClr val="1B1714"/>
-                          </a:solidFill>
-                          <a:latin typeface="IBM Plex Mono" pitchFamily="34" charset="0"/>
-                          <a:ea typeface="IBM Plex Mono" pitchFamily="34" charset="-122"/>
-                          <a:cs typeface="IBM Plex Mono" pitchFamily="34" charset="-120"/>
-                        </a:rPr>
-                        <a:t>20%</a:t>
-                      </a:r>
-                      <a:endParaRPr lang="en-US" sz="950" dirty="0">
-                        <a:latin typeface="IBM Plex Mono" charset="0"/>
-                        <a:ea typeface="IBM Plex Mono" charset="0"/>
-                        <a:cs typeface="IBM Plex Mono" charset="0"/>
-                      </a:endParaRPr>
-                    </a:p>
-                  </a:txBody>
-                  <a:tcPr marL="63500" marR="63500" marT="25400" marB="25400" anchor="ctr">
-                    <a:lnL w="6350" cap="flat" cmpd="sng" algn="ctr">
-                      <a:solidFill>
-                        <a:srgbClr val="E4DED4"/>
-                      </a:solidFill>
-                      <a:prstDash val="solid"/>
-                      <a:round/>
-                      <a:headEnd type="none" w="med" len="med"/>
-                      <a:tailEnd type="none" w="med" len="med"/>
-                    </a:lnL>
-                    <a:lnR w="6350" cap="flat" cmpd="sng" algn="ctr">
-                      <a:solidFill>
-                        <a:srgbClr val="E4DED4"/>
-                      </a:solidFill>
-                      <a:prstDash val="solid"/>
-                      <a:round/>
-                      <a:headEnd type="none" w="med" len="med"/>
-                      <a:tailEnd type="none" w="med" len="med"/>
-                    </a:lnR>
-                    <a:lnT w="6350" cap="flat" cmpd="sng" algn="ctr">
-                      <a:solidFill>
-                        <a:srgbClr val="E4DED4"/>
-                      </a:solidFill>
-                      <a:prstDash val="solid"/>
-                      <a:round/>
-                      <a:headEnd type="none" w="med" len="med"/>
-                      <a:tailEnd type="none" w="med" len="med"/>
-                    </a:lnT>
-                    <a:lnB w="6350" cap="flat" cmpd="sng" algn="ctr">
-                      <a:solidFill>
-                        <a:srgbClr val="E4DED4"/>
-                      </a:solidFill>
-                      <a:prstDash val="solid"/>
-                      <a:round/>
-                      <a:headEnd type="none" w="med" len="med"/>
-                      <a:tailEnd type="none" w="med" len="med"/>
-                    </a:lnB>
-                    <a:solidFill>
-                      <a:srgbClr val="FFFFFF"/>
-                    </a:solidFill>
-                  </a:tcPr>
-                </a:tc>
-                <a:tc>
-                  <a:txBody>
-                    <a:bodyPr/>
-                    <a:lstStyle/>
-                    <a:p>
-                      <a:pPr algn="ctr" indent="0" marL="0">
-                        <a:buNone/>
-                      </a:pPr>
-                      <a:r>
-                        <a:rPr lang="en-US" sz="950" dirty="0">
-                          <a:solidFill>
-                            <a:srgbClr val="1B1714"/>
-                          </a:solidFill>
-                          <a:latin typeface="IBM Plex Mono" pitchFamily="34" charset="0"/>
-                          <a:ea typeface="IBM Plex Mono" pitchFamily="34" charset="-122"/>
-                          <a:cs typeface="IBM Plex Mono" pitchFamily="34" charset="-120"/>
-                        </a:rPr>
-                        <a:t>20%</a:t>
-                      </a:r>
-                      <a:endParaRPr lang="en-US" sz="950" dirty="0">
-                        <a:latin typeface="IBM Plex Mono" charset="0"/>
-                        <a:ea typeface="IBM Plex Mono" charset="0"/>
-                        <a:cs typeface="IBM Plex Mono" charset="0"/>
-                      </a:endParaRPr>
-                    </a:p>
-                  </a:txBody>
-                  <a:tcPr marL="63500" marR="63500" marT="25400" marB="25400" anchor="ctr">
-                    <a:lnL w="6350" cap="flat" cmpd="sng" algn="ctr">
-                      <a:solidFill>
-                        <a:srgbClr val="E4DED4"/>
-                      </a:solidFill>
-                      <a:prstDash val="solid"/>
-                      <a:round/>
-                      <a:headEnd type="none" w="med" len="med"/>
-                      <a:tailEnd type="none" w="med" len="med"/>
-                    </a:lnL>
-                    <a:lnR w="6350" cap="flat" cmpd="sng" algn="ctr">
-                      <a:solidFill>
-                        <a:srgbClr val="E4DED4"/>
-                      </a:solidFill>
-                      <a:prstDash val="solid"/>
-                      <a:round/>
-                      <a:headEnd type="none" w="med" len="med"/>
-                      <a:tailEnd type="none" w="med" len="med"/>
-                    </a:lnR>
-                    <a:lnT w="6350" cap="flat" cmpd="sng" algn="ctr">
-                      <a:solidFill>
-                        <a:srgbClr val="E4DED4"/>
-                      </a:solidFill>
-                      <a:prstDash val="solid"/>
-                      <a:round/>
-                      <a:headEnd type="none" w="med" len="med"/>
-                      <a:tailEnd type="none" w="med" len="med"/>
-                    </a:lnT>
-                    <a:lnB w="6350" cap="flat" cmpd="sng" algn="ctr">
-                      <a:solidFill>
-                        <a:srgbClr val="E4DED4"/>
-                      </a:solidFill>
-                      <a:prstDash val="solid"/>
-                      <a:round/>
-                      <a:headEnd type="none" w="med" len="med"/>
-                      <a:tailEnd type="none" w="med" len="med"/>
-                    </a:lnB>
-                    <a:solidFill>
-                      <a:srgbClr val="FFFFFF"/>
-                    </a:solidFill>
-                  </a:tcPr>
-                </a:tc>
-                <a:tc>
-                  <a:txBody>
-                    <a:bodyPr/>
-                    <a:lstStyle/>
-                    <a:p>
-                      <a:pPr algn="ctr" indent="0" marL="0">
-                        <a:buNone/>
-                      </a:pPr>
-                      <a:r>
-                        <a:rPr lang="en-US" sz="950" dirty="0">
-                          <a:solidFill>
-                            <a:srgbClr val="1B1714"/>
-                          </a:solidFill>
-                          <a:latin typeface="IBM Plex Mono" pitchFamily="34" charset="0"/>
-                          <a:ea typeface="IBM Plex Mono" pitchFamily="34" charset="-122"/>
-                          <a:cs typeface="IBM Plex Mono" pitchFamily="34" charset="-120"/>
-                        </a:rPr>
-                        <a:t>$7.8bn</a:t>
-                      </a:r>
-                      <a:endParaRPr lang="en-US" sz="950" dirty="0">
-                        <a:latin typeface="IBM Plex Mono" charset="0"/>
-                        <a:ea typeface="IBM Plex Mono" charset="0"/>
-                        <a:cs typeface="IBM Plex Mono" charset="0"/>
-                      </a:endParaRPr>
-                    </a:p>
-                  </a:txBody>
-                  <a:tcPr marL="63500" marR="63500" marT="25400" marB="25400" anchor="ctr">
-                    <a:lnL w="6350" cap="flat" cmpd="sng" algn="ctr">
-                      <a:solidFill>
-                        <a:srgbClr val="E4DED4"/>
-                      </a:solidFill>
-                      <a:prstDash val="solid"/>
-                      <a:round/>
-                      <a:headEnd type="none" w="med" len="med"/>
-                      <a:tailEnd type="none" w="med" len="med"/>
-                    </a:lnL>
-                    <a:lnR w="6350" cap="flat" cmpd="sng" algn="ctr">
-                      <a:solidFill>
-                        <a:srgbClr val="E4DED4"/>
-                      </a:solidFill>
-                      <a:prstDash val="solid"/>
-                      <a:round/>
-                      <a:headEnd type="none" w="med" len="med"/>
-                      <a:tailEnd type="none" w="med" len="med"/>
-                    </a:lnR>
-                    <a:lnT w="6350" cap="flat" cmpd="sng" algn="ctr">
-                      <a:solidFill>
-                        <a:srgbClr val="E4DED4"/>
-                      </a:solidFill>
-                      <a:prstDash val="solid"/>
-                      <a:round/>
-                      <a:headEnd type="none" w="med" len="med"/>
-                      <a:tailEnd type="none" w="med" len="med"/>
-                    </a:lnT>
-                    <a:lnB w="6350" cap="flat" cmpd="sng" algn="ctr">
-                      <a:solidFill>
-                        <a:srgbClr val="E4DED4"/>
-                      </a:solidFill>
-                      <a:prstDash val="solid"/>
-                      <a:round/>
-                      <a:headEnd type="none" w="med" len="med"/>
-                      <a:tailEnd type="none" w="med" len="med"/>
-                    </a:lnB>
-                    <a:solidFill>
-                      <a:srgbClr val="FFFFFF"/>
-                    </a:solidFill>
-                  </a:tcPr>
-                </a:tc>
-                <a:tc>
-                  <a:txBody>
-                    <a:bodyPr/>
-                    <a:lstStyle/>
-                    <a:p>
-                      <a:pPr algn="ctr" indent="0" marL="0">
-                        <a:buNone/>
-                      </a:pPr>
-                      <a:r>
-                        <a:rPr lang="en-US" sz="1200" b="1" dirty="0">
-                          <a:solidFill>
-                            <a:srgbClr val="C1121F"/>
-                          </a:solidFill>
-                          <a:latin typeface="Space Grotesk" pitchFamily="34" charset="0"/>
-                          <a:ea typeface="Space Grotesk" pitchFamily="34" charset="-122"/>
-                          <a:cs typeface="Space Grotesk" pitchFamily="34" charset="-120"/>
-                        </a:rPr>
-                        <a:t>15.1x</a:t>
-                      </a:r>
-                      <a:endParaRPr lang="en-US" sz="1200" dirty="0">
-                        <a:latin typeface="Space Grotesk" charset="0"/>
-                        <a:ea typeface="Space Grotesk" charset="0"/>
-                        <a:cs typeface="Space Grotesk" charset="0"/>
-                      </a:endParaRPr>
-                    </a:p>
-                  </a:txBody>
-                  <a:tcPr marL="63500" marR="63500" marT="25400" marB="25400" anchor="ctr">
-                    <a:lnL w="6350" cap="flat" cmpd="sng" algn="ctr">
-                      <a:solidFill>
-                        <a:srgbClr val="E4DED4"/>
-                      </a:solidFill>
-                      <a:prstDash val="solid"/>
-                      <a:round/>
-                      <a:headEnd type="none" w="med" len="med"/>
-                      <a:tailEnd type="none" w="med" len="med"/>
-                    </a:lnL>
-                    <a:lnR w="6350" cap="flat" cmpd="sng" algn="ctr">
-                      <a:solidFill>
-                        <a:srgbClr val="E4DED4"/>
-                      </a:solidFill>
-                      <a:prstDash val="solid"/>
-                      <a:round/>
-                      <a:headEnd type="none" w="med" len="med"/>
-                      <a:tailEnd type="none" w="med" len="med"/>
-                    </a:lnR>
-                    <a:lnT w="6350" cap="flat" cmpd="sng" algn="ctr">
-                      <a:solidFill>
-                        <a:srgbClr val="E4DED4"/>
-                      </a:solidFill>
-                      <a:prstDash val="solid"/>
-                      <a:round/>
-                      <a:headEnd type="none" w="med" len="med"/>
-                      <a:tailEnd type="none" w="med" len="med"/>
-                    </a:lnT>
-                    <a:lnB w="6350" cap="flat" cmpd="sng" algn="ctr">
-                      <a:solidFill>
-                        <a:srgbClr val="E4DED4"/>
-                      </a:solidFill>
-                      <a:prstDash val="solid"/>
-                      <a:round/>
-                      <a:headEnd type="none" w="med" len="med"/>
-                      <a:tailEnd type="none" w="med" len="med"/>
-                    </a:lnB>
-                    <a:solidFill>
-                      <a:srgbClr val="FFFFFF"/>
-                    </a:solidFill>
-                  </a:tcPr>
-                </a:tc>
-                <a:tc>
-                  <a:txBody>
-                    <a:bodyPr/>
-                    <a:lstStyle/>
-                    <a:p>
-                      <a:pPr algn="ctr" indent="0" marL="0">
-                        <a:buNone/>
-                      </a:pPr>
-                      <a:r>
-                        <a:rPr lang="en-US" sz="800" b="1" dirty="0">
-                          <a:solidFill>
-                            <a:srgbClr val="C1121F"/>
-                          </a:solidFill>
-                          <a:latin typeface="IBM Plex Mono" pitchFamily="34" charset="0"/>
-                          <a:ea typeface="IBM Plex Mono" pitchFamily="34" charset="-122"/>
-                          <a:cs typeface="IBM Plex Mono" pitchFamily="34" charset="-120"/>
-                        </a:rPr>
-                        <a:t>10.5%</a:t>
-                      </a:r>
-                      <a:endParaRPr lang="en-US" sz="800" dirty="0">
-                        <a:latin typeface="IBM Plex Mono" charset="0"/>
-                        <a:ea typeface="IBM Plex Mono" charset="0"/>
-                        <a:cs typeface="IBM Plex Mono" charset="0"/>
-                      </a:endParaRPr>
-                    </a:p>
-                  </a:txBody>
-                  <a:tcPr marL="63500" marR="63500" marT="25400" marB="25400" anchor="ctr">
-                    <a:lnL w="6350" cap="flat" cmpd="sng" algn="ctr">
-                      <a:solidFill>
-                        <a:srgbClr val="E4DED4"/>
-                      </a:solidFill>
-                      <a:prstDash val="solid"/>
-                      <a:round/>
-                      <a:headEnd type="none" w="med" len="med"/>
-                      <a:tailEnd type="none" w="med" len="med"/>
-                    </a:lnL>
-                    <a:lnR w="6350" cap="flat" cmpd="sng" algn="ctr">
-                      <a:solidFill>
-                        <a:srgbClr val="E4DED4"/>
-                      </a:solidFill>
-                      <a:prstDash val="solid"/>
-                      <a:round/>
-                      <a:headEnd type="none" w="med" len="med"/>
-                      <a:tailEnd type="none" w="med" len="med"/>
-                    </a:lnR>
-                    <a:lnT w="6350" cap="flat" cmpd="sng" algn="ctr">
-                      <a:solidFill>
-                        <a:srgbClr val="E4DED4"/>
-                      </a:solidFill>
-                      <a:prstDash val="solid"/>
-                      <a:round/>
-                      <a:headEnd type="none" w="med" len="med"/>
-                      <a:tailEnd type="none" w="med" len="med"/>
-                    </a:lnT>
-                    <a:lnB w="6350" cap="flat" cmpd="sng" algn="ctr">
-                      <a:solidFill>
-                        <a:srgbClr val="E4DED4"/>
-                      </a:solidFill>
-                      <a:prstDash val="solid"/>
-                      <a:round/>
-                      <a:headEnd type="none" w="med" len="med"/>
-                      <a:tailEnd type="none" w="med" len="med"/>
-                    </a:lnB>
-                    <a:solidFill>
-                      <a:srgbClr val="FFFFFF"/>
-                    </a:solidFill>
-                  </a:tcPr>
-                </a:tc>
-              </a:tr>
-              <a:tr h="402336">
-                <a:tc>
-                  <a:txBody>
-                    <a:bodyPr/>
-                    <a:lstStyle/>
-                    <a:p>
-                      <a:pPr indent="0" marL="0">
-                        <a:buNone/>
-                      </a:pPr>
-                      <a:r>
-                        <a:rPr lang="en-US" sz="950" dirty="0">
-                          <a:solidFill>
-                            <a:srgbClr val="1B1714"/>
-                          </a:solidFill>
-                          <a:latin typeface="IBM Plex Sans KR" pitchFamily="34" charset="0"/>
-                          <a:ea typeface="IBM Plex Sans KR" pitchFamily="34" charset="-122"/>
-                          <a:cs typeface="IBM Plex Sans KR" pitchFamily="34" charset="-120"/>
-                        </a:rPr>
-                        <a:t>② CoC 해제 → 희석 30%</a:t>
-                      </a:r>
-                      <a:endParaRPr lang="en-US" sz="950" dirty="0">
-                        <a:latin typeface="IBM Plex Sans KR" charset="0"/>
-                        <a:ea typeface="IBM Plex Sans KR" charset="0"/>
-                        <a:cs typeface="IBM Plex Sans KR" charset="0"/>
-                      </a:endParaRPr>
-                    </a:p>
-                  </a:txBody>
-                  <a:tcPr marL="63500" marR="63500" marT="25400" marB="25400" anchor="ctr">
-                    <a:lnL w="6350" cap="flat" cmpd="sng" algn="ctr">
-                      <a:solidFill>
-                        <a:srgbClr val="E4DED4"/>
-                      </a:solidFill>
-                      <a:prstDash val="solid"/>
-                      <a:round/>
-                      <a:headEnd type="none" w="med" len="med"/>
-                      <a:tailEnd type="none" w="med" len="med"/>
-                    </a:lnL>
-                    <a:lnR w="6350" cap="flat" cmpd="sng" algn="ctr">
-                      <a:solidFill>
-                        <a:srgbClr val="E4DED4"/>
-                      </a:solidFill>
-                      <a:prstDash val="solid"/>
-                      <a:round/>
-                      <a:headEnd type="none" w="med" len="med"/>
-                      <a:tailEnd type="none" w="med" len="med"/>
-                    </a:lnR>
-                    <a:lnT w="6350" cap="flat" cmpd="sng" algn="ctr">
-                      <a:solidFill>
-                        <a:srgbClr val="E4DED4"/>
-                      </a:solidFill>
-                      <a:prstDash val="solid"/>
-                      <a:round/>
-                      <a:headEnd type="none" w="med" len="med"/>
-                      <a:tailEnd type="none" w="med" len="med"/>
-                    </a:lnT>
-                    <a:lnB w="6350" cap="flat" cmpd="sng" algn="ctr">
-                      <a:solidFill>
-                        <a:srgbClr val="E4DED4"/>
-                      </a:solidFill>
-                      <a:prstDash val="solid"/>
-                      <a:round/>
-                      <a:headEnd type="none" w="med" len="med"/>
-                      <a:tailEnd type="none" w="med" len="med"/>
-                    </a:lnB>
-                    <a:solidFill>
-                      <a:srgbClr val="FFFFFF"/>
-                    </a:solidFill>
-                  </a:tcPr>
-                </a:tc>
-                <a:tc>
-                  <a:txBody>
-                    <a:bodyPr/>
-                    <a:lstStyle/>
-                    <a:p>
-                      <a:pPr algn="ctr" indent="0" marL="0">
-                        <a:buNone/>
-                      </a:pPr>
-                      <a:r>
-                        <a:rPr lang="en-US" sz="950" dirty="0">
-                          <a:solidFill>
-                            <a:srgbClr val="1B1714"/>
-                          </a:solidFill>
-                          <a:latin typeface="IBM Plex Mono" pitchFamily="34" charset="0"/>
-                          <a:ea typeface="IBM Plex Mono" pitchFamily="34" charset="-122"/>
-                          <a:cs typeface="IBM Plex Mono" pitchFamily="34" charset="-120"/>
-                        </a:rPr>
-                        <a:t>10%</a:t>
-                      </a:r>
-                      <a:endParaRPr lang="en-US" sz="950" dirty="0">
-                        <a:latin typeface="IBM Plex Mono" charset="0"/>
-                        <a:ea typeface="IBM Plex Mono" charset="0"/>
-                        <a:cs typeface="IBM Plex Mono" charset="0"/>
-                      </a:endParaRPr>
-                    </a:p>
-                  </a:txBody>
-                  <a:tcPr marL="63500" marR="63500" marT="25400" marB="25400" anchor="ctr">
-                    <a:lnL w="6350" cap="flat" cmpd="sng" algn="ctr">
-                      <a:solidFill>
-                        <a:srgbClr val="E4DED4"/>
-                      </a:solidFill>
-                      <a:prstDash val="solid"/>
-                      <a:round/>
-                      <a:headEnd type="none" w="med" len="med"/>
-                      <a:tailEnd type="none" w="med" len="med"/>
-                    </a:lnL>
-                    <a:lnR w="6350" cap="flat" cmpd="sng" algn="ctr">
-                      <a:solidFill>
-                        <a:srgbClr val="E4DED4"/>
-                      </a:solidFill>
-                      <a:prstDash val="solid"/>
-                      <a:round/>
-                      <a:headEnd type="none" w="med" len="med"/>
-                      <a:tailEnd type="none" w="med" len="med"/>
-                    </a:lnR>
-                    <a:lnT w="6350" cap="flat" cmpd="sng" algn="ctr">
-                      <a:solidFill>
-                        <a:srgbClr val="E4DED4"/>
-                      </a:solidFill>
-                      <a:prstDash val="solid"/>
-                      <a:round/>
-                      <a:headEnd type="none" w="med" len="med"/>
-                      <a:tailEnd type="none" w="med" len="med"/>
-                    </a:lnT>
-                    <a:lnB w="6350" cap="flat" cmpd="sng" algn="ctr">
-                      <a:solidFill>
-                        <a:srgbClr val="E4DED4"/>
-                      </a:solidFill>
-                      <a:prstDash val="solid"/>
-                      <a:round/>
-                      <a:headEnd type="none" w="med" len="med"/>
-                      <a:tailEnd type="none" w="med" len="med"/>
-                    </a:lnB>
-                    <a:solidFill>
-                      <a:srgbClr val="FFFFFF"/>
-                    </a:solidFill>
-                  </a:tcPr>
-                </a:tc>
-                <a:tc>
-                  <a:txBody>
-                    <a:bodyPr/>
-                    <a:lstStyle/>
-                    <a:p>
-                      <a:pPr algn="ctr" indent="0" marL="0">
-                        <a:buNone/>
-                      </a:pPr>
-                      <a:r>
-                        <a:rPr lang="en-US" sz="950" dirty="0">
-                          <a:solidFill>
-                            <a:srgbClr val="1B1714"/>
-                          </a:solidFill>
-                          <a:latin typeface="IBM Plex Mono" pitchFamily="34" charset="0"/>
-                          <a:ea typeface="IBM Plex Mono" pitchFamily="34" charset="-122"/>
-                          <a:cs typeface="IBM Plex Mono" pitchFamily="34" charset="-120"/>
-                        </a:rPr>
-                        <a:t>30%</a:t>
-                      </a:r>
-                      <a:endParaRPr lang="en-US" sz="950" dirty="0">
-                        <a:latin typeface="IBM Plex Mono" charset="0"/>
-                        <a:ea typeface="IBM Plex Mono" charset="0"/>
-                        <a:cs typeface="IBM Plex Mono" charset="0"/>
-                      </a:endParaRPr>
-                    </a:p>
-                  </a:txBody>
-                  <a:tcPr marL="63500" marR="63500" marT="25400" marB="25400" anchor="ctr">
-                    <a:lnL w="6350" cap="flat" cmpd="sng" algn="ctr">
-                      <a:solidFill>
-                        <a:srgbClr val="E4DED4"/>
-                      </a:solidFill>
-                      <a:prstDash val="solid"/>
-                      <a:round/>
-                      <a:headEnd type="none" w="med" len="med"/>
-                      <a:tailEnd type="none" w="med" len="med"/>
-                    </a:lnL>
-                    <a:lnR w="6350" cap="flat" cmpd="sng" algn="ctr">
-                      <a:solidFill>
-                        <a:srgbClr val="E4DED4"/>
-                      </a:solidFill>
-                      <a:prstDash val="solid"/>
-                      <a:round/>
-                      <a:headEnd type="none" w="med" len="med"/>
-                      <a:tailEnd type="none" w="med" len="med"/>
-                    </a:lnR>
-                    <a:lnT w="6350" cap="flat" cmpd="sng" algn="ctr">
-                      <a:solidFill>
-                        <a:srgbClr val="E4DED4"/>
-                      </a:solidFill>
-                      <a:prstDash val="solid"/>
-                      <a:round/>
-                      <a:headEnd type="none" w="med" len="med"/>
-                      <a:tailEnd type="none" w="med" len="med"/>
-                    </a:lnT>
-                    <a:lnB w="6350" cap="flat" cmpd="sng" algn="ctr">
-                      <a:solidFill>
-                        <a:srgbClr val="E4DED4"/>
-                      </a:solidFill>
-                      <a:prstDash val="solid"/>
-                      <a:round/>
-                      <a:headEnd type="none" w="med" len="med"/>
-                      <a:tailEnd type="none" w="med" len="med"/>
-                    </a:lnB>
-                    <a:solidFill>
-                      <a:srgbClr val="FFFFFF"/>
-                    </a:solidFill>
-                  </a:tcPr>
-                </a:tc>
-                <a:tc>
-                  <a:txBody>
-                    <a:bodyPr/>
-                    <a:lstStyle/>
-                    <a:p>
-                      <a:pPr algn="ctr" indent="0" marL="0">
-                        <a:buNone/>
-                      </a:pPr>
-                      <a:r>
-                        <a:rPr lang="en-US" sz="950" dirty="0">
-                          <a:solidFill>
-                            <a:srgbClr val="1B1714"/>
-                          </a:solidFill>
-                          <a:latin typeface="IBM Plex Mono" pitchFamily="34" charset="0"/>
-                          <a:ea typeface="IBM Plex Mono" pitchFamily="34" charset="-122"/>
-                          <a:cs typeface="IBM Plex Mono" pitchFamily="34" charset="-120"/>
-                        </a:rPr>
-                        <a:t>$7.8bn</a:t>
-                      </a:r>
-                      <a:endParaRPr lang="en-US" sz="950" dirty="0">
-                        <a:latin typeface="IBM Plex Mono" charset="0"/>
-                        <a:ea typeface="IBM Plex Mono" charset="0"/>
-                        <a:cs typeface="IBM Plex Mono" charset="0"/>
-                      </a:endParaRPr>
-                    </a:p>
-                  </a:txBody>
-                  <a:tcPr marL="63500" marR="63500" marT="25400" marB="25400" anchor="ctr">
-                    <a:lnL w="6350" cap="flat" cmpd="sng" algn="ctr">
-                      <a:solidFill>
-                        <a:srgbClr val="E4DED4"/>
-                      </a:solidFill>
-                      <a:prstDash val="solid"/>
-                      <a:round/>
-                      <a:headEnd type="none" w="med" len="med"/>
-                      <a:tailEnd type="none" w="med" len="med"/>
-                    </a:lnL>
-                    <a:lnR w="6350" cap="flat" cmpd="sng" algn="ctr">
-                      <a:solidFill>
-                        <a:srgbClr val="E4DED4"/>
-                      </a:solidFill>
-                      <a:prstDash val="solid"/>
-                      <a:round/>
-                      <a:headEnd type="none" w="med" len="med"/>
-                      <a:tailEnd type="none" w="med" len="med"/>
-                    </a:lnR>
-                    <a:lnT w="6350" cap="flat" cmpd="sng" algn="ctr">
-                      <a:solidFill>
-                        <a:srgbClr val="E4DED4"/>
-                      </a:solidFill>
-                      <a:prstDash val="solid"/>
-                      <a:round/>
-                      <a:headEnd type="none" w="med" len="med"/>
-                      <a:tailEnd type="none" w="med" len="med"/>
-                    </a:lnT>
-                    <a:lnB w="6350" cap="flat" cmpd="sng" algn="ctr">
-                      <a:solidFill>
-                        <a:srgbClr val="E4DED4"/>
-                      </a:solidFill>
-                      <a:prstDash val="solid"/>
-                      <a:round/>
-                      <a:headEnd type="none" w="med" len="med"/>
-                      <a:tailEnd type="none" w="med" len="med"/>
-                    </a:lnB>
-                    <a:solidFill>
-                      <a:srgbClr val="FFFFFF"/>
-                    </a:solidFill>
-                  </a:tcPr>
-                </a:tc>
-                <a:tc>
-                  <a:txBody>
-                    <a:bodyPr/>
-                    <a:lstStyle/>
-                    <a:p>
-                      <a:pPr algn="ctr" indent="0" marL="0">
-                        <a:buNone/>
-                      </a:pPr>
-                      <a:r>
-                        <a:rPr lang="en-US" sz="1200" b="1" dirty="0">
-                          <a:solidFill>
-                            <a:srgbClr val="C1121F"/>
-                          </a:solidFill>
-                          <a:latin typeface="Space Grotesk" pitchFamily="34" charset="0"/>
-                          <a:ea typeface="Space Grotesk" pitchFamily="34" charset="-122"/>
-                          <a:cs typeface="Space Grotesk" pitchFamily="34" charset="-120"/>
-                        </a:rPr>
-                        <a:t>15.1x</a:t>
-                      </a:r>
-                      <a:endParaRPr lang="en-US" sz="1200" dirty="0">
-                        <a:latin typeface="Space Grotesk" charset="0"/>
-                        <a:ea typeface="Space Grotesk" charset="0"/>
-                        <a:cs typeface="Space Grotesk" charset="0"/>
-                      </a:endParaRPr>
-                    </a:p>
-                  </a:txBody>
-                  <a:tcPr marL="63500" marR="63500" marT="25400" marB="25400" anchor="ctr">
-                    <a:lnL w="6350" cap="flat" cmpd="sng" algn="ctr">
-                      <a:solidFill>
-                        <a:srgbClr val="E4DED4"/>
-                      </a:solidFill>
-                      <a:prstDash val="solid"/>
-                      <a:round/>
-                      <a:headEnd type="none" w="med" len="med"/>
-                      <a:tailEnd type="none" w="med" len="med"/>
-                    </a:lnL>
-                    <a:lnR w="6350" cap="flat" cmpd="sng" algn="ctr">
-                      <a:solidFill>
-                        <a:srgbClr val="E4DED4"/>
-                      </a:solidFill>
-                      <a:prstDash val="solid"/>
-                      <a:round/>
-                      <a:headEnd type="none" w="med" len="med"/>
-                      <a:tailEnd type="none" w="med" len="med"/>
-                    </a:lnR>
-                    <a:lnT w="6350" cap="flat" cmpd="sng" algn="ctr">
-                      <a:solidFill>
-                        <a:srgbClr val="E4DED4"/>
-                      </a:solidFill>
-                      <a:prstDash val="solid"/>
-                      <a:round/>
-                      <a:headEnd type="none" w="med" len="med"/>
-                      <a:tailEnd type="none" w="med" len="med"/>
-                    </a:lnT>
-                    <a:lnB w="6350" cap="flat" cmpd="sng" algn="ctr">
-                      <a:solidFill>
-                        <a:srgbClr val="E4DED4"/>
-                      </a:solidFill>
-                      <a:prstDash val="solid"/>
-                      <a:round/>
-                      <a:headEnd type="none" w="med" len="med"/>
-                      <a:tailEnd type="none" w="med" len="med"/>
-                    </a:lnB>
-                    <a:solidFill>
-                      <a:srgbClr val="FFFFFF"/>
-                    </a:solidFill>
-                  </a:tcPr>
-                </a:tc>
-                <a:tc>
-                  <a:txBody>
-                    <a:bodyPr/>
-                    <a:lstStyle/>
-                    <a:p>
-                      <a:pPr algn="ctr" indent="0" marL="0">
-                        <a:buNone/>
-                      </a:pPr>
-                      <a:r>
-                        <a:rPr lang="en-US" sz="800" b="1" dirty="0">
-                          <a:solidFill>
-                            <a:srgbClr val="C1121F"/>
-                          </a:solidFill>
-                          <a:latin typeface="IBM Plex Mono" pitchFamily="34" charset="0"/>
-                          <a:ea typeface="IBM Plex Mono" pitchFamily="34" charset="-122"/>
-                          <a:cs typeface="IBM Plex Mono" pitchFamily="34" charset="-120"/>
-                        </a:rPr>
-                        <a:t>10.5%</a:t>
-                      </a:r>
-                      <a:endParaRPr lang="en-US" sz="800" dirty="0">
-                        <a:latin typeface="IBM Plex Mono" charset="0"/>
-                        <a:ea typeface="IBM Plex Mono" charset="0"/>
-                        <a:cs typeface="IBM Plex Mono" charset="0"/>
-                      </a:endParaRPr>
-                    </a:p>
-                  </a:txBody>
-                  <a:tcPr marL="63500" marR="63500" marT="25400" marB="25400" anchor="ctr">
-                    <a:lnL w="6350" cap="flat" cmpd="sng" algn="ctr">
-                      <a:solidFill>
-                        <a:srgbClr val="E4DED4"/>
-                      </a:solidFill>
-                      <a:prstDash val="solid"/>
-                      <a:round/>
-                      <a:headEnd type="none" w="med" len="med"/>
-                      <a:tailEnd type="none" w="med" len="med"/>
-                    </a:lnL>
-                    <a:lnR w="6350" cap="flat" cmpd="sng" algn="ctr">
-                      <a:solidFill>
-                        <a:srgbClr val="E4DED4"/>
-                      </a:solidFill>
-                      <a:prstDash val="solid"/>
-                      <a:round/>
-                      <a:headEnd type="none" w="med" len="med"/>
-                      <a:tailEnd type="none" w="med" len="med"/>
-                    </a:lnR>
-                    <a:lnT w="6350" cap="flat" cmpd="sng" algn="ctr">
-                      <a:solidFill>
-                        <a:srgbClr val="E4DED4"/>
-                      </a:solidFill>
-                      <a:prstDash val="solid"/>
-                      <a:round/>
-                      <a:headEnd type="none" w="med" len="med"/>
-                      <a:tailEnd type="none" w="med" len="med"/>
-                    </a:lnT>
-                    <a:lnB w="6350" cap="flat" cmpd="sng" algn="ctr">
-                      <a:solidFill>
-                        <a:srgbClr val="E4DED4"/>
-                      </a:solidFill>
-                      <a:prstDash val="solid"/>
-                      <a:round/>
-                      <a:headEnd type="none" w="med" len="med"/>
-                      <a:tailEnd type="none" w="med" len="med"/>
-                    </a:lnB>
-                    <a:solidFill>
-                      <a:srgbClr val="FFFFFF"/>
-                    </a:solidFill>
-                  </a:tcPr>
-                </a:tc>
-              </a:tr>
-              <a:tr h="402336">
-                <a:tc>
-                  <a:txBody>
-                    <a:bodyPr/>
-                    <a:lstStyle/>
-                    <a:p>
-                      <a:pPr indent="0" marL="0">
-                        <a:buNone/>
-                      </a:pPr>
-                      <a:r>
-                        <a:rPr lang="en-US" sz="950" dirty="0">
-                          <a:solidFill>
-                            <a:srgbClr val="1B1714"/>
-                          </a:solidFill>
-                          <a:latin typeface="IBM Plex Sans KR" pitchFamily="34" charset="0"/>
-                          <a:ea typeface="IBM Plex Sans KR" pitchFamily="34" charset="-122"/>
-                          <a:cs typeface="IBM Plex Sans KR" pitchFamily="34" charset="-120"/>
-                        </a:rPr>
-                        <a:t>③ CoC 완화 → 희석 49%</a:t>
-                      </a:r>
-                      <a:endParaRPr lang="en-US" sz="950" dirty="0">
-                        <a:latin typeface="IBM Plex Sans KR" charset="0"/>
-                        <a:ea typeface="IBM Plex Sans KR" charset="0"/>
-                        <a:cs typeface="IBM Plex Sans KR" charset="0"/>
-                      </a:endParaRPr>
-                    </a:p>
-                  </a:txBody>
-                  <a:tcPr marL="63500" marR="63500" marT="25400" marB="25400" anchor="ctr">
-                    <a:lnL w="6350" cap="flat" cmpd="sng" algn="ctr">
-                      <a:solidFill>
-                        <a:srgbClr val="E4DED4"/>
-                      </a:solidFill>
-                      <a:prstDash val="solid"/>
-                      <a:round/>
-                      <a:headEnd type="none" w="med" len="med"/>
-                      <a:tailEnd type="none" w="med" len="med"/>
-                    </a:lnL>
-                    <a:lnR w="6350" cap="flat" cmpd="sng" algn="ctr">
-                      <a:solidFill>
-                        <a:srgbClr val="E4DED4"/>
-                      </a:solidFill>
-                      <a:prstDash val="solid"/>
-                      <a:round/>
-                      <a:headEnd type="none" w="med" len="med"/>
-                      <a:tailEnd type="none" w="med" len="med"/>
-                    </a:lnR>
-                    <a:lnT w="6350" cap="flat" cmpd="sng" algn="ctr">
-                      <a:solidFill>
-                        <a:srgbClr val="E4DED4"/>
-                      </a:solidFill>
-                      <a:prstDash val="solid"/>
-                      <a:round/>
-                      <a:headEnd type="none" w="med" len="med"/>
-                      <a:tailEnd type="none" w="med" len="med"/>
-                    </a:lnT>
-                    <a:lnB w="6350" cap="flat" cmpd="sng" algn="ctr">
-                      <a:solidFill>
-                        <a:srgbClr val="E4DED4"/>
-                      </a:solidFill>
-                      <a:prstDash val="solid"/>
-                      <a:round/>
-                      <a:headEnd type="none" w="med" len="med"/>
-                      <a:tailEnd type="none" w="med" len="med"/>
-                    </a:lnB>
-                    <a:solidFill>
-                      <a:srgbClr val="FFFFFF"/>
-                    </a:solidFill>
-                  </a:tcPr>
-                </a:tc>
-                <a:tc>
-                  <a:txBody>
-                    <a:bodyPr/>
-                    <a:lstStyle/>
-                    <a:p>
-                      <a:pPr algn="ctr" indent="0" marL="0">
-                        <a:buNone/>
-                      </a:pPr>
-                      <a:r>
-                        <a:rPr lang="en-US" sz="950" dirty="0">
-                          <a:solidFill>
-                            <a:srgbClr val="1B1714"/>
-                          </a:solidFill>
-                          <a:latin typeface="IBM Plex Mono" pitchFamily="34" charset="0"/>
-                          <a:ea typeface="IBM Plex Mono" pitchFamily="34" charset="-122"/>
-                          <a:cs typeface="IBM Plex Mono" pitchFamily="34" charset="-120"/>
-                        </a:rPr>
-                        <a:t>10%</a:t>
-                      </a:r>
-                      <a:endParaRPr lang="en-US" sz="950" dirty="0">
-                        <a:latin typeface="IBM Plex Mono" charset="0"/>
-                        <a:ea typeface="IBM Plex Mono" charset="0"/>
-                        <a:cs typeface="IBM Plex Mono" charset="0"/>
-                      </a:endParaRPr>
-                    </a:p>
-                  </a:txBody>
-                  <a:tcPr marL="63500" marR="63500" marT="25400" marB="25400" anchor="ctr">
-                    <a:lnL w="6350" cap="flat" cmpd="sng" algn="ctr">
-                      <a:solidFill>
-                        <a:srgbClr val="E4DED4"/>
-                      </a:solidFill>
-                      <a:prstDash val="solid"/>
-                      <a:round/>
-                      <a:headEnd type="none" w="med" len="med"/>
-                      <a:tailEnd type="none" w="med" len="med"/>
-                    </a:lnL>
-                    <a:lnR w="6350" cap="flat" cmpd="sng" algn="ctr">
-                      <a:solidFill>
-                        <a:srgbClr val="E4DED4"/>
-                      </a:solidFill>
-                      <a:prstDash val="solid"/>
-                      <a:round/>
-                      <a:headEnd type="none" w="med" len="med"/>
-                      <a:tailEnd type="none" w="med" len="med"/>
-                    </a:lnR>
-                    <a:lnT w="6350" cap="flat" cmpd="sng" algn="ctr">
-                      <a:solidFill>
-                        <a:srgbClr val="E4DED4"/>
-                      </a:solidFill>
-                      <a:prstDash val="solid"/>
-                      <a:round/>
-                      <a:headEnd type="none" w="med" len="med"/>
-                      <a:tailEnd type="none" w="med" len="med"/>
-                    </a:lnT>
-                    <a:lnB w="6350" cap="flat" cmpd="sng" algn="ctr">
-                      <a:solidFill>
-                        <a:srgbClr val="E4DED4"/>
-                      </a:solidFill>
-                      <a:prstDash val="solid"/>
-                      <a:round/>
-                      <a:headEnd type="none" w="med" len="med"/>
-                      <a:tailEnd type="none" w="med" len="med"/>
-                    </a:lnB>
-                    <a:solidFill>
-                      <a:srgbClr val="FFFFFF"/>
-                    </a:solidFill>
-                  </a:tcPr>
-                </a:tc>
-                <a:tc>
-                  <a:txBody>
-                    <a:bodyPr/>
-                    <a:lstStyle/>
-                    <a:p>
-                      <a:pPr algn="ctr" indent="0" marL="0">
-                        <a:buNone/>
-                      </a:pPr>
-                      <a:r>
-                        <a:rPr lang="en-US" sz="950" dirty="0">
-                          <a:solidFill>
-                            <a:srgbClr val="1B1714"/>
-                          </a:solidFill>
-                          <a:latin typeface="IBM Plex Mono" pitchFamily="34" charset="0"/>
-                          <a:ea typeface="IBM Plex Mono" pitchFamily="34" charset="-122"/>
-                          <a:cs typeface="IBM Plex Mono" pitchFamily="34" charset="-120"/>
-                        </a:rPr>
-                        <a:t>49%</a:t>
-                      </a:r>
-                      <a:endParaRPr lang="en-US" sz="950" dirty="0">
-                        <a:latin typeface="IBM Plex Mono" charset="0"/>
-                        <a:ea typeface="IBM Plex Mono" charset="0"/>
-                        <a:cs typeface="IBM Plex Mono" charset="0"/>
-                      </a:endParaRPr>
-                    </a:p>
-                  </a:txBody>
-                  <a:tcPr marL="63500" marR="63500" marT="25400" marB="25400" anchor="ctr">
-                    <a:lnL w="6350" cap="flat" cmpd="sng" algn="ctr">
-                      <a:solidFill>
-                        <a:srgbClr val="E4DED4"/>
-                      </a:solidFill>
-                      <a:prstDash val="solid"/>
-                      <a:round/>
-                      <a:headEnd type="none" w="med" len="med"/>
-                      <a:tailEnd type="none" w="med" len="med"/>
-                    </a:lnL>
-                    <a:lnR w="6350" cap="flat" cmpd="sng" algn="ctr">
-                      <a:solidFill>
-                        <a:srgbClr val="E4DED4"/>
-                      </a:solidFill>
-                      <a:prstDash val="solid"/>
-                      <a:round/>
-                      <a:headEnd type="none" w="med" len="med"/>
-                      <a:tailEnd type="none" w="med" len="med"/>
-                    </a:lnR>
-                    <a:lnT w="6350" cap="flat" cmpd="sng" algn="ctr">
-                      <a:solidFill>
-                        <a:srgbClr val="E4DED4"/>
-                      </a:solidFill>
-                      <a:prstDash val="solid"/>
-                      <a:round/>
-                      <a:headEnd type="none" w="med" len="med"/>
-                      <a:tailEnd type="none" w="med" len="med"/>
-                    </a:lnT>
-                    <a:lnB w="6350" cap="flat" cmpd="sng" algn="ctr">
-                      <a:solidFill>
-                        <a:srgbClr val="E4DED4"/>
-                      </a:solidFill>
-                      <a:prstDash val="solid"/>
-                      <a:round/>
-                      <a:headEnd type="none" w="med" len="med"/>
-                      <a:tailEnd type="none" w="med" len="med"/>
-                    </a:lnB>
-                    <a:solidFill>
-                      <a:srgbClr val="FFFFFF"/>
-                    </a:solidFill>
-                  </a:tcPr>
-                </a:tc>
-                <a:tc>
-                  <a:txBody>
-                    <a:bodyPr/>
-                    <a:lstStyle/>
-                    <a:p>
-                      <a:pPr algn="ctr" indent="0" marL="0">
-                        <a:buNone/>
-                      </a:pPr>
-                      <a:r>
-                        <a:rPr lang="en-US" sz="950" dirty="0">
-                          <a:solidFill>
-                            <a:srgbClr val="1B1714"/>
-                          </a:solidFill>
-                          <a:latin typeface="IBM Plex Mono" pitchFamily="34" charset="0"/>
-                          <a:ea typeface="IBM Plex Mono" pitchFamily="34" charset="-122"/>
-                          <a:cs typeface="IBM Plex Mono" pitchFamily="34" charset="-120"/>
-                        </a:rPr>
-                        <a:t>$7.3bn</a:t>
-                      </a:r>
-                      <a:endParaRPr lang="en-US" sz="950" dirty="0">
-                        <a:latin typeface="IBM Plex Mono" charset="0"/>
-                        <a:ea typeface="IBM Plex Mono" charset="0"/>
-                        <a:cs typeface="IBM Plex Mono" charset="0"/>
-                      </a:endParaRPr>
-                    </a:p>
-                  </a:txBody>
-                  <a:tcPr marL="63500" marR="63500" marT="25400" marB="25400" anchor="ctr">
-                    <a:lnL w="6350" cap="flat" cmpd="sng" algn="ctr">
-                      <a:solidFill>
-                        <a:srgbClr val="E4DED4"/>
-                      </a:solidFill>
-                      <a:prstDash val="solid"/>
-                      <a:round/>
-                      <a:headEnd type="none" w="med" len="med"/>
-                      <a:tailEnd type="none" w="med" len="med"/>
-                    </a:lnL>
-                    <a:lnR w="6350" cap="flat" cmpd="sng" algn="ctr">
-                      <a:solidFill>
-                        <a:srgbClr val="E4DED4"/>
-                      </a:solidFill>
-                      <a:prstDash val="solid"/>
-                      <a:round/>
-                      <a:headEnd type="none" w="med" len="med"/>
-                      <a:tailEnd type="none" w="med" len="med"/>
-                    </a:lnR>
-                    <a:lnT w="6350" cap="flat" cmpd="sng" algn="ctr">
-                      <a:solidFill>
-                        <a:srgbClr val="E4DED4"/>
-                      </a:solidFill>
-                      <a:prstDash val="solid"/>
-                      <a:round/>
-                      <a:headEnd type="none" w="med" len="med"/>
-                      <a:tailEnd type="none" w="med" len="med"/>
-                    </a:lnT>
-                    <a:lnB w="6350" cap="flat" cmpd="sng" algn="ctr">
-                      <a:solidFill>
-                        <a:srgbClr val="E4DED4"/>
-                      </a:solidFill>
-                      <a:prstDash val="solid"/>
-                      <a:round/>
-                      <a:headEnd type="none" w="med" len="med"/>
-                      <a:tailEnd type="none" w="med" len="med"/>
-                    </a:lnB>
-                    <a:solidFill>
-                      <a:srgbClr val="FFFFFF"/>
-                    </a:solidFill>
-                  </a:tcPr>
-                </a:tc>
-                <a:tc>
-                  <a:txBody>
-                    <a:bodyPr/>
-                    <a:lstStyle/>
-                    <a:p>
-                      <a:pPr algn="ctr" indent="0" marL="0">
-                        <a:buNone/>
-                      </a:pPr>
-                      <a:r>
-                        <a:rPr lang="en-US" sz="1200" b="1" dirty="0">
-                          <a:solidFill>
-                            <a:srgbClr val="C1121F"/>
-                          </a:solidFill>
-                          <a:latin typeface="Space Grotesk" pitchFamily="34" charset="0"/>
-                          <a:ea typeface="Space Grotesk" pitchFamily="34" charset="-122"/>
-                          <a:cs typeface="Space Grotesk" pitchFamily="34" charset="-120"/>
-                        </a:rPr>
-                        <a:t>14.0x</a:t>
-                      </a:r>
-                      <a:endParaRPr lang="en-US" sz="1200" dirty="0">
-                        <a:latin typeface="Space Grotesk" charset="0"/>
-                        <a:ea typeface="Space Grotesk" charset="0"/>
-                        <a:cs typeface="Space Grotesk" charset="0"/>
-                      </a:endParaRPr>
-                    </a:p>
-                  </a:txBody>
-                  <a:tcPr marL="63500" marR="63500" marT="25400" marB="25400" anchor="ctr">
-                    <a:lnL w="6350" cap="flat" cmpd="sng" algn="ctr">
-                      <a:solidFill>
-                        <a:srgbClr val="E4DED4"/>
-                      </a:solidFill>
-                      <a:prstDash val="solid"/>
-                      <a:round/>
-                      <a:headEnd type="none" w="med" len="med"/>
-                      <a:tailEnd type="none" w="med" len="med"/>
-                    </a:lnL>
-                    <a:lnR w="6350" cap="flat" cmpd="sng" algn="ctr">
-                      <a:solidFill>
-                        <a:srgbClr val="E4DED4"/>
-                      </a:solidFill>
-                      <a:prstDash val="solid"/>
-                      <a:round/>
-                      <a:headEnd type="none" w="med" len="med"/>
-                      <a:tailEnd type="none" w="med" len="med"/>
-                    </a:lnR>
-                    <a:lnT w="6350" cap="flat" cmpd="sng" algn="ctr">
-                      <a:solidFill>
-                        <a:srgbClr val="E4DED4"/>
-                      </a:solidFill>
-                      <a:prstDash val="solid"/>
-                      <a:round/>
-                      <a:headEnd type="none" w="med" len="med"/>
-                      <a:tailEnd type="none" w="med" len="med"/>
-                    </a:lnT>
-                    <a:lnB w="6350" cap="flat" cmpd="sng" algn="ctr">
-                      <a:solidFill>
-                        <a:srgbClr val="E4DED4"/>
-                      </a:solidFill>
-                      <a:prstDash val="solid"/>
-                      <a:round/>
-                      <a:headEnd type="none" w="med" len="med"/>
-                      <a:tailEnd type="none" w="med" len="med"/>
-                    </a:lnB>
-                    <a:solidFill>
-                      <a:srgbClr val="FFFFFF"/>
-                    </a:solidFill>
-                  </a:tcPr>
-                </a:tc>
-                <a:tc>
-                  <a:txBody>
-                    <a:bodyPr/>
-                    <a:lstStyle/>
-                    <a:p>
-                      <a:pPr algn="ctr" indent="0" marL="0">
-                        <a:buNone/>
-                      </a:pPr>
-                      <a:r>
-                        <a:rPr lang="en-US" sz="800" b="1" dirty="0">
-                          <a:solidFill>
-                            <a:srgbClr val="C1121F"/>
-                          </a:solidFill>
-                          <a:latin typeface="IBM Plex Mono" pitchFamily="34" charset="0"/>
-                          <a:ea typeface="IBM Plex Mono" pitchFamily="34" charset="-122"/>
-                          <a:cs typeface="IBM Plex Mono" pitchFamily="34" charset="-120"/>
-                        </a:rPr>
-                        <a:t>9.7%</a:t>
-                      </a:r>
-                      <a:endParaRPr lang="en-US" sz="800" dirty="0">
-                        <a:latin typeface="IBM Plex Mono" charset="0"/>
-                        <a:ea typeface="IBM Plex Mono" charset="0"/>
-                        <a:cs typeface="IBM Plex Mono" charset="0"/>
-                      </a:endParaRPr>
-                    </a:p>
-                  </a:txBody>
-                  <a:tcPr marL="63500" marR="63500" marT="25400" marB="25400" anchor="ctr">
-                    <a:lnL w="6350" cap="flat" cmpd="sng" algn="ctr">
-                      <a:solidFill>
-                        <a:srgbClr val="E4DED4"/>
-                      </a:solidFill>
-                      <a:prstDash val="solid"/>
-                      <a:round/>
-                      <a:headEnd type="none" w="med" len="med"/>
-                      <a:tailEnd type="none" w="med" len="med"/>
-                    </a:lnL>
-                    <a:lnR w="6350" cap="flat" cmpd="sng" algn="ctr">
-                      <a:solidFill>
-                        <a:srgbClr val="E4DED4"/>
-                      </a:solidFill>
-                      <a:prstDash val="solid"/>
-                      <a:round/>
-                      <a:headEnd type="none" w="med" len="med"/>
-                      <a:tailEnd type="none" w="med" len="med"/>
-                    </a:lnR>
-                    <a:lnT w="6350" cap="flat" cmpd="sng" algn="ctr">
-                      <a:solidFill>
-                        <a:srgbClr val="E4DED4"/>
-                      </a:solidFill>
-                      <a:prstDash val="solid"/>
-                      <a:round/>
-                      <a:headEnd type="none" w="med" len="med"/>
-                      <a:tailEnd type="none" w="med" len="med"/>
-                    </a:lnT>
-                    <a:lnB w="6350" cap="flat" cmpd="sng" algn="ctr">
-                      <a:solidFill>
-                        <a:srgbClr val="E4DED4"/>
-                      </a:solidFill>
-                      <a:prstDash val="solid"/>
-                      <a:round/>
-                      <a:headEnd type="none" w="med" len="med"/>
-                      <a:tailEnd type="none" w="med" len="med"/>
-                    </a:lnB>
-                    <a:solidFill>
-                      <a:srgbClr val="FFFFFF"/>
-                    </a:solidFill>
-                  </a:tcPr>
-                </a:tc>
-              </a:tr>
-              <a:tr h="402336">
-                <a:tc>
-                  <a:txBody>
-                    <a:bodyPr/>
-                    <a:lstStyle/>
-                    <a:p>
-                      <a:pPr indent="0" marL="0">
-                        <a:buNone/>
-                      </a:pPr>
-                      <a:r>
-                        <a:rPr lang="en-US" sz="950" dirty="0">
-                          <a:solidFill>
-                            <a:srgbClr val="1B1714"/>
-                          </a:solidFill>
-                          <a:latin typeface="IBM Plex Sans KR" pitchFamily="34" charset="0"/>
-                          <a:ea typeface="IBM Plex Sans KR" pitchFamily="34" charset="-122"/>
-                          <a:cs typeface="IBM Plex Sans KR" pitchFamily="34" charset="-120"/>
-                        </a:rPr>
-                        <a:t>최대결합 (그랜트20+희석49)</a:t>
-                      </a:r>
-                      <a:endParaRPr lang="en-US" sz="950" dirty="0">
-                        <a:latin typeface="IBM Plex Sans KR" charset="0"/>
-                        <a:ea typeface="IBM Plex Sans KR" charset="0"/>
-                        <a:cs typeface="IBM Plex Sans KR" charset="0"/>
                       </a:endParaRPr>
                     </a:p>
                   </a:txBody>
@@ -10719,6 +9147,1578 @@
                           <a:ea typeface="IBM Plex Mono" pitchFamily="34" charset="-122"/>
                           <a:cs typeface="IBM Plex Mono" pitchFamily="34" charset="-120"/>
                         </a:rPr>
+                        <a:t>$8.5bn</a:t>
+                      </a:r>
+                      <a:endParaRPr lang="en-US" sz="950" dirty="0">
+                        <a:latin typeface="IBM Plex Mono" charset="0"/>
+                        <a:ea typeface="IBM Plex Mono" charset="0"/>
+                        <a:cs typeface="IBM Plex Mono" charset="0"/>
+                      </a:endParaRPr>
+                    </a:p>
+                  </a:txBody>
+                  <a:tcPr marL="63500" marR="63500" marT="25400" marB="25400" anchor="ctr">
+                    <a:lnL w="6350" cap="flat" cmpd="sng" algn="ctr">
+                      <a:solidFill>
+                        <a:srgbClr val="E4DED4"/>
+                      </a:solidFill>
+                      <a:prstDash val="solid"/>
+                      <a:round/>
+                      <a:headEnd type="none" w="med" len="med"/>
+                      <a:tailEnd type="none" w="med" len="med"/>
+                    </a:lnL>
+                    <a:lnR w="6350" cap="flat" cmpd="sng" algn="ctr">
+                      <a:solidFill>
+                        <a:srgbClr val="E4DED4"/>
+                      </a:solidFill>
+                      <a:prstDash val="solid"/>
+                      <a:round/>
+                      <a:headEnd type="none" w="med" len="med"/>
+                      <a:tailEnd type="none" w="med" len="med"/>
+                    </a:lnR>
+                    <a:lnT w="6350" cap="flat" cmpd="sng" algn="ctr">
+                      <a:solidFill>
+                        <a:srgbClr val="E4DED4"/>
+                      </a:solidFill>
+                      <a:prstDash val="solid"/>
+                      <a:round/>
+                      <a:headEnd type="none" w="med" len="med"/>
+                      <a:tailEnd type="none" w="med" len="med"/>
+                    </a:lnT>
+                    <a:lnB w="6350" cap="flat" cmpd="sng" algn="ctr">
+                      <a:solidFill>
+                        <a:srgbClr val="E4DED4"/>
+                      </a:solidFill>
+                      <a:prstDash val="solid"/>
+                      <a:round/>
+                      <a:headEnd type="none" w="med" len="med"/>
+                      <a:tailEnd type="none" w="med" len="med"/>
+                    </a:lnB>
+                    <a:solidFill>
+                      <a:srgbClr val="E8F3EC"/>
+                    </a:solidFill>
+                  </a:tcPr>
+                </a:tc>
+                <a:tc>
+                  <a:txBody>
+                    <a:bodyPr/>
+                    <a:lstStyle/>
+                    <a:p>
+                      <a:pPr algn="ctr" indent="0" marL="0">
+                        <a:buNone/>
+                      </a:pPr>
+                      <a:r>
+                        <a:rPr lang="en-US" sz="1200" b="1" dirty="0">
+                          <a:solidFill>
+                            <a:srgbClr val="1E7A4D"/>
+                          </a:solidFill>
+                          <a:latin typeface="Space Grotesk" pitchFamily="34" charset="0"/>
+                          <a:ea typeface="Space Grotesk" pitchFamily="34" charset="-122"/>
+                          <a:cs typeface="Space Grotesk" pitchFamily="34" charset="-120"/>
+                        </a:rPr>
+                        <a:t>11.4x</a:t>
+                      </a:r>
+                      <a:endParaRPr lang="en-US" sz="1200" dirty="0">
+                        <a:latin typeface="Space Grotesk" charset="0"/>
+                        <a:ea typeface="Space Grotesk" charset="0"/>
+                        <a:cs typeface="Space Grotesk" charset="0"/>
+                      </a:endParaRPr>
+                    </a:p>
+                  </a:txBody>
+                  <a:tcPr marL="63500" marR="63500" marT="25400" marB="25400" anchor="ctr">
+                    <a:lnL w="6350" cap="flat" cmpd="sng" algn="ctr">
+                      <a:solidFill>
+                        <a:srgbClr val="E4DED4"/>
+                      </a:solidFill>
+                      <a:prstDash val="solid"/>
+                      <a:round/>
+                      <a:headEnd type="none" w="med" len="med"/>
+                      <a:tailEnd type="none" w="med" len="med"/>
+                    </a:lnL>
+                    <a:lnR w="6350" cap="flat" cmpd="sng" algn="ctr">
+                      <a:solidFill>
+                        <a:srgbClr val="E4DED4"/>
+                      </a:solidFill>
+                      <a:prstDash val="solid"/>
+                      <a:round/>
+                      <a:headEnd type="none" w="med" len="med"/>
+                      <a:tailEnd type="none" w="med" len="med"/>
+                    </a:lnR>
+                    <a:lnT w="6350" cap="flat" cmpd="sng" algn="ctr">
+                      <a:solidFill>
+                        <a:srgbClr val="E4DED4"/>
+                      </a:solidFill>
+                      <a:prstDash val="solid"/>
+                      <a:round/>
+                      <a:headEnd type="none" w="med" len="med"/>
+                      <a:tailEnd type="none" w="med" len="med"/>
+                    </a:lnT>
+                    <a:lnB w="6350" cap="flat" cmpd="sng" algn="ctr">
+                      <a:solidFill>
+                        <a:srgbClr val="E4DED4"/>
+                      </a:solidFill>
+                      <a:prstDash val="solid"/>
+                      <a:round/>
+                      <a:headEnd type="none" w="med" len="med"/>
+                      <a:tailEnd type="none" w="med" len="med"/>
+                    </a:lnB>
+                    <a:solidFill>
+                      <a:srgbClr val="E8F3EC"/>
+                    </a:solidFill>
+                  </a:tcPr>
+                </a:tc>
+                <a:tc>
+                  <a:txBody>
+                    <a:bodyPr/>
+                    <a:lstStyle/>
+                    <a:p>
+                      <a:pPr algn="ctr" indent="0" marL="0">
+                        <a:buNone/>
+                      </a:pPr>
+                      <a:r>
+                        <a:rPr lang="en-US" sz="800" b="1" dirty="0">
+                          <a:solidFill>
+                            <a:srgbClr val="6F6960"/>
+                          </a:solidFill>
+                          <a:latin typeface="IBM Plex Mono" pitchFamily="34" charset="0"/>
+                          <a:ea typeface="IBM Plex Mono" pitchFamily="34" charset="-122"/>
+                          <a:cs typeface="IBM Plex Mono" pitchFamily="34" charset="-120"/>
+                        </a:rPr>
+                        <a:t>11.4%</a:t>
+                      </a:r>
+                      <a:endParaRPr lang="en-US" sz="800" dirty="0">
+                        <a:latin typeface="IBM Plex Mono" charset="0"/>
+                        <a:ea typeface="IBM Plex Mono" charset="0"/>
+                        <a:cs typeface="IBM Plex Mono" charset="0"/>
+                      </a:endParaRPr>
+                    </a:p>
+                  </a:txBody>
+                  <a:tcPr marL="63500" marR="63500" marT="25400" marB="25400" anchor="ctr">
+                    <a:lnL w="6350" cap="flat" cmpd="sng" algn="ctr">
+                      <a:solidFill>
+                        <a:srgbClr val="E4DED4"/>
+                      </a:solidFill>
+                      <a:prstDash val="solid"/>
+                      <a:round/>
+                      <a:headEnd type="none" w="med" len="med"/>
+                      <a:tailEnd type="none" w="med" len="med"/>
+                    </a:lnL>
+                    <a:lnR w="6350" cap="flat" cmpd="sng" algn="ctr">
+                      <a:solidFill>
+                        <a:srgbClr val="E4DED4"/>
+                      </a:solidFill>
+                      <a:prstDash val="solid"/>
+                      <a:round/>
+                      <a:headEnd type="none" w="med" len="med"/>
+                      <a:tailEnd type="none" w="med" len="med"/>
+                    </a:lnR>
+                    <a:lnT w="6350" cap="flat" cmpd="sng" algn="ctr">
+                      <a:solidFill>
+                        <a:srgbClr val="E4DED4"/>
+                      </a:solidFill>
+                      <a:prstDash val="solid"/>
+                      <a:round/>
+                      <a:headEnd type="none" w="med" len="med"/>
+                      <a:tailEnd type="none" w="med" len="med"/>
+                    </a:lnT>
+                    <a:lnB w="6350" cap="flat" cmpd="sng" algn="ctr">
+                      <a:solidFill>
+                        <a:srgbClr val="E4DED4"/>
+                      </a:solidFill>
+                      <a:prstDash val="solid"/>
+                      <a:round/>
+                      <a:headEnd type="none" w="med" len="med"/>
+                      <a:tailEnd type="none" w="med" len="med"/>
+                    </a:lnB>
+                    <a:solidFill>
+                      <a:srgbClr val="E8F3EC"/>
+                    </a:solidFill>
+                  </a:tcPr>
+                </a:tc>
+              </a:tr>
+              <a:tr h="402336">
+                <a:tc>
+                  <a:txBody>
+                    <a:bodyPr/>
+                    <a:lstStyle/>
+                    <a:p>
+                      <a:pPr indent="0" marL="0">
+                        <a:buNone/>
+                      </a:pPr>
+                      <a:r>
+                        <a:rPr lang="en-US" sz="950" dirty="0">
+                          <a:solidFill>
+                            <a:srgbClr val="1B1714"/>
+                          </a:solidFill>
+                          <a:latin typeface="IBM Plex Sans KR" pitchFamily="34" charset="0"/>
+                          <a:ea typeface="IBM Plex Sans KR" pitchFamily="34" charset="-122"/>
+                          <a:cs typeface="IBM Plex Sans KR" pitchFamily="34" charset="-120"/>
+                        </a:rPr>
+                        <a:t>① CoC 20% + 그랜트 20%</a:t>
+                      </a:r>
+                      <a:endParaRPr lang="en-US" sz="950" dirty="0">
+                        <a:latin typeface="IBM Plex Sans KR" charset="0"/>
+                        <a:ea typeface="IBM Plex Sans KR" charset="0"/>
+                        <a:cs typeface="IBM Plex Sans KR" charset="0"/>
+                      </a:endParaRPr>
+                    </a:p>
+                  </a:txBody>
+                  <a:tcPr marL="63500" marR="63500" marT="25400" marB="25400" anchor="ctr">
+                    <a:lnL w="6350" cap="flat" cmpd="sng" algn="ctr">
+                      <a:solidFill>
+                        <a:srgbClr val="E4DED4"/>
+                      </a:solidFill>
+                      <a:prstDash val="solid"/>
+                      <a:round/>
+                      <a:headEnd type="none" w="med" len="med"/>
+                      <a:tailEnd type="none" w="med" len="med"/>
+                    </a:lnL>
+                    <a:lnR w="6350" cap="flat" cmpd="sng" algn="ctr">
+                      <a:solidFill>
+                        <a:srgbClr val="E4DED4"/>
+                      </a:solidFill>
+                      <a:prstDash val="solid"/>
+                      <a:round/>
+                      <a:headEnd type="none" w="med" len="med"/>
+                      <a:tailEnd type="none" w="med" len="med"/>
+                    </a:lnR>
+                    <a:lnT w="6350" cap="flat" cmpd="sng" algn="ctr">
+                      <a:solidFill>
+                        <a:srgbClr val="E4DED4"/>
+                      </a:solidFill>
+                      <a:prstDash val="solid"/>
+                      <a:round/>
+                      <a:headEnd type="none" w="med" len="med"/>
+                      <a:tailEnd type="none" w="med" len="med"/>
+                    </a:lnT>
+                    <a:lnB w="6350" cap="flat" cmpd="sng" algn="ctr">
+                      <a:solidFill>
+                        <a:srgbClr val="E4DED4"/>
+                      </a:solidFill>
+                      <a:prstDash val="solid"/>
+                      <a:round/>
+                      <a:headEnd type="none" w="med" len="med"/>
+                      <a:tailEnd type="none" w="med" len="med"/>
+                    </a:lnB>
+                    <a:solidFill>
+                      <a:srgbClr val="E8F3EC"/>
+                    </a:solidFill>
+                  </a:tcPr>
+                </a:tc>
+                <a:tc>
+                  <a:txBody>
+                    <a:bodyPr/>
+                    <a:lstStyle/>
+                    <a:p>
+                      <a:pPr algn="ctr" indent="0" marL="0">
+                        <a:buNone/>
+                      </a:pPr>
+                      <a:r>
+                        <a:rPr lang="en-US" sz="950" dirty="0">
+                          <a:solidFill>
+                            <a:srgbClr val="1B1714"/>
+                          </a:solidFill>
+                          <a:latin typeface="IBM Plex Mono" pitchFamily="34" charset="0"/>
+                          <a:ea typeface="IBM Plex Mono" pitchFamily="34" charset="-122"/>
+                          <a:cs typeface="IBM Plex Mono" pitchFamily="34" charset="-120"/>
+                        </a:rPr>
+                        <a:t>20%</a:t>
+                      </a:r>
+                      <a:endParaRPr lang="en-US" sz="950" dirty="0">
+                        <a:latin typeface="IBM Plex Mono" charset="0"/>
+                        <a:ea typeface="IBM Plex Mono" charset="0"/>
+                        <a:cs typeface="IBM Plex Mono" charset="0"/>
+                      </a:endParaRPr>
+                    </a:p>
+                  </a:txBody>
+                  <a:tcPr marL="63500" marR="63500" marT="25400" marB="25400" anchor="ctr">
+                    <a:lnL w="6350" cap="flat" cmpd="sng" algn="ctr">
+                      <a:solidFill>
+                        <a:srgbClr val="E4DED4"/>
+                      </a:solidFill>
+                      <a:prstDash val="solid"/>
+                      <a:round/>
+                      <a:headEnd type="none" w="med" len="med"/>
+                      <a:tailEnd type="none" w="med" len="med"/>
+                    </a:lnL>
+                    <a:lnR w="6350" cap="flat" cmpd="sng" algn="ctr">
+                      <a:solidFill>
+                        <a:srgbClr val="E4DED4"/>
+                      </a:solidFill>
+                      <a:prstDash val="solid"/>
+                      <a:round/>
+                      <a:headEnd type="none" w="med" len="med"/>
+                      <a:tailEnd type="none" w="med" len="med"/>
+                    </a:lnR>
+                    <a:lnT w="6350" cap="flat" cmpd="sng" algn="ctr">
+                      <a:solidFill>
+                        <a:srgbClr val="E4DED4"/>
+                      </a:solidFill>
+                      <a:prstDash val="solid"/>
+                      <a:round/>
+                      <a:headEnd type="none" w="med" len="med"/>
+                      <a:tailEnd type="none" w="med" len="med"/>
+                    </a:lnT>
+                    <a:lnB w="6350" cap="flat" cmpd="sng" algn="ctr">
+                      <a:solidFill>
+                        <a:srgbClr val="E4DED4"/>
+                      </a:solidFill>
+                      <a:prstDash val="solid"/>
+                      <a:round/>
+                      <a:headEnd type="none" w="med" len="med"/>
+                      <a:tailEnd type="none" w="med" len="med"/>
+                    </a:lnB>
+                    <a:solidFill>
+                      <a:srgbClr val="E8F3EC"/>
+                    </a:solidFill>
+                  </a:tcPr>
+                </a:tc>
+                <a:tc>
+                  <a:txBody>
+                    <a:bodyPr/>
+                    <a:lstStyle/>
+                    <a:p>
+                      <a:pPr algn="ctr" indent="0" marL="0">
+                        <a:buNone/>
+                      </a:pPr>
+                      <a:r>
+                        <a:rPr lang="en-US" sz="950" dirty="0">
+                          <a:solidFill>
+                            <a:srgbClr val="1B1714"/>
+                          </a:solidFill>
+                          <a:latin typeface="IBM Plex Mono" pitchFamily="34" charset="0"/>
+                          <a:ea typeface="IBM Plex Mono" pitchFamily="34" charset="-122"/>
+                          <a:cs typeface="IBM Plex Mono" pitchFamily="34" charset="-120"/>
+                        </a:rPr>
+                        <a:t>20%</a:t>
+                      </a:r>
+                      <a:endParaRPr lang="en-US" sz="950" dirty="0">
+                        <a:latin typeface="IBM Plex Mono" charset="0"/>
+                        <a:ea typeface="IBM Plex Mono" charset="0"/>
+                        <a:cs typeface="IBM Plex Mono" charset="0"/>
+                      </a:endParaRPr>
+                    </a:p>
+                  </a:txBody>
+                  <a:tcPr marL="63500" marR="63500" marT="25400" marB="25400" anchor="ctr">
+                    <a:lnL w="6350" cap="flat" cmpd="sng" algn="ctr">
+                      <a:solidFill>
+                        <a:srgbClr val="E4DED4"/>
+                      </a:solidFill>
+                      <a:prstDash val="solid"/>
+                      <a:round/>
+                      <a:headEnd type="none" w="med" len="med"/>
+                      <a:tailEnd type="none" w="med" len="med"/>
+                    </a:lnL>
+                    <a:lnR w="6350" cap="flat" cmpd="sng" algn="ctr">
+                      <a:solidFill>
+                        <a:srgbClr val="E4DED4"/>
+                      </a:solidFill>
+                      <a:prstDash val="solid"/>
+                      <a:round/>
+                      <a:headEnd type="none" w="med" len="med"/>
+                      <a:tailEnd type="none" w="med" len="med"/>
+                    </a:lnR>
+                    <a:lnT w="6350" cap="flat" cmpd="sng" algn="ctr">
+                      <a:solidFill>
+                        <a:srgbClr val="E4DED4"/>
+                      </a:solidFill>
+                      <a:prstDash val="solid"/>
+                      <a:round/>
+                      <a:headEnd type="none" w="med" len="med"/>
+                      <a:tailEnd type="none" w="med" len="med"/>
+                    </a:lnT>
+                    <a:lnB w="6350" cap="flat" cmpd="sng" algn="ctr">
+                      <a:solidFill>
+                        <a:srgbClr val="E4DED4"/>
+                      </a:solidFill>
+                      <a:prstDash val="solid"/>
+                      <a:round/>
+                      <a:headEnd type="none" w="med" len="med"/>
+                      <a:tailEnd type="none" w="med" len="med"/>
+                    </a:lnB>
+                    <a:solidFill>
+                      <a:srgbClr val="E8F3EC"/>
+                    </a:solidFill>
+                  </a:tcPr>
+                </a:tc>
+                <a:tc>
+                  <a:txBody>
+                    <a:bodyPr/>
+                    <a:lstStyle/>
+                    <a:p>
+                      <a:pPr algn="ctr" indent="0" marL="0">
+                        <a:buNone/>
+                      </a:pPr>
+                      <a:r>
+                        <a:rPr lang="en-US" sz="950" dirty="0">
+                          <a:solidFill>
+                            <a:srgbClr val="1B1714"/>
+                          </a:solidFill>
+                          <a:latin typeface="IBM Plex Mono" pitchFamily="34" charset="0"/>
+                          <a:ea typeface="IBM Plex Mono" pitchFamily="34" charset="-122"/>
+                          <a:cs typeface="IBM Plex Mono" pitchFamily="34" charset="-120"/>
+                        </a:rPr>
+                        <a:t>$7.8bn</a:t>
+                      </a:r>
+                      <a:endParaRPr lang="en-US" sz="950" dirty="0">
+                        <a:latin typeface="IBM Plex Mono" charset="0"/>
+                        <a:ea typeface="IBM Plex Mono" charset="0"/>
+                        <a:cs typeface="IBM Plex Mono" charset="0"/>
+                      </a:endParaRPr>
+                    </a:p>
+                  </a:txBody>
+                  <a:tcPr marL="63500" marR="63500" marT="25400" marB="25400" anchor="ctr">
+                    <a:lnL w="6350" cap="flat" cmpd="sng" algn="ctr">
+                      <a:solidFill>
+                        <a:srgbClr val="E4DED4"/>
+                      </a:solidFill>
+                      <a:prstDash val="solid"/>
+                      <a:round/>
+                      <a:headEnd type="none" w="med" len="med"/>
+                      <a:tailEnd type="none" w="med" len="med"/>
+                    </a:lnL>
+                    <a:lnR w="6350" cap="flat" cmpd="sng" algn="ctr">
+                      <a:solidFill>
+                        <a:srgbClr val="E4DED4"/>
+                      </a:solidFill>
+                      <a:prstDash val="solid"/>
+                      <a:round/>
+                      <a:headEnd type="none" w="med" len="med"/>
+                      <a:tailEnd type="none" w="med" len="med"/>
+                    </a:lnR>
+                    <a:lnT w="6350" cap="flat" cmpd="sng" algn="ctr">
+                      <a:solidFill>
+                        <a:srgbClr val="E4DED4"/>
+                      </a:solidFill>
+                      <a:prstDash val="solid"/>
+                      <a:round/>
+                      <a:headEnd type="none" w="med" len="med"/>
+                      <a:tailEnd type="none" w="med" len="med"/>
+                    </a:lnT>
+                    <a:lnB w="6350" cap="flat" cmpd="sng" algn="ctr">
+                      <a:solidFill>
+                        <a:srgbClr val="E4DED4"/>
+                      </a:solidFill>
+                      <a:prstDash val="solid"/>
+                      <a:round/>
+                      <a:headEnd type="none" w="med" len="med"/>
+                      <a:tailEnd type="none" w="med" len="med"/>
+                    </a:lnB>
+                    <a:solidFill>
+                      <a:srgbClr val="E8F3EC"/>
+                    </a:solidFill>
+                  </a:tcPr>
+                </a:tc>
+                <a:tc>
+                  <a:txBody>
+                    <a:bodyPr/>
+                    <a:lstStyle/>
+                    <a:p>
+                      <a:pPr algn="ctr" indent="0" marL="0">
+                        <a:buNone/>
+                      </a:pPr>
+                      <a:r>
+                        <a:rPr lang="en-US" sz="1200" b="1" dirty="0">
+                          <a:solidFill>
+                            <a:srgbClr val="1E7A4D"/>
+                          </a:solidFill>
+                          <a:latin typeface="Space Grotesk" pitchFamily="34" charset="0"/>
+                          <a:ea typeface="Space Grotesk" pitchFamily="34" charset="-122"/>
+                          <a:cs typeface="Space Grotesk" pitchFamily="34" charset="-120"/>
+                        </a:rPr>
+                        <a:t>10.5x</a:t>
+                      </a:r>
+                      <a:endParaRPr lang="en-US" sz="1200" dirty="0">
+                        <a:latin typeface="Space Grotesk" charset="0"/>
+                        <a:ea typeface="Space Grotesk" charset="0"/>
+                        <a:cs typeface="Space Grotesk" charset="0"/>
+                      </a:endParaRPr>
+                    </a:p>
+                  </a:txBody>
+                  <a:tcPr marL="63500" marR="63500" marT="25400" marB="25400" anchor="ctr">
+                    <a:lnL w="6350" cap="flat" cmpd="sng" algn="ctr">
+                      <a:solidFill>
+                        <a:srgbClr val="E4DED4"/>
+                      </a:solidFill>
+                      <a:prstDash val="solid"/>
+                      <a:round/>
+                      <a:headEnd type="none" w="med" len="med"/>
+                      <a:tailEnd type="none" w="med" len="med"/>
+                    </a:lnL>
+                    <a:lnR w="6350" cap="flat" cmpd="sng" algn="ctr">
+                      <a:solidFill>
+                        <a:srgbClr val="E4DED4"/>
+                      </a:solidFill>
+                      <a:prstDash val="solid"/>
+                      <a:round/>
+                      <a:headEnd type="none" w="med" len="med"/>
+                      <a:tailEnd type="none" w="med" len="med"/>
+                    </a:lnR>
+                    <a:lnT w="6350" cap="flat" cmpd="sng" algn="ctr">
+                      <a:solidFill>
+                        <a:srgbClr val="E4DED4"/>
+                      </a:solidFill>
+                      <a:prstDash val="solid"/>
+                      <a:round/>
+                      <a:headEnd type="none" w="med" len="med"/>
+                      <a:tailEnd type="none" w="med" len="med"/>
+                    </a:lnT>
+                    <a:lnB w="6350" cap="flat" cmpd="sng" algn="ctr">
+                      <a:solidFill>
+                        <a:srgbClr val="E4DED4"/>
+                      </a:solidFill>
+                      <a:prstDash val="solid"/>
+                      <a:round/>
+                      <a:headEnd type="none" w="med" len="med"/>
+                      <a:tailEnd type="none" w="med" len="med"/>
+                    </a:lnB>
+                    <a:solidFill>
+                      <a:srgbClr val="E8F3EC"/>
+                    </a:solidFill>
+                  </a:tcPr>
+                </a:tc>
+                <a:tc>
+                  <a:txBody>
+                    <a:bodyPr/>
+                    <a:lstStyle/>
+                    <a:p>
+                      <a:pPr algn="ctr" indent="0" marL="0">
+                        <a:buNone/>
+                      </a:pPr>
+                      <a:r>
+                        <a:rPr lang="en-US" sz="800" b="1" dirty="0">
+                          <a:solidFill>
+                            <a:srgbClr val="6F6960"/>
+                          </a:solidFill>
+                          <a:latin typeface="IBM Plex Mono" pitchFamily="34" charset="0"/>
+                          <a:ea typeface="IBM Plex Mono" pitchFamily="34" charset="-122"/>
+                          <a:cs typeface="IBM Plex Mono" pitchFamily="34" charset="-120"/>
+                        </a:rPr>
+                        <a:t>10.5%</a:t>
+                      </a:r>
+                      <a:endParaRPr lang="en-US" sz="800" dirty="0">
+                        <a:latin typeface="IBM Plex Mono" charset="0"/>
+                        <a:ea typeface="IBM Plex Mono" charset="0"/>
+                        <a:cs typeface="IBM Plex Mono" charset="0"/>
+                      </a:endParaRPr>
+                    </a:p>
+                  </a:txBody>
+                  <a:tcPr marL="63500" marR="63500" marT="25400" marB="25400" anchor="ctr">
+                    <a:lnL w="6350" cap="flat" cmpd="sng" algn="ctr">
+                      <a:solidFill>
+                        <a:srgbClr val="E4DED4"/>
+                      </a:solidFill>
+                      <a:prstDash val="solid"/>
+                      <a:round/>
+                      <a:headEnd type="none" w="med" len="med"/>
+                      <a:tailEnd type="none" w="med" len="med"/>
+                    </a:lnL>
+                    <a:lnR w="6350" cap="flat" cmpd="sng" algn="ctr">
+                      <a:solidFill>
+                        <a:srgbClr val="E4DED4"/>
+                      </a:solidFill>
+                      <a:prstDash val="solid"/>
+                      <a:round/>
+                      <a:headEnd type="none" w="med" len="med"/>
+                      <a:tailEnd type="none" w="med" len="med"/>
+                    </a:lnR>
+                    <a:lnT w="6350" cap="flat" cmpd="sng" algn="ctr">
+                      <a:solidFill>
+                        <a:srgbClr val="E4DED4"/>
+                      </a:solidFill>
+                      <a:prstDash val="solid"/>
+                      <a:round/>
+                      <a:headEnd type="none" w="med" len="med"/>
+                      <a:tailEnd type="none" w="med" len="med"/>
+                    </a:lnT>
+                    <a:lnB w="6350" cap="flat" cmpd="sng" algn="ctr">
+                      <a:solidFill>
+                        <a:srgbClr val="E4DED4"/>
+                      </a:solidFill>
+                      <a:prstDash val="solid"/>
+                      <a:round/>
+                      <a:headEnd type="none" w="med" len="med"/>
+                      <a:tailEnd type="none" w="med" len="med"/>
+                    </a:lnB>
+                    <a:solidFill>
+                      <a:srgbClr val="E8F3EC"/>
+                    </a:solidFill>
+                  </a:tcPr>
+                </a:tc>
+              </a:tr>
+              <a:tr h="402336">
+                <a:tc>
+                  <a:txBody>
+                    <a:bodyPr/>
+                    <a:lstStyle/>
+                    <a:p>
+                      <a:pPr indent="0" marL="0">
+                        <a:buNone/>
+                      </a:pPr>
+                      <a:r>
+                        <a:rPr lang="en-US" sz="950" dirty="0">
+                          <a:solidFill>
+                            <a:srgbClr val="1B1714"/>
+                          </a:solidFill>
+                          <a:latin typeface="IBM Plex Sans KR" pitchFamily="34" charset="0"/>
+                          <a:ea typeface="IBM Plex Sans KR" pitchFamily="34" charset="-122"/>
+                          <a:cs typeface="IBM Plex Sans KR" pitchFamily="34" charset="-120"/>
+                        </a:rPr>
+                        <a:t>② CoC 해제 → 희석 30%</a:t>
+                      </a:r>
+                      <a:endParaRPr lang="en-US" sz="950" dirty="0">
+                        <a:latin typeface="IBM Plex Sans KR" charset="0"/>
+                        <a:ea typeface="IBM Plex Sans KR" charset="0"/>
+                        <a:cs typeface="IBM Plex Sans KR" charset="0"/>
+                      </a:endParaRPr>
+                    </a:p>
+                  </a:txBody>
+                  <a:tcPr marL="63500" marR="63500" marT="25400" marB="25400" anchor="ctr">
+                    <a:lnL w="6350" cap="flat" cmpd="sng" algn="ctr">
+                      <a:solidFill>
+                        <a:srgbClr val="E4DED4"/>
+                      </a:solidFill>
+                      <a:prstDash val="solid"/>
+                      <a:round/>
+                      <a:headEnd type="none" w="med" len="med"/>
+                      <a:tailEnd type="none" w="med" len="med"/>
+                    </a:lnL>
+                    <a:lnR w="6350" cap="flat" cmpd="sng" algn="ctr">
+                      <a:solidFill>
+                        <a:srgbClr val="E4DED4"/>
+                      </a:solidFill>
+                      <a:prstDash val="solid"/>
+                      <a:round/>
+                      <a:headEnd type="none" w="med" len="med"/>
+                      <a:tailEnd type="none" w="med" len="med"/>
+                    </a:lnR>
+                    <a:lnT w="6350" cap="flat" cmpd="sng" algn="ctr">
+                      <a:solidFill>
+                        <a:srgbClr val="E4DED4"/>
+                      </a:solidFill>
+                      <a:prstDash val="solid"/>
+                      <a:round/>
+                      <a:headEnd type="none" w="med" len="med"/>
+                      <a:tailEnd type="none" w="med" len="med"/>
+                    </a:lnT>
+                    <a:lnB w="6350" cap="flat" cmpd="sng" algn="ctr">
+                      <a:solidFill>
+                        <a:srgbClr val="E4DED4"/>
+                      </a:solidFill>
+                      <a:prstDash val="solid"/>
+                      <a:round/>
+                      <a:headEnd type="none" w="med" len="med"/>
+                      <a:tailEnd type="none" w="med" len="med"/>
+                    </a:lnB>
+                    <a:solidFill>
+                      <a:srgbClr val="E8F3EC"/>
+                    </a:solidFill>
+                  </a:tcPr>
+                </a:tc>
+                <a:tc>
+                  <a:txBody>
+                    <a:bodyPr/>
+                    <a:lstStyle/>
+                    <a:p>
+                      <a:pPr algn="ctr" indent="0" marL="0">
+                        <a:buNone/>
+                      </a:pPr>
+                      <a:r>
+                        <a:rPr lang="en-US" sz="950" dirty="0">
+                          <a:solidFill>
+                            <a:srgbClr val="1B1714"/>
+                          </a:solidFill>
+                          <a:latin typeface="IBM Plex Mono" pitchFamily="34" charset="0"/>
+                          <a:ea typeface="IBM Plex Mono" pitchFamily="34" charset="-122"/>
+                          <a:cs typeface="IBM Plex Mono" pitchFamily="34" charset="-120"/>
+                        </a:rPr>
+                        <a:t>10%</a:t>
+                      </a:r>
+                      <a:endParaRPr lang="en-US" sz="950" dirty="0">
+                        <a:latin typeface="IBM Plex Mono" charset="0"/>
+                        <a:ea typeface="IBM Plex Mono" charset="0"/>
+                        <a:cs typeface="IBM Plex Mono" charset="0"/>
+                      </a:endParaRPr>
+                    </a:p>
+                  </a:txBody>
+                  <a:tcPr marL="63500" marR="63500" marT="25400" marB="25400" anchor="ctr">
+                    <a:lnL w="6350" cap="flat" cmpd="sng" algn="ctr">
+                      <a:solidFill>
+                        <a:srgbClr val="E4DED4"/>
+                      </a:solidFill>
+                      <a:prstDash val="solid"/>
+                      <a:round/>
+                      <a:headEnd type="none" w="med" len="med"/>
+                      <a:tailEnd type="none" w="med" len="med"/>
+                    </a:lnL>
+                    <a:lnR w="6350" cap="flat" cmpd="sng" algn="ctr">
+                      <a:solidFill>
+                        <a:srgbClr val="E4DED4"/>
+                      </a:solidFill>
+                      <a:prstDash val="solid"/>
+                      <a:round/>
+                      <a:headEnd type="none" w="med" len="med"/>
+                      <a:tailEnd type="none" w="med" len="med"/>
+                    </a:lnR>
+                    <a:lnT w="6350" cap="flat" cmpd="sng" algn="ctr">
+                      <a:solidFill>
+                        <a:srgbClr val="E4DED4"/>
+                      </a:solidFill>
+                      <a:prstDash val="solid"/>
+                      <a:round/>
+                      <a:headEnd type="none" w="med" len="med"/>
+                      <a:tailEnd type="none" w="med" len="med"/>
+                    </a:lnT>
+                    <a:lnB w="6350" cap="flat" cmpd="sng" algn="ctr">
+                      <a:solidFill>
+                        <a:srgbClr val="E4DED4"/>
+                      </a:solidFill>
+                      <a:prstDash val="solid"/>
+                      <a:round/>
+                      <a:headEnd type="none" w="med" len="med"/>
+                      <a:tailEnd type="none" w="med" len="med"/>
+                    </a:lnB>
+                    <a:solidFill>
+                      <a:srgbClr val="E8F3EC"/>
+                    </a:solidFill>
+                  </a:tcPr>
+                </a:tc>
+                <a:tc>
+                  <a:txBody>
+                    <a:bodyPr/>
+                    <a:lstStyle/>
+                    <a:p>
+                      <a:pPr algn="ctr" indent="0" marL="0">
+                        <a:buNone/>
+                      </a:pPr>
+                      <a:r>
+                        <a:rPr lang="en-US" sz="950" dirty="0">
+                          <a:solidFill>
+                            <a:srgbClr val="1B1714"/>
+                          </a:solidFill>
+                          <a:latin typeface="IBM Plex Mono" pitchFamily="34" charset="0"/>
+                          <a:ea typeface="IBM Plex Mono" pitchFamily="34" charset="-122"/>
+                          <a:cs typeface="IBM Plex Mono" pitchFamily="34" charset="-120"/>
+                        </a:rPr>
+                        <a:t>30%</a:t>
+                      </a:r>
+                      <a:endParaRPr lang="en-US" sz="950" dirty="0">
+                        <a:latin typeface="IBM Plex Mono" charset="0"/>
+                        <a:ea typeface="IBM Plex Mono" charset="0"/>
+                        <a:cs typeface="IBM Plex Mono" charset="0"/>
+                      </a:endParaRPr>
+                    </a:p>
+                  </a:txBody>
+                  <a:tcPr marL="63500" marR="63500" marT="25400" marB="25400" anchor="ctr">
+                    <a:lnL w="6350" cap="flat" cmpd="sng" algn="ctr">
+                      <a:solidFill>
+                        <a:srgbClr val="E4DED4"/>
+                      </a:solidFill>
+                      <a:prstDash val="solid"/>
+                      <a:round/>
+                      <a:headEnd type="none" w="med" len="med"/>
+                      <a:tailEnd type="none" w="med" len="med"/>
+                    </a:lnL>
+                    <a:lnR w="6350" cap="flat" cmpd="sng" algn="ctr">
+                      <a:solidFill>
+                        <a:srgbClr val="E4DED4"/>
+                      </a:solidFill>
+                      <a:prstDash val="solid"/>
+                      <a:round/>
+                      <a:headEnd type="none" w="med" len="med"/>
+                      <a:tailEnd type="none" w="med" len="med"/>
+                    </a:lnR>
+                    <a:lnT w="6350" cap="flat" cmpd="sng" algn="ctr">
+                      <a:solidFill>
+                        <a:srgbClr val="E4DED4"/>
+                      </a:solidFill>
+                      <a:prstDash val="solid"/>
+                      <a:round/>
+                      <a:headEnd type="none" w="med" len="med"/>
+                      <a:tailEnd type="none" w="med" len="med"/>
+                    </a:lnT>
+                    <a:lnB w="6350" cap="flat" cmpd="sng" algn="ctr">
+                      <a:solidFill>
+                        <a:srgbClr val="E4DED4"/>
+                      </a:solidFill>
+                      <a:prstDash val="solid"/>
+                      <a:round/>
+                      <a:headEnd type="none" w="med" len="med"/>
+                      <a:tailEnd type="none" w="med" len="med"/>
+                    </a:lnB>
+                    <a:solidFill>
+                      <a:srgbClr val="E8F3EC"/>
+                    </a:solidFill>
+                  </a:tcPr>
+                </a:tc>
+                <a:tc>
+                  <a:txBody>
+                    <a:bodyPr/>
+                    <a:lstStyle/>
+                    <a:p>
+                      <a:pPr algn="ctr" indent="0" marL="0">
+                        <a:buNone/>
+                      </a:pPr>
+                      <a:r>
+                        <a:rPr lang="en-US" sz="950" dirty="0">
+                          <a:solidFill>
+                            <a:srgbClr val="1B1714"/>
+                          </a:solidFill>
+                          <a:latin typeface="IBM Plex Mono" pitchFamily="34" charset="0"/>
+                          <a:ea typeface="IBM Plex Mono" pitchFamily="34" charset="-122"/>
+                          <a:cs typeface="IBM Plex Mono" pitchFamily="34" charset="-120"/>
+                        </a:rPr>
+                        <a:t>$7.8bn</a:t>
+                      </a:r>
+                      <a:endParaRPr lang="en-US" sz="950" dirty="0">
+                        <a:latin typeface="IBM Plex Mono" charset="0"/>
+                        <a:ea typeface="IBM Plex Mono" charset="0"/>
+                        <a:cs typeface="IBM Plex Mono" charset="0"/>
+                      </a:endParaRPr>
+                    </a:p>
+                  </a:txBody>
+                  <a:tcPr marL="63500" marR="63500" marT="25400" marB="25400" anchor="ctr">
+                    <a:lnL w="6350" cap="flat" cmpd="sng" algn="ctr">
+                      <a:solidFill>
+                        <a:srgbClr val="E4DED4"/>
+                      </a:solidFill>
+                      <a:prstDash val="solid"/>
+                      <a:round/>
+                      <a:headEnd type="none" w="med" len="med"/>
+                      <a:tailEnd type="none" w="med" len="med"/>
+                    </a:lnL>
+                    <a:lnR w="6350" cap="flat" cmpd="sng" algn="ctr">
+                      <a:solidFill>
+                        <a:srgbClr val="E4DED4"/>
+                      </a:solidFill>
+                      <a:prstDash val="solid"/>
+                      <a:round/>
+                      <a:headEnd type="none" w="med" len="med"/>
+                      <a:tailEnd type="none" w="med" len="med"/>
+                    </a:lnR>
+                    <a:lnT w="6350" cap="flat" cmpd="sng" algn="ctr">
+                      <a:solidFill>
+                        <a:srgbClr val="E4DED4"/>
+                      </a:solidFill>
+                      <a:prstDash val="solid"/>
+                      <a:round/>
+                      <a:headEnd type="none" w="med" len="med"/>
+                      <a:tailEnd type="none" w="med" len="med"/>
+                    </a:lnT>
+                    <a:lnB w="6350" cap="flat" cmpd="sng" algn="ctr">
+                      <a:solidFill>
+                        <a:srgbClr val="E4DED4"/>
+                      </a:solidFill>
+                      <a:prstDash val="solid"/>
+                      <a:round/>
+                      <a:headEnd type="none" w="med" len="med"/>
+                      <a:tailEnd type="none" w="med" len="med"/>
+                    </a:lnB>
+                    <a:solidFill>
+                      <a:srgbClr val="E8F3EC"/>
+                    </a:solidFill>
+                  </a:tcPr>
+                </a:tc>
+                <a:tc>
+                  <a:txBody>
+                    <a:bodyPr/>
+                    <a:lstStyle/>
+                    <a:p>
+                      <a:pPr algn="ctr" indent="0" marL="0">
+                        <a:buNone/>
+                      </a:pPr>
+                      <a:r>
+                        <a:rPr lang="en-US" sz="1200" b="1" dirty="0">
+                          <a:solidFill>
+                            <a:srgbClr val="1E7A4D"/>
+                          </a:solidFill>
+                          <a:latin typeface="Space Grotesk" pitchFamily="34" charset="0"/>
+                          <a:ea typeface="Space Grotesk" pitchFamily="34" charset="-122"/>
+                          <a:cs typeface="Space Grotesk" pitchFamily="34" charset="-120"/>
+                        </a:rPr>
+                        <a:t>10.5x</a:t>
+                      </a:r>
+                      <a:endParaRPr lang="en-US" sz="1200" dirty="0">
+                        <a:latin typeface="Space Grotesk" charset="0"/>
+                        <a:ea typeface="Space Grotesk" charset="0"/>
+                        <a:cs typeface="Space Grotesk" charset="0"/>
+                      </a:endParaRPr>
+                    </a:p>
+                  </a:txBody>
+                  <a:tcPr marL="63500" marR="63500" marT="25400" marB="25400" anchor="ctr">
+                    <a:lnL w="6350" cap="flat" cmpd="sng" algn="ctr">
+                      <a:solidFill>
+                        <a:srgbClr val="E4DED4"/>
+                      </a:solidFill>
+                      <a:prstDash val="solid"/>
+                      <a:round/>
+                      <a:headEnd type="none" w="med" len="med"/>
+                      <a:tailEnd type="none" w="med" len="med"/>
+                    </a:lnL>
+                    <a:lnR w="6350" cap="flat" cmpd="sng" algn="ctr">
+                      <a:solidFill>
+                        <a:srgbClr val="E4DED4"/>
+                      </a:solidFill>
+                      <a:prstDash val="solid"/>
+                      <a:round/>
+                      <a:headEnd type="none" w="med" len="med"/>
+                      <a:tailEnd type="none" w="med" len="med"/>
+                    </a:lnR>
+                    <a:lnT w="6350" cap="flat" cmpd="sng" algn="ctr">
+                      <a:solidFill>
+                        <a:srgbClr val="E4DED4"/>
+                      </a:solidFill>
+                      <a:prstDash val="solid"/>
+                      <a:round/>
+                      <a:headEnd type="none" w="med" len="med"/>
+                      <a:tailEnd type="none" w="med" len="med"/>
+                    </a:lnT>
+                    <a:lnB w="6350" cap="flat" cmpd="sng" algn="ctr">
+                      <a:solidFill>
+                        <a:srgbClr val="E4DED4"/>
+                      </a:solidFill>
+                      <a:prstDash val="solid"/>
+                      <a:round/>
+                      <a:headEnd type="none" w="med" len="med"/>
+                      <a:tailEnd type="none" w="med" len="med"/>
+                    </a:lnB>
+                    <a:solidFill>
+                      <a:srgbClr val="E8F3EC"/>
+                    </a:solidFill>
+                  </a:tcPr>
+                </a:tc>
+                <a:tc>
+                  <a:txBody>
+                    <a:bodyPr/>
+                    <a:lstStyle/>
+                    <a:p>
+                      <a:pPr algn="ctr" indent="0" marL="0">
+                        <a:buNone/>
+                      </a:pPr>
+                      <a:r>
+                        <a:rPr lang="en-US" sz="800" b="1" dirty="0">
+                          <a:solidFill>
+                            <a:srgbClr val="6F6960"/>
+                          </a:solidFill>
+                          <a:latin typeface="IBM Plex Mono" pitchFamily="34" charset="0"/>
+                          <a:ea typeface="IBM Plex Mono" pitchFamily="34" charset="-122"/>
+                          <a:cs typeface="IBM Plex Mono" pitchFamily="34" charset="-120"/>
+                        </a:rPr>
+                        <a:t>10.5%</a:t>
+                      </a:r>
+                      <a:endParaRPr lang="en-US" sz="800" dirty="0">
+                        <a:latin typeface="IBM Plex Mono" charset="0"/>
+                        <a:ea typeface="IBM Plex Mono" charset="0"/>
+                        <a:cs typeface="IBM Plex Mono" charset="0"/>
+                      </a:endParaRPr>
+                    </a:p>
+                  </a:txBody>
+                  <a:tcPr marL="63500" marR="63500" marT="25400" marB="25400" anchor="ctr">
+                    <a:lnL w="6350" cap="flat" cmpd="sng" algn="ctr">
+                      <a:solidFill>
+                        <a:srgbClr val="E4DED4"/>
+                      </a:solidFill>
+                      <a:prstDash val="solid"/>
+                      <a:round/>
+                      <a:headEnd type="none" w="med" len="med"/>
+                      <a:tailEnd type="none" w="med" len="med"/>
+                    </a:lnL>
+                    <a:lnR w="6350" cap="flat" cmpd="sng" algn="ctr">
+                      <a:solidFill>
+                        <a:srgbClr val="E4DED4"/>
+                      </a:solidFill>
+                      <a:prstDash val="solid"/>
+                      <a:round/>
+                      <a:headEnd type="none" w="med" len="med"/>
+                      <a:tailEnd type="none" w="med" len="med"/>
+                    </a:lnR>
+                    <a:lnT w="6350" cap="flat" cmpd="sng" algn="ctr">
+                      <a:solidFill>
+                        <a:srgbClr val="E4DED4"/>
+                      </a:solidFill>
+                      <a:prstDash val="solid"/>
+                      <a:round/>
+                      <a:headEnd type="none" w="med" len="med"/>
+                      <a:tailEnd type="none" w="med" len="med"/>
+                    </a:lnT>
+                    <a:lnB w="6350" cap="flat" cmpd="sng" algn="ctr">
+                      <a:solidFill>
+                        <a:srgbClr val="E4DED4"/>
+                      </a:solidFill>
+                      <a:prstDash val="solid"/>
+                      <a:round/>
+                      <a:headEnd type="none" w="med" len="med"/>
+                      <a:tailEnd type="none" w="med" len="med"/>
+                    </a:lnB>
+                    <a:solidFill>
+                      <a:srgbClr val="E8F3EC"/>
+                    </a:solidFill>
+                  </a:tcPr>
+                </a:tc>
+              </a:tr>
+              <a:tr h="402336">
+                <a:tc>
+                  <a:txBody>
+                    <a:bodyPr/>
+                    <a:lstStyle/>
+                    <a:p>
+                      <a:pPr indent="0" marL="0">
+                        <a:buNone/>
+                      </a:pPr>
+                      <a:r>
+                        <a:rPr lang="en-US" sz="950" dirty="0">
+                          <a:solidFill>
+                            <a:srgbClr val="1B1714"/>
+                          </a:solidFill>
+                          <a:latin typeface="IBM Plex Sans KR" pitchFamily="34" charset="0"/>
+                          <a:ea typeface="IBM Plex Sans KR" pitchFamily="34" charset="-122"/>
+                          <a:cs typeface="IBM Plex Sans KR" pitchFamily="34" charset="-120"/>
+                        </a:rPr>
+                        <a:t>③ CoC 완화 → 희석 49%</a:t>
+                      </a:r>
+                      <a:endParaRPr lang="en-US" sz="950" dirty="0">
+                        <a:latin typeface="IBM Plex Sans KR" charset="0"/>
+                        <a:ea typeface="IBM Plex Sans KR" charset="0"/>
+                        <a:cs typeface="IBM Plex Sans KR" charset="0"/>
+                      </a:endParaRPr>
+                    </a:p>
+                  </a:txBody>
+                  <a:tcPr marL="63500" marR="63500" marT="25400" marB="25400" anchor="ctr">
+                    <a:lnL w="6350" cap="flat" cmpd="sng" algn="ctr">
+                      <a:solidFill>
+                        <a:srgbClr val="E4DED4"/>
+                      </a:solidFill>
+                      <a:prstDash val="solid"/>
+                      <a:round/>
+                      <a:headEnd type="none" w="med" len="med"/>
+                      <a:tailEnd type="none" w="med" len="med"/>
+                    </a:lnL>
+                    <a:lnR w="6350" cap="flat" cmpd="sng" algn="ctr">
+                      <a:solidFill>
+                        <a:srgbClr val="E4DED4"/>
+                      </a:solidFill>
+                      <a:prstDash val="solid"/>
+                      <a:round/>
+                      <a:headEnd type="none" w="med" len="med"/>
+                      <a:tailEnd type="none" w="med" len="med"/>
+                    </a:lnR>
+                    <a:lnT w="6350" cap="flat" cmpd="sng" algn="ctr">
+                      <a:solidFill>
+                        <a:srgbClr val="E4DED4"/>
+                      </a:solidFill>
+                      <a:prstDash val="solid"/>
+                      <a:round/>
+                      <a:headEnd type="none" w="med" len="med"/>
+                      <a:tailEnd type="none" w="med" len="med"/>
+                    </a:lnT>
+                    <a:lnB w="6350" cap="flat" cmpd="sng" algn="ctr">
+                      <a:solidFill>
+                        <a:srgbClr val="E4DED4"/>
+                      </a:solidFill>
+                      <a:prstDash val="solid"/>
+                      <a:round/>
+                      <a:headEnd type="none" w="med" len="med"/>
+                      <a:tailEnd type="none" w="med" len="med"/>
+                    </a:lnB>
+                    <a:solidFill>
+                      <a:srgbClr val="E8F3EC"/>
+                    </a:solidFill>
+                  </a:tcPr>
+                </a:tc>
+                <a:tc>
+                  <a:txBody>
+                    <a:bodyPr/>
+                    <a:lstStyle/>
+                    <a:p>
+                      <a:pPr algn="ctr" indent="0" marL="0">
+                        <a:buNone/>
+                      </a:pPr>
+                      <a:r>
+                        <a:rPr lang="en-US" sz="950" dirty="0">
+                          <a:solidFill>
+                            <a:srgbClr val="1B1714"/>
+                          </a:solidFill>
+                          <a:latin typeface="IBM Plex Mono" pitchFamily="34" charset="0"/>
+                          <a:ea typeface="IBM Plex Mono" pitchFamily="34" charset="-122"/>
+                          <a:cs typeface="IBM Plex Mono" pitchFamily="34" charset="-120"/>
+                        </a:rPr>
+                        <a:t>10%</a:t>
+                      </a:r>
+                      <a:endParaRPr lang="en-US" sz="950" dirty="0">
+                        <a:latin typeface="IBM Plex Mono" charset="0"/>
+                        <a:ea typeface="IBM Plex Mono" charset="0"/>
+                        <a:cs typeface="IBM Plex Mono" charset="0"/>
+                      </a:endParaRPr>
+                    </a:p>
+                  </a:txBody>
+                  <a:tcPr marL="63500" marR="63500" marT="25400" marB="25400" anchor="ctr">
+                    <a:lnL w="6350" cap="flat" cmpd="sng" algn="ctr">
+                      <a:solidFill>
+                        <a:srgbClr val="E4DED4"/>
+                      </a:solidFill>
+                      <a:prstDash val="solid"/>
+                      <a:round/>
+                      <a:headEnd type="none" w="med" len="med"/>
+                      <a:tailEnd type="none" w="med" len="med"/>
+                    </a:lnL>
+                    <a:lnR w="6350" cap="flat" cmpd="sng" algn="ctr">
+                      <a:solidFill>
+                        <a:srgbClr val="E4DED4"/>
+                      </a:solidFill>
+                      <a:prstDash val="solid"/>
+                      <a:round/>
+                      <a:headEnd type="none" w="med" len="med"/>
+                      <a:tailEnd type="none" w="med" len="med"/>
+                    </a:lnR>
+                    <a:lnT w="6350" cap="flat" cmpd="sng" algn="ctr">
+                      <a:solidFill>
+                        <a:srgbClr val="E4DED4"/>
+                      </a:solidFill>
+                      <a:prstDash val="solid"/>
+                      <a:round/>
+                      <a:headEnd type="none" w="med" len="med"/>
+                      <a:tailEnd type="none" w="med" len="med"/>
+                    </a:lnT>
+                    <a:lnB w="6350" cap="flat" cmpd="sng" algn="ctr">
+                      <a:solidFill>
+                        <a:srgbClr val="E4DED4"/>
+                      </a:solidFill>
+                      <a:prstDash val="solid"/>
+                      <a:round/>
+                      <a:headEnd type="none" w="med" len="med"/>
+                      <a:tailEnd type="none" w="med" len="med"/>
+                    </a:lnB>
+                    <a:solidFill>
+                      <a:srgbClr val="E8F3EC"/>
+                    </a:solidFill>
+                  </a:tcPr>
+                </a:tc>
+                <a:tc>
+                  <a:txBody>
+                    <a:bodyPr/>
+                    <a:lstStyle/>
+                    <a:p>
+                      <a:pPr algn="ctr" indent="0" marL="0">
+                        <a:buNone/>
+                      </a:pPr>
+                      <a:r>
+                        <a:rPr lang="en-US" sz="950" dirty="0">
+                          <a:solidFill>
+                            <a:srgbClr val="1B1714"/>
+                          </a:solidFill>
+                          <a:latin typeface="IBM Plex Mono" pitchFamily="34" charset="0"/>
+                          <a:ea typeface="IBM Plex Mono" pitchFamily="34" charset="-122"/>
+                          <a:cs typeface="IBM Plex Mono" pitchFamily="34" charset="-120"/>
+                        </a:rPr>
+                        <a:t>49%</a:t>
+                      </a:r>
+                      <a:endParaRPr lang="en-US" sz="950" dirty="0">
+                        <a:latin typeface="IBM Plex Mono" charset="0"/>
+                        <a:ea typeface="IBM Plex Mono" charset="0"/>
+                        <a:cs typeface="IBM Plex Mono" charset="0"/>
+                      </a:endParaRPr>
+                    </a:p>
+                  </a:txBody>
+                  <a:tcPr marL="63500" marR="63500" marT="25400" marB="25400" anchor="ctr">
+                    <a:lnL w="6350" cap="flat" cmpd="sng" algn="ctr">
+                      <a:solidFill>
+                        <a:srgbClr val="E4DED4"/>
+                      </a:solidFill>
+                      <a:prstDash val="solid"/>
+                      <a:round/>
+                      <a:headEnd type="none" w="med" len="med"/>
+                      <a:tailEnd type="none" w="med" len="med"/>
+                    </a:lnL>
+                    <a:lnR w="6350" cap="flat" cmpd="sng" algn="ctr">
+                      <a:solidFill>
+                        <a:srgbClr val="E4DED4"/>
+                      </a:solidFill>
+                      <a:prstDash val="solid"/>
+                      <a:round/>
+                      <a:headEnd type="none" w="med" len="med"/>
+                      <a:tailEnd type="none" w="med" len="med"/>
+                    </a:lnR>
+                    <a:lnT w="6350" cap="flat" cmpd="sng" algn="ctr">
+                      <a:solidFill>
+                        <a:srgbClr val="E4DED4"/>
+                      </a:solidFill>
+                      <a:prstDash val="solid"/>
+                      <a:round/>
+                      <a:headEnd type="none" w="med" len="med"/>
+                      <a:tailEnd type="none" w="med" len="med"/>
+                    </a:lnT>
+                    <a:lnB w="6350" cap="flat" cmpd="sng" algn="ctr">
+                      <a:solidFill>
+                        <a:srgbClr val="E4DED4"/>
+                      </a:solidFill>
+                      <a:prstDash val="solid"/>
+                      <a:round/>
+                      <a:headEnd type="none" w="med" len="med"/>
+                      <a:tailEnd type="none" w="med" len="med"/>
+                    </a:lnB>
+                    <a:solidFill>
+                      <a:srgbClr val="E8F3EC"/>
+                    </a:solidFill>
+                  </a:tcPr>
+                </a:tc>
+                <a:tc>
+                  <a:txBody>
+                    <a:bodyPr/>
+                    <a:lstStyle/>
+                    <a:p>
+                      <a:pPr algn="ctr" indent="0" marL="0">
+                        <a:buNone/>
+                      </a:pPr>
+                      <a:r>
+                        <a:rPr lang="en-US" sz="950" dirty="0">
+                          <a:solidFill>
+                            <a:srgbClr val="1B1714"/>
+                          </a:solidFill>
+                          <a:latin typeface="IBM Plex Mono" pitchFamily="34" charset="0"/>
+                          <a:ea typeface="IBM Plex Mono" pitchFamily="34" charset="-122"/>
+                          <a:cs typeface="IBM Plex Mono" pitchFamily="34" charset="-120"/>
+                        </a:rPr>
+                        <a:t>$7.3bn</a:t>
+                      </a:r>
+                      <a:endParaRPr lang="en-US" sz="950" dirty="0">
+                        <a:latin typeface="IBM Plex Mono" charset="0"/>
+                        <a:ea typeface="IBM Plex Mono" charset="0"/>
+                        <a:cs typeface="IBM Plex Mono" charset="0"/>
+                      </a:endParaRPr>
+                    </a:p>
+                  </a:txBody>
+                  <a:tcPr marL="63500" marR="63500" marT="25400" marB="25400" anchor="ctr">
+                    <a:lnL w="6350" cap="flat" cmpd="sng" algn="ctr">
+                      <a:solidFill>
+                        <a:srgbClr val="E4DED4"/>
+                      </a:solidFill>
+                      <a:prstDash val="solid"/>
+                      <a:round/>
+                      <a:headEnd type="none" w="med" len="med"/>
+                      <a:tailEnd type="none" w="med" len="med"/>
+                    </a:lnL>
+                    <a:lnR w="6350" cap="flat" cmpd="sng" algn="ctr">
+                      <a:solidFill>
+                        <a:srgbClr val="E4DED4"/>
+                      </a:solidFill>
+                      <a:prstDash val="solid"/>
+                      <a:round/>
+                      <a:headEnd type="none" w="med" len="med"/>
+                      <a:tailEnd type="none" w="med" len="med"/>
+                    </a:lnR>
+                    <a:lnT w="6350" cap="flat" cmpd="sng" algn="ctr">
+                      <a:solidFill>
+                        <a:srgbClr val="E4DED4"/>
+                      </a:solidFill>
+                      <a:prstDash val="solid"/>
+                      <a:round/>
+                      <a:headEnd type="none" w="med" len="med"/>
+                      <a:tailEnd type="none" w="med" len="med"/>
+                    </a:lnT>
+                    <a:lnB w="6350" cap="flat" cmpd="sng" algn="ctr">
+                      <a:solidFill>
+                        <a:srgbClr val="E4DED4"/>
+                      </a:solidFill>
+                      <a:prstDash val="solid"/>
+                      <a:round/>
+                      <a:headEnd type="none" w="med" len="med"/>
+                      <a:tailEnd type="none" w="med" len="med"/>
+                    </a:lnB>
+                    <a:solidFill>
+                      <a:srgbClr val="E8F3EC"/>
+                    </a:solidFill>
+                  </a:tcPr>
+                </a:tc>
+                <a:tc>
+                  <a:txBody>
+                    <a:bodyPr/>
+                    <a:lstStyle/>
+                    <a:p>
+                      <a:pPr algn="ctr" indent="0" marL="0">
+                        <a:buNone/>
+                      </a:pPr>
+                      <a:r>
+                        <a:rPr lang="en-US" sz="1200" b="1" dirty="0">
+                          <a:solidFill>
+                            <a:srgbClr val="1E7A4D"/>
+                          </a:solidFill>
+                          <a:latin typeface="Space Grotesk" pitchFamily="34" charset="0"/>
+                          <a:ea typeface="Space Grotesk" pitchFamily="34" charset="-122"/>
+                          <a:cs typeface="Space Grotesk" pitchFamily="34" charset="-120"/>
+                        </a:rPr>
+                        <a:t>9.7x</a:t>
+                      </a:r>
+                      <a:endParaRPr lang="en-US" sz="1200" dirty="0">
+                        <a:latin typeface="Space Grotesk" charset="0"/>
+                        <a:ea typeface="Space Grotesk" charset="0"/>
+                        <a:cs typeface="Space Grotesk" charset="0"/>
+                      </a:endParaRPr>
+                    </a:p>
+                  </a:txBody>
+                  <a:tcPr marL="63500" marR="63500" marT="25400" marB="25400" anchor="ctr">
+                    <a:lnL w="6350" cap="flat" cmpd="sng" algn="ctr">
+                      <a:solidFill>
+                        <a:srgbClr val="E4DED4"/>
+                      </a:solidFill>
+                      <a:prstDash val="solid"/>
+                      <a:round/>
+                      <a:headEnd type="none" w="med" len="med"/>
+                      <a:tailEnd type="none" w="med" len="med"/>
+                    </a:lnL>
+                    <a:lnR w="6350" cap="flat" cmpd="sng" algn="ctr">
+                      <a:solidFill>
+                        <a:srgbClr val="E4DED4"/>
+                      </a:solidFill>
+                      <a:prstDash val="solid"/>
+                      <a:round/>
+                      <a:headEnd type="none" w="med" len="med"/>
+                      <a:tailEnd type="none" w="med" len="med"/>
+                    </a:lnR>
+                    <a:lnT w="6350" cap="flat" cmpd="sng" algn="ctr">
+                      <a:solidFill>
+                        <a:srgbClr val="E4DED4"/>
+                      </a:solidFill>
+                      <a:prstDash val="solid"/>
+                      <a:round/>
+                      <a:headEnd type="none" w="med" len="med"/>
+                      <a:tailEnd type="none" w="med" len="med"/>
+                    </a:lnT>
+                    <a:lnB w="6350" cap="flat" cmpd="sng" algn="ctr">
+                      <a:solidFill>
+                        <a:srgbClr val="E4DED4"/>
+                      </a:solidFill>
+                      <a:prstDash val="solid"/>
+                      <a:round/>
+                      <a:headEnd type="none" w="med" len="med"/>
+                      <a:tailEnd type="none" w="med" len="med"/>
+                    </a:lnB>
+                    <a:solidFill>
+                      <a:srgbClr val="E8F3EC"/>
+                    </a:solidFill>
+                  </a:tcPr>
+                </a:tc>
+                <a:tc>
+                  <a:txBody>
+                    <a:bodyPr/>
+                    <a:lstStyle/>
+                    <a:p>
+                      <a:pPr algn="ctr" indent="0" marL="0">
+                        <a:buNone/>
+                      </a:pPr>
+                      <a:r>
+                        <a:rPr lang="en-US" sz="800" b="1" dirty="0">
+                          <a:solidFill>
+                            <a:srgbClr val="6F6960"/>
+                          </a:solidFill>
+                          <a:latin typeface="IBM Plex Mono" pitchFamily="34" charset="0"/>
+                          <a:ea typeface="IBM Plex Mono" pitchFamily="34" charset="-122"/>
+                          <a:cs typeface="IBM Plex Mono" pitchFamily="34" charset="-120"/>
+                        </a:rPr>
+                        <a:t>9.7%</a:t>
+                      </a:r>
+                      <a:endParaRPr lang="en-US" sz="800" dirty="0">
+                        <a:latin typeface="IBM Plex Mono" charset="0"/>
+                        <a:ea typeface="IBM Plex Mono" charset="0"/>
+                        <a:cs typeface="IBM Plex Mono" charset="0"/>
+                      </a:endParaRPr>
+                    </a:p>
+                  </a:txBody>
+                  <a:tcPr marL="63500" marR="63500" marT="25400" marB="25400" anchor="ctr">
+                    <a:lnL w="6350" cap="flat" cmpd="sng" algn="ctr">
+                      <a:solidFill>
+                        <a:srgbClr val="E4DED4"/>
+                      </a:solidFill>
+                      <a:prstDash val="solid"/>
+                      <a:round/>
+                      <a:headEnd type="none" w="med" len="med"/>
+                      <a:tailEnd type="none" w="med" len="med"/>
+                    </a:lnL>
+                    <a:lnR w="6350" cap="flat" cmpd="sng" algn="ctr">
+                      <a:solidFill>
+                        <a:srgbClr val="E4DED4"/>
+                      </a:solidFill>
+                      <a:prstDash val="solid"/>
+                      <a:round/>
+                      <a:headEnd type="none" w="med" len="med"/>
+                      <a:tailEnd type="none" w="med" len="med"/>
+                    </a:lnR>
+                    <a:lnT w="6350" cap="flat" cmpd="sng" algn="ctr">
+                      <a:solidFill>
+                        <a:srgbClr val="E4DED4"/>
+                      </a:solidFill>
+                      <a:prstDash val="solid"/>
+                      <a:round/>
+                      <a:headEnd type="none" w="med" len="med"/>
+                      <a:tailEnd type="none" w="med" len="med"/>
+                    </a:lnT>
+                    <a:lnB w="6350" cap="flat" cmpd="sng" algn="ctr">
+                      <a:solidFill>
+                        <a:srgbClr val="E4DED4"/>
+                      </a:solidFill>
+                      <a:prstDash val="solid"/>
+                      <a:round/>
+                      <a:headEnd type="none" w="med" len="med"/>
+                      <a:tailEnd type="none" w="med" len="med"/>
+                    </a:lnB>
+                    <a:solidFill>
+                      <a:srgbClr val="E8F3EC"/>
+                    </a:solidFill>
+                  </a:tcPr>
+                </a:tc>
+              </a:tr>
+              <a:tr h="402336">
+                <a:tc>
+                  <a:txBody>
+                    <a:bodyPr/>
+                    <a:lstStyle/>
+                    <a:p>
+                      <a:pPr indent="0" marL="0">
+                        <a:buNone/>
+                      </a:pPr>
+                      <a:r>
+                        <a:rPr lang="en-US" sz="950" dirty="0">
+                          <a:solidFill>
+                            <a:srgbClr val="1B1714"/>
+                          </a:solidFill>
+                          <a:latin typeface="IBM Plex Sans KR" pitchFamily="34" charset="0"/>
+                          <a:ea typeface="IBM Plex Sans KR" pitchFamily="34" charset="-122"/>
+                          <a:cs typeface="IBM Plex Sans KR" pitchFamily="34" charset="-120"/>
+                        </a:rPr>
+                        <a:t>최대결합 (그랜트20+희석49)</a:t>
+                      </a:r>
+                      <a:endParaRPr lang="en-US" sz="950" dirty="0">
+                        <a:latin typeface="IBM Plex Sans KR" charset="0"/>
+                        <a:ea typeface="IBM Plex Sans KR" charset="0"/>
+                        <a:cs typeface="IBM Plex Sans KR" charset="0"/>
+                      </a:endParaRPr>
+                    </a:p>
+                  </a:txBody>
+                  <a:tcPr marL="63500" marR="63500" marT="25400" marB="25400" anchor="ctr">
+                    <a:lnL w="6350" cap="flat" cmpd="sng" algn="ctr">
+                      <a:solidFill>
+                        <a:srgbClr val="E4DED4"/>
+                      </a:solidFill>
+                      <a:prstDash val="solid"/>
+                      <a:round/>
+                      <a:headEnd type="none" w="med" len="med"/>
+                      <a:tailEnd type="none" w="med" len="med"/>
+                    </a:lnL>
+                    <a:lnR w="6350" cap="flat" cmpd="sng" algn="ctr">
+                      <a:solidFill>
+                        <a:srgbClr val="E4DED4"/>
+                      </a:solidFill>
+                      <a:prstDash val="solid"/>
+                      <a:round/>
+                      <a:headEnd type="none" w="med" len="med"/>
+                      <a:tailEnd type="none" w="med" len="med"/>
+                    </a:lnR>
+                    <a:lnT w="6350" cap="flat" cmpd="sng" algn="ctr">
+                      <a:solidFill>
+                        <a:srgbClr val="E4DED4"/>
+                      </a:solidFill>
+                      <a:prstDash val="solid"/>
+                      <a:round/>
+                      <a:headEnd type="none" w="med" len="med"/>
+                      <a:tailEnd type="none" w="med" len="med"/>
+                    </a:lnT>
+                    <a:lnB w="6350" cap="flat" cmpd="sng" algn="ctr">
+                      <a:solidFill>
+                        <a:srgbClr val="E4DED4"/>
+                      </a:solidFill>
+                      <a:prstDash val="solid"/>
+                      <a:round/>
+                      <a:headEnd type="none" w="med" len="med"/>
+                      <a:tailEnd type="none" w="med" len="med"/>
+                    </a:lnB>
+                    <a:solidFill>
+                      <a:srgbClr val="E8F3EC"/>
+                    </a:solidFill>
+                  </a:tcPr>
+                </a:tc>
+                <a:tc>
+                  <a:txBody>
+                    <a:bodyPr/>
+                    <a:lstStyle/>
+                    <a:p>
+                      <a:pPr algn="ctr" indent="0" marL="0">
+                        <a:buNone/>
+                      </a:pPr>
+                      <a:r>
+                        <a:rPr lang="en-US" sz="950" dirty="0">
+                          <a:solidFill>
+                            <a:srgbClr val="1B1714"/>
+                          </a:solidFill>
+                          <a:latin typeface="IBM Plex Mono" pitchFamily="34" charset="0"/>
+                          <a:ea typeface="IBM Plex Mono" pitchFamily="34" charset="-122"/>
+                          <a:cs typeface="IBM Plex Mono" pitchFamily="34" charset="-120"/>
+                        </a:rPr>
+                        <a:t>20%</a:t>
+                      </a:r>
+                      <a:endParaRPr lang="en-US" sz="950" dirty="0">
+                        <a:latin typeface="IBM Plex Mono" charset="0"/>
+                        <a:ea typeface="IBM Plex Mono" charset="0"/>
+                        <a:cs typeface="IBM Plex Mono" charset="0"/>
+                      </a:endParaRPr>
+                    </a:p>
+                  </a:txBody>
+                  <a:tcPr marL="63500" marR="63500" marT="25400" marB="25400" anchor="ctr">
+                    <a:lnL w="6350" cap="flat" cmpd="sng" algn="ctr">
+                      <a:solidFill>
+                        <a:srgbClr val="E4DED4"/>
+                      </a:solidFill>
+                      <a:prstDash val="solid"/>
+                      <a:round/>
+                      <a:headEnd type="none" w="med" len="med"/>
+                      <a:tailEnd type="none" w="med" len="med"/>
+                    </a:lnL>
+                    <a:lnR w="6350" cap="flat" cmpd="sng" algn="ctr">
+                      <a:solidFill>
+                        <a:srgbClr val="E4DED4"/>
+                      </a:solidFill>
+                      <a:prstDash val="solid"/>
+                      <a:round/>
+                      <a:headEnd type="none" w="med" len="med"/>
+                      <a:tailEnd type="none" w="med" len="med"/>
+                    </a:lnR>
+                    <a:lnT w="6350" cap="flat" cmpd="sng" algn="ctr">
+                      <a:solidFill>
+                        <a:srgbClr val="E4DED4"/>
+                      </a:solidFill>
+                      <a:prstDash val="solid"/>
+                      <a:round/>
+                      <a:headEnd type="none" w="med" len="med"/>
+                      <a:tailEnd type="none" w="med" len="med"/>
+                    </a:lnT>
+                    <a:lnB w="6350" cap="flat" cmpd="sng" algn="ctr">
+                      <a:solidFill>
+                        <a:srgbClr val="E4DED4"/>
+                      </a:solidFill>
+                      <a:prstDash val="solid"/>
+                      <a:round/>
+                      <a:headEnd type="none" w="med" len="med"/>
+                      <a:tailEnd type="none" w="med" len="med"/>
+                    </a:lnB>
+                    <a:solidFill>
+                      <a:srgbClr val="E8F3EC"/>
+                    </a:solidFill>
+                  </a:tcPr>
+                </a:tc>
+                <a:tc>
+                  <a:txBody>
+                    <a:bodyPr/>
+                    <a:lstStyle/>
+                    <a:p>
+                      <a:pPr algn="ctr" indent="0" marL="0">
+                        <a:buNone/>
+                      </a:pPr>
+                      <a:r>
+                        <a:rPr lang="en-US" sz="950" dirty="0">
+                          <a:solidFill>
+                            <a:srgbClr val="1B1714"/>
+                          </a:solidFill>
+                          <a:latin typeface="IBM Plex Mono" pitchFamily="34" charset="0"/>
+                          <a:ea typeface="IBM Plex Mono" pitchFamily="34" charset="-122"/>
+                          <a:cs typeface="IBM Plex Mono" pitchFamily="34" charset="-120"/>
+                        </a:rPr>
                         <a:t>49%</a:t>
                       </a:r>
                       <a:endParaRPr lang="en-US" sz="950" dirty="0">
@@ -10849,13 +10849,13 @@
                       <a:r>
                         <a:rPr lang="en-US" sz="1200" b="1" dirty="0">
                           <a:solidFill>
-                            <a:srgbClr val="C1121F"/>
+                            <a:srgbClr val="1E7A4D"/>
                           </a:solidFill>
                           <a:latin typeface="Space Grotesk" pitchFamily="34" charset="0"/>
                           <a:ea typeface="Space Grotesk" pitchFamily="34" charset="-122"/>
                           <a:cs typeface="Space Grotesk" pitchFamily="34" charset="-120"/>
                         </a:rPr>
-                        <a:t>13.5x</a:t>
+                        <a:t>9.3x</a:t>
                       </a:r>
                       <a:endParaRPr lang="en-US" sz="1200" dirty="0">
                         <a:latin typeface="Space Grotesk" charset="0"/>
@@ -10917,7 +10917,7 @@
                       <a:r>
                         <a:rPr lang="en-US" sz="800" b="1" dirty="0">
                           <a:solidFill>
-                            <a:srgbClr val="6F6960"/>
+                            <a:srgbClr val="1E7A4D"/>
                           </a:solidFill>
                           <a:latin typeface="IBM Plex Mono" pitchFamily="34" charset="0"/>
                           <a:ea typeface="IBM Plex Mono" pitchFamily="34" charset="-122"/>
@@ -11012,7 +11012,7 @@
                 <a:ea typeface="IBM Plex Sans KR" pitchFamily="34" charset="-122"/>
                 <a:cs typeface="IBM Plex Sans KR" pitchFamily="34" charset="-120"/>
               </a:rPr>
-              <a:t>필요EBITDA% = 딜을 peer 하단(13x)에 맞추는 데 필요한 ex-AMPC 마진 · 현 9% 대비 전 시나리오 미달(9.3~11.4%) → 마진 개선 必</a:t>
+              <a:t>필요EBITDA% = 딜을 peer 하단(13x)에 맞추는 데 필요한 ex-AMPC 마진 · 현 13% 마진이 전 시나리오(9.3~11.4%)를 상회 → 전부 성립</a:t>
             </a:r>
             <a:endParaRPr lang="en-US" sz="750" dirty="0"/>
           </a:p>
@@ -11051,7 +11051,7 @@
                 <a:ea typeface="IBM Plex Mono" pitchFamily="34" charset="-122"/>
                 <a:cs typeface="IBM Plex Mono" pitchFamily="34" charset="-120"/>
               </a:rPr>
-              <a:t>peer 밴드(보수 8~13x) 대비 — 전 시나리오 초과</a:t>
+              <a:t>peer 밴드(보수 8~13x) 대비 — 전 시나리오 밴드 내</a:t>
             </a:r>
             <a:endParaRPr lang="en-US" sz="850" dirty="0"/>
           </a:p>
@@ -11089,7 +11089,7 @@
         <p:spPr>
           <a:xfrm>
             <a:off x="4178808" y="4992624"/>
-            <a:ext cx="2674620" cy="164592"/>
+            <a:ext cx="5349240" cy="164592"/>
           </a:xfrm>
           <a:prstGeom prst="rect">
             <a:avLst/>
@@ -11114,7 +11114,7 @@
         <p:spPr>
           <a:xfrm>
             <a:off x="4178808" y="4764024"/>
-            <a:ext cx="2674620" cy="182880"/>
+            <a:ext cx="5349240" cy="182880"/>
           </a:xfrm>
           <a:prstGeom prst="rect">
             <a:avLst/>
@@ -11152,20 +11152,18 @@
         </p:nvSpPr>
         <p:spPr>
           <a:xfrm>
-            <a:off x="7120890" y="4855464"/>
-            <a:ext cx="1604772" cy="0"/>
+            <a:off x="5569610" y="4855464"/>
+            <a:ext cx="2246681" cy="0"/>
           </a:xfrm>
           <a:prstGeom prst="line">
             <a:avLst/>
           </a:prstGeom>
           <a:noFill/>
-          <a:ln w="15875">
+          <a:ln w="25400">
             <a:solidFill>
-              <a:srgbClr val="FF8E84"/>
+              <a:srgbClr val="1E7A4D"/>
             </a:solidFill>
             <a:prstDash val="solid"/>
-            <a:headEnd type="none"/>
-            <a:tailEnd type="triangle"/>
           </a:ln>
         </p:spPr>
       </p:sp>
@@ -11177,8 +11175,8 @@
         </p:nvSpPr>
         <p:spPr>
           <a:xfrm>
-            <a:off x="6663690" y="4672584"/>
-            <a:ext cx="2519172" cy="164592"/>
+            <a:off x="5020970" y="4672584"/>
+            <a:ext cx="3343961" cy="164592"/>
           </a:xfrm>
           <a:prstGeom prst="rect">
             <a:avLst/>
@@ -11194,15 +11192,15 @@
               <a:buNone/>
             </a:pPr>
             <a:r>
-              <a:rPr lang="en-US" sz="700" dirty="0">
-                <a:solidFill>
-                  <a:srgbClr val="FF8E84"/>
+              <a:rPr lang="en-US" sz="700" b="1" dirty="0">
+                <a:solidFill>
+                  <a:srgbClr val="1E7A4D"/>
                 </a:solidFill>
                 <a:latin typeface="IBM Plex Mono" pitchFamily="34" charset="0"/>
                 <a:ea typeface="IBM Plex Mono" pitchFamily="34" charset="-122"/>
                 <a:cs typeface="IBM Plex Mono" pitchFamily="34" charset="-120"/>
               </a:rPr>
-              <a:t>조달 레버 −3.0x → 밴드 상단 진입</a:t>
+              <a:t>전 시나리오 밴드 내 (9.3~11.4x)</a:t>
             </a:r>
             <a:endParaRPr lang="en-US" sz="700" dirty="0"/>
           </a:p>
@@ -11216,14 +11214,14 @@
         </p:nvSpPr>
         <p:spPr>
           <a:xfrm>
-            <a:off x="8679942" y="5029200"/>
+            <a:off x="7770571" y="5029200"/>
             <a:ext cx="91440" cy="91440"/>
           </a:xfrm>
           <a:prstGeom prst="ellipse">
             <a:avLst/>
           </a:prstGeom>
           <a:solidFill>
-            <a:srgbClr val="C1121F"/>
+            <a:srgbClr val="1E7A4D"/>
           </a:solidFill>
           <a:ln/>
         </p:spPr>
@@ -11236,7 +11234,7 @@
         </p:nvSpPr>
         <p:spPr>
           <a:xfrm>
-            <a:off x="8085582" y="5166360"/>
+            <a:off x="7176211" y="5166360"/>
             <a:ext cx="1280160" cy="182880"/>
           </a:xfrm>
           <a:prstGeom prst="rect">
@@ -11255,13 +11253,13 @@
             <a:r>
               <a:rPr lang="en-US" sz="750" b="1" dirty="0">
                 <a:solidFill>
-                  <a:srgbClr val="C1121F"/>
+                  <a:srgbClr val="1E7A4D"/>
                 </a:solidFill>
                 <a:latin typeface="IBM Plex Mono" pitchFamily="34" charset="0"/>
                 <a:ea typeface="IBM Plex Mono" pitchFamily="34" charset="-122"/>
                 <a:cs typeface="IBM Plex Mono" pitchFamily="34" charset="-120"/>
               </a:rPr>
-              <a:t>BASE 16.5x</a:t>
+              <a:t>BASE 11.4x</a:t>
             </a:r>
             <a:endParaRPr lang="en-US" sz="750" dirty="0"/>
           </a:p>
@@ -11275,47 +11273,7 @@
         </p:nvSpPr>
         <p:spPr>
           <a:xfrm>
-            <a:off x="7931048" y="5029200"/>
-            <a:ext cx="91440" cy="91440"/>
-          </a:xfrm>
-          <a:prstGeom prst="ellipse">
-            <a:avLst/>
-          </a:prstGeom>
-          <a:solidFill>
-            <a:srgbClr val="C1121F"/>
-          </a:solidFill>
-          <a:ln/>
-        </p:spPr>
-      </p:sp>
-      <p:sp>
-        <p:nvSpPr>
-          <p:cNvPr id="50" name="Shape 47"/>
-          <p:cNvSpPr/>
-          <p:nvPr/>
-        </p:nvSpPr>
-        <p:spPr>
-          <a:xfrm>
-            <a:off x="7342632" y="5029200"/>
-            <a:ext cx="91440" cy="91440"/>
-          </a:xfrm>
-          <a:prstGeom prst="ellipse">
-            <a:avLst/>
-          </a:prstGeom>
-          <a:solidFill>
-            <a:srgbClr val="8A5A55"/>
-          </a:solidFill>
-          <a:ln/>
-        </p:spPr>
-      </p:sp>
-      <p:sp>
-        <p:nvSpPr>
-          <p:cNvPr id="51" name="Shape 48"/>
-          <p:cNvSpPr/>
-          <p:nvPr/>
-        </p:nvSpPr>
-        <p:spPr>
-          <a:xfrm>
-            <a:off x="7075170" y="5029200"/>
+            <a:off x="6807708" y="5029200"/>
             <a:ext cx="91440" cy="91440"/>
           </a:xfrm>
           <a:prstGeom prst="ellipse">
@@ -11329,13 +11287,53 @@
       </p:sp>
       <p:sp>
         <p:nvSpPr>
+          <p:cNvPr id="50" name="Shape 47"/>
+          <p:cNvSpPr/>
+          <p:nvPr/>
+        </p:nvSpPr>
+        <p:spPr>
+          <a:xfrm>
+            <a:off x="5951830" y="5029200"/>
+            <a:ext cx="91440" cy="91440"/>
+          </a:xfrm>
+          <a:prstGeom prst="ellipse">
+            <a:avLst/>
+          </a:prstGeom>
+          <a:solidFill>
+            <a:srgbClr val="1E7A4D"/>
+          </a:solidFill>
+          <a:ln/>
+        </p:spPr>
+      </p:sp>
+      <p:sp>
+        <p:nvSpPr>
+          <p:cNvPr id="51" name="Shape 48"/>
+          <p:cNvSpPr/>
+          <p:nvPr/>
+        </p:nvSpPr>
+        <p:spPr>
+          <a:xfrm>
+            <a:off x="5523890" y="5029200"/>
+            <a:ext cx="91440" cy="91440"/>
+          </a:xfrm>
+          <a:prstGeom prst="ellipse">
+            <a:avLst/>
+          </a:prstGeom>
+          <a:solidFill>
+            <a:srgbClr val="1E7A4D"/>
+          </a:solidFill>
+          <a:ln/>
+        </p:spPr>
+      </p:sp>
+      <p:sp>
+        <p:nvSpPr>
           <p:cNvPr id="52" name="Text 49"/>
           <p:cNvSpPr/>
           <p:nvPr/>
         </p:nvSpPr>
         <p:spPr>
           <a:xfrm>
-            <a:off x="6480810" y="5166360"/>
+            <a:off x="4929530" y="5166360"/>
             <a:ext cx="1280160" cy="182880"/>
           </a:xfrm>
           <a:prstGeom prst="rect">
@@ -11360,7 +11358,7 @@
                 <a:ea typeface="IBM Plex Mono" pitchFamily="34" charset="-122"/>
                 <a:cs typeface="IBM Plex Mono" pitchFamily="34" charset="-120"/>
               </a:rPr>
-              <a:t>최대 13.5x</a:t>
+              <a:t>최대 9.3x</a:t>
             </a:r>
             <a:endParaRPr lang="en-US" sz="750" dirty="0"/>
           </a:p>
@@ -11413,7 +11411,7 @@
         </p:nvSpPr>
         <p:spPr>
           <a:xfrm>
-            <a:off x="5509260" y="5330952"/>
+            <a:off x="4974336" y="5330952"/>
             <a:ext cx="548640" cy="164592"/>
           </a:xfrm>
           <a:prstGeom prst="rect">
@@ -11438,7 +11436,7 @@
                 <a:ea typeface="IBM Plex Mono" pitchFamily="34" charset="-122"/>
                 <a:cs typeface="IBM Plex Mono" pitchFamily="34" charset="-120"/>
               </a:rPr>
-              <a:t>11x</a:t>
+              <a:t>9x</a:t>
             </a:r>
             <a:endParaRPr lang="en-US" sz="700" dirty="0"/>
           </a:p>
@@ -11452,7 +11450,7 @@
         </p:nvSpPr>
         <p:spPr>
           <a:xfrm>
-            <a:off x="6579108" y="5330952"/>
+            <a:off x="6044184" y="5330952"/>
             <a:ext cx="548640" cy="164592"/>
           </a:xfrm>
           <a:prstGeom prst="rect">
@@ -11477,7 +11475,7 @@
                 <a:ea typeface="IBM Plex Mono" pitchFamily="34" charset="-122"/>
                 <a:cs typeface="IBM Plex Mono" pitchFamily="34" charset="-120"/>
               </a:rPr>
-              <a:t>13x</a:t>
+              <a:t>10x</a:t>
             </a:r>
             <a:endParaRPr lang="en-US" sz="700" dirty="0"/>
           </a:p>
@@ -11491,7 +11489,7 @@
         </p:nvSpPr>
         <p:spPr>
           <a:xfrm>
-            <a:off x="7648956" y="5330952"/>
+            <a:off x="7114032" y="5330952"/>
             <a:ext cx="548640" cy="164592"/>
           </a:xfrm>
           <a:prstGeom prst="rect">
@@ -11516,7 +11514,7 @@
                 <a:ea typeface="IBM Plex Mono" pitchFamily="34" charset="-122"/>
                 <a:cs typeface="IBM Plex Mono" pitchFamily="34" charset="-120"/>
               </a:rPr>
-              <a:t>15x</a:t>
+              <a:t>11x</a:t>
             </a:r>
             <a:endParaRPr lang="en-US" sz="700" dirty="0"/>
           </a:p>
@@ -11530,7 +11528,7 @@
         </p:nvSpPr>
         <p:spPr>
           <a:xfrm>
-            <a:off x="8718804" y="5330952"/>
+            <a:off x="8183880" y="5330952"/>
             <a:ext cx="548640" cy="164592"/>
           </a:xfrm>
           <a:prstGeom prst="rect">
@@ -11555,7 +11553,7 @@
                 <a:ea typeface="IBM Plex Mono" pitchFamily="34" charset="-122"/>
                 <a:cs typeface="IBM Plex Mono" pitchFamily="34" charset="-120"/>
               </a:rPr>
-              <a:t>17x</a:t>
+              <a:t>12x</a:t>
             </a:r>
             <a:endParaRPr lang="en-US" sz="700" dirty="0"/>
           </a:p>
@@ -11563,7 +11561,46 @@
       </p:sp>
       <p:sp>
         <p:nvSpPr>
-          <p:cNvPr id="58" name="Shape 55"/>
+          <p:cNvPr id="58" name="Text 55"/>
+          <p:cNvSpPr/>
+          <p:nvPr/>
+        </p:nvSpPr>
+        <p:spPr>
+          <a:xfrm>
+            <a:off x="9253728" y="5330952"/>
+            <a:ext cx="548640" cy="164592"/>
+          </a:xfrm>
+          <a:prstGeom prst="rect">
+            <a:avLst/>
+          </a:prstGeom>
+          <a:noFill/>
+          <a:ln/>
+        </p:spPr>
+        <p:txBody>
+          <a:bodyPr wrap="square" lIns="0" tIns="0" rIns="0" bIns="0" rtlCol="0" anchor="ctr"/>
+          <a:lstStyle/>
+          <a:p>
+            <a:pPr algn="ctr" indent="0" marL="0">
+              <a:buNone/>
+            </a:pPr>
+            <a:r>
+              <a:rPr lang="en-US" sz="700" dirty="0">
+                <a:solidFill>
+                  <a:srgbClr val="9A847C"/>
+                </a:solidFill>
+                <a:latin typeface="IBM Plex Mono" pitchFamily="34" charset="0"/>
+                <a:ea typeface="IBM Plex Mono" pitchFamily="34" charset="-122"/>
+                <a:cs typeface="IBM Plex Mono" pitchFamily="34" charset="-120"/>
+              </a:rPr>
+              <a:t>13x</a:t>
+            </a:r>
+            <a:endParaRPr lang="en-US" sz="700" dirty="0"/>
+          </a:p>
+        </p:txBody>
+      </p:sp>
+      <p:sp>
+        <p:nvSpPr>
+          <p:cNvPr id="59" name="Shape 56"/>
           <p:cNvSpPr/>
           <p:nvPr/>
         </p:nvSpPr>
@@ -11585,7 +11622,7 @@
       </p:sp>
       <p:sp>
         <p:nvSpPr>
-          <p:cNvPr id="59" name="Text 56"/>
+          <p:cNvPr id="60" name="Text 57"/>
           <p:cNvSpPr/>
           <p:nvPr/>
         </p:nvSpPr>
@@ -11616,7 +11653,7 @@
                 <a:ea typeface="Noto Serif KR" pitchFamily="34" charset="-122"/>
                 <a:cs typeface="Noto Serif KR" pitchFamily="34" charset="-120"/>
               </a:rPr>
-              <a:t>결론 — BA 18GW: 최대결합만 정상화 peer 밴드 하단에 진입</a:t>
+              <a:t>결론 — ex-AMPC EBITDA 13%면 전 시나리오가 peer 밴드에 든다</a:t>
             </a:r>
             <a:endParaRPr lang="en-US" sz="1300" dirty="0"/>
           </a:p>
@@ -11624,7 +11661,7 @@
       </p:sp>
       <p:sp>
         <p:nvSpPr>
-          <p:cNvPr id="60" name="Text 57"/>
+          <p:cNvPr id="61" name="Text 58"/>
           <p:cNvSpPr/>
           <p:nvPr/>
         </p:nvSpPr>
@@ -11658,7 +11695,7 @@
                 <a:ea typeface="IBM Plex Sans KR" pitchFamily="34" charset="-122"/>
                 <a:cs typeface="IBM Plex Sans KR" pitchFamily="34" charset="-120"/>
               </a:rPr>
-              <a:t>BA를 18GW로 축소하면 run-rate ex-AMPC EBITDA가 </a:t>
+              <a:t>ex-AMPC EBITDA 마진을 9%→13%로 올리면 run-rate EBITDA가 </a:t>
             </a:r>
             <a:pPr indent="0" marL="0">
               <a:lnSpc>
@@ -11669,13 +11706,13 @@
             <a:r>
               <a:rPr lang="en-US" sz="950" b="1" dirty="0">
                 <a:solidFill>
-                  <a:srgbClr val="FF8E84"/>
+                  <a:srgbClr val="86D6A6"/>
                 </a:solidFill>
                 <a:latin typeface="IBM Plex Sans KR" pitchFamily="34" charset="0"/>
                 <a:ea typeface="IBM Plex Sans KR" pitchFamily="34" charset="-122"/>
                 <a:cs typeface="IBM Plex Sans KR" pitchFamily="34" charset="-120"/>
               </a:rPr>
-              <a:t>$554→$518mm</a:t>
+              <a:t>$518→$748mm</a:t>
             </a:r>
             <a:pPr indent="0" marL="0">
               <a:lnSpc>
@@ -11692,7 +11729,7 @@
                 <a:ea typeface="IBM Plex Sans KR" pitchFamily="34" charset="-122"/>
                 <a:cs typeface="IBM Plex Sans KR" pitchFamily="34" charset="-120"/>
               </a:rPr>
-              <a:t>로 줄어 역산 필요 멀티플이 </a:t>
+              <a:t>로 커져 역산 필요 멀티플이 </a:t>
             </a:r>
             <a:pPr indent="0" marL="0">
               <a:lnSpc>
@@ -11703,13 +11740,13 @@
             <a:r>
               <a:rPr lang="en-US" sz="950" b="1" dirty="0">
                 <a:solidFill>
-                  <a:srgbClr val="FF8E84"/>
+                  <a:srgbClr val="86D6A6"/>
                 </a:solidFill>
                 <a:latin typeface="IBM Plex Sans KR" pitchFamily="34" charset="0"/>
                 <a:ea typeface="IBM Plex Sans KR" pitchFamily="34" charset="-122"/>
                 <a:cs typeface="IBM Plex Sans KR" pitchFamily="34" charset="-120"/>
               </a:rPr>
-              <a:t>BASE 16.5x → 최대결합 13.5x</a:t>
+              <a:t>BASE 11.4x → 최대결합 9.3x</a:t>
             </a:r>
             <a:pPr indent="0" marL="0">
               <a:lnSpc>
@@ -11726,7 +11763,7 @@
                 <a:ea typeface="IBM Plex Sans KR" pitchFamily="34" charset="-122"/>
                 <a:cs typeface="IBM Plex Sans KR" pitchFamily="34" charset="-120"/>
               </a:rPr>
-              <a:t>로 상승. 그랜트20+희석49(최대결합)면 13.5x로 </a:t>
+              <a:t>로 하락, </a:t>
             </a:r>
             <a:pPr indent="0" marL="0">
               <a:lnSpc>
@@ -11737,13 +11774,13 @@
             <a:r>
               <a:rPr lang="en-US" sz="950" b="1" dirty="0">
                 <a:solidFill>
-                  <a:srgbClr val="FF8E84"/>
+                  <a:srgbClr val="86D6A6"/>
                 </a:solidFill>
                 <a:latin typeface="IBM Plex Sans KR" pitchFamily="34" charset="0"/>
                 <a:ea typeface="IBM Plex Sans KR" pitchFamily="34" charset="-122"/>
                 <a:cs typeface="IBM Plex Sans KR" pitchFamily="34" charset="-120"/>
               </a:rPr>
-              <a:t>정상화 peer(13~15x) 하단 진입, BASE는 16.5x로 초과</a:t>
+              <a:t>전 시나리오가 peer 밴드(8~13x) 내</a:t>
             </a:r>
             <a:pPr indent="0" marL="0">
               <a:lnSpc>
@@ -11760,7 +11797,7 @@
                 <a:ea typeface="IBM Plex Sans KR" pitchFamily="34" charset="-122"/>
                 <a:cs typeface="IBM Plex Sans KR" pitchFamily="34" charset="-120"/>
               </a:rPr>
-              <a:t>(2029E 분모면 16.6~20.3x). DCF 내재 </a:t>
+              <a:t>(2029E 분모면 11.5~14.0x). DCF 내재 </a:t>
             </a:r>
             <a:pPr indent="0" marL="0">
               <a:lnSpc>
@@ -11777,7 +11814,7 @@
                 <a:ea typeface="IBM Plex Sans KR" pitchFamily="34" charset="-122"/>
                 <a:cs typeface="IBM Plex Sans KR" pitchFamily="34" charset="-120"/>
               </a:rPr>
-              <a:t>8.5x는 여전히 할인</a:t>
+              <a:t>8.1x</a:t>
             </a:r>
             <a:pPr indent="0" marL="0">
               <a:lnSpc>
@@ -11794,7 +11831,7 @@
                 <a:ea typeface="IBM Plex Sans KR" pitchFamily="34" charset="-122"/>
                 <a:cs typeface="IBM Plex Sans KR" pitchFamily="34" charset="-120"/>
               </a:rPr>
-              <a:t>. 규모 축소가 지분조달 여력 악화 → 마진 개선(</a:t>
+              <a:t>. AMPC 비중도 </a:t>
             </a:r>
             <a:pPr indent="0" marL="0">
               <a:lnSpc>
@@ -11811,7 +11848,7 @@
                 <a:ea typeface="IBM Plex Sans KR" pitchFamily="34" charset="-122"/>
                 <a:cs typeface="IBM Plex Sans KR" pitchFamily="34" charset="-120"/>
               </a:rPr>
-              <a:t>필요 EBITDA% 9.3~11.4%</a:t>
+              <a:t>76→55%</a:t>
             </a:r>
             <a:pPr indent="0" marL="0">
               <a:lnSpc>
@@ -11828,7 +11865,7 @@
                 <a:ea typeface="IBM Plex Sans KR" pitchFamily="34" charset="-122"/>
                 <a:cs typeface="IBM Plex Sans KR" pitchFamily="34" charset="-120"/>
               </a:rPr>
-              <a:t>)이 관건. WACC10.5%·TGR2%·순차입 $6.4bn ★</a:t>
+              <a:t>로 낮아져 사업 자생력↑ — 마진이 딜 성립의 핵심 레버. WACC10.5%·TGR2%·순차입 $6.4bn ★</a:t>
             </a:r>
             <a:endParaRPr lang="en-US" sz="950" dirty="0"/>
           </a:p>
@@ -11836,7 +11873,7 @@
       </p:sp>
       <p:sp>
         <p:nvSpPr>
-          <p:cNvPr id="61" name="Shape 58"/>
+          <p:cNvPr id="62" name="Shape 59"/>
           <p:cNvSpPr/>
           <p:nvPr/>
         </p:nvSpPr>
@@ -11859,7 +11896,7 @@
       </p:sp>
       <p:sp>
         <p:nvSpPr>
-          <p:cNvPr id="62" name="Text 59"/>
+          <p:cNvPr id="63" name="Text 60"/>
           <p:cNvSpPr/>
           <p:nvPr/>
         </p:nvSpPr>
@@ -11898,7 +11935,7 @@
       </p:sp>
       <p:sp>
         <p:nvSpPr>
-          <p:cNvPr id="63" name="Text 60"/>
+          <p:cNvPr id="64" name="Text 61"/>
           <p:cNvSpPr/>
           <p:nvPr/>
         </p:nvSpPr>
@@ -14148,7 +14185,7 @@
                           <a:ea typeface="IBM Plex Mono" pitchFamily="34" charset="-122"/>
                           <a:cs typeface="IBM Plex Mono" pitchFamily="34" charset="-120"/>
                         </a:rPr>
-                        <a:t>$518mm</a:t>
+                        <a:t>$748mm</a:t>
                       </a:r>
                       <a:endParaRPr lang="en-US" sz="950" dirty="0">
                         <a:latin typeface="IBM Plex Mono" charset="0"/>
@@ -14216,7 +14253,7 @@
                           <a:ea typeface="Space Grotesk" pitchFamily="34" charset="-122"/>
                           <a:cs typeface="Space Grotesk" pitchFamily="34" charset="-120"/>
                         </a:rPr>
-                        <a:t>8.5x</a:t>
+                        <a:t>8.1x</a:t>
                       </a:r>
                       <a:endParaRPr lang="en-US" sz="1150" dirty="0">
                         <a:latin typeface="Space Grotesk" charset="0"/>
@@ -14284,7 +14321,7 @@
                           <a:ea typeface="IBM Plex Mono" pitchFamily="34" charset="-122"/>
                           <a:cs typeface="IBM Plex Mono" pitchFamily="34" charset="-120"/>
                         </a:rPr>
-                        <a:t>13.5~16.5x</a:t>
+                        <a:t>9.3~11.4x</a:t>
                       </a:r>
                       <a:endParaRPr lang="en-US" sz="950" dirty="0">
                         <a:latin typeface="IBM Plex Mono" charset="0"/>
@@ -14422,7 +14459,7 @@
                           <a:ea typeface="IBM Plex Mono" pitchFamily="34" charset="-122"/>
                           <a:cs typeface="IBM Plex Mono" pitchFamily="34" charset="-120"/>
                         </a:rPr>
-                        <a:t>$421mm</a:t>
+                        <a:t>$607mm</a:t>
                       </a:r>
                       <a:endParaRPr lang="en-US" sz="950" dirty="0">
                         <a:latin typeface="IBM Plex Mono" charset="0"/>
@@ -14490,7 +14527,7 @@
                           <a:ea typeface="Space Grotesk" pitchFamily="34" charset="-122"/>
                           <a:cs typeface="Space Grotesk" pitchFamily="34" charset="-120"/>
                         </a:rPr>
-                        <a:t>10.5x</a:t>
+                        <a:t>9.9x</a:t>
                       </a:r>
                       <a:endParaRPr lang="en-US" sz="1150" dirty="0">
                         <a:latin typeface="Space Grotesk" charset="0"/>
@@ -14558,7 +14595,7 @@
                           <a:ea typeface="IBM Plex Mono" pitchFamily="34" charset="-122"/>
                           <a:cs typeface="IBM Plex Mono" pitchFamily="34" charset="-120"/>
                         </a:rPr>
-                        <a:t>16.6~20.3x</a:t>
+                        <a:t>11.5~14.0x</a:t>
                       </a:r>
                       <a:endParaRPr lang="en-US" sz="950" dirty="0">
                         <a:latin typeface="IBM Plex Mono" charset="0"/>
@@ -14711,7 +14748,7 @@
                 <a:ea typeface="IBM Plex Sans KR" pitchFamily="34" charset="-122"/>
                 <a:cs typeface="IBM Plex Sans KR" pitchFamily="34" charset="-120"/>
               </a:rPr>
-              <a:t>× $518mm  → EV $6.7bn  </a:t>
+              <a:t>× $748mm  → EV $9.7bn  </a:t>
             </a:r>
             <a:pPr indent="0" marL="0">
               <a:lnSpc>
@@ -14728,7 +14765,7 @@
                 <a:ea typeface="IBM Plex Sans KR" pitchFamily="34" charset="-122"/>
                 <a:cs typeface="IBM Plex Sans KR" pitchFamily="34" charset="-120"/>
               </a:rPr>
-              <a:t>지분 +$0.3bn
+              <a:t>지분 +$3.3bn
 </a:t>
             </a:r>
             <a:pPr indent="0" marL="0">
@@ -14746,7 +14783,7 @@
                 <a:ea typeface="IBM Plex Sans KR" pitchFamily="34" charset="-122"/>
                 <a:cs typeface="IBM Plex Sans KR" pitchFamily="34" charset="-120"/>
               </a:rPr>
-              <a:t>× $421mm  → EV $5.5bn  </a:t>
+              <a:t>× $607mm  → EV $7.9bn  </a:t>
             </a:r>
             <a:pPr indent="0" marL="0">
               <a:lnSpc>
@@ -14757,13 +14794,13 @@
             <a:r>
               <a:rPr lang="en-US" sz="1000" b="1" dirty="0">
                 <a:solidFill>
-                  <a:srgbClr val="FF8E84"/>
+                  <a:srgbClr val="86D6A6"/>
                 </a:solidFill>
                 <a:latin typeface="IBM Plex Sans KR" pitchFamily="34" charset="0"/>
                 <a:ea typeface="IBM Plex Sans KR" pitchFamily="34" charset="-122"/>
                 <a:cs typeface="IBM Plex Sans KR" pitchFamily="34" charset="-120"/>
               </a:rPr>
-              <a:t>지분 −$0.9bn</a:t>
+              <a:t>지분 +$1.5bn</a:t>
             </a:r>
             <a:endParaRPr lang="en-US" sz="1000" dirty="0"/>
           </a:p>
@@ -14802,7 +14839,7 @@
                 <a:ea typeface="IBM Plex Mono" pitchFamily="34" charset="-122"/>
                 <a:cs typeface="IBM Plex Mono" pitchFamily="34" charset="-120"/>
               </a:rPr>
-              <a:t>풋볼필드 — 내재 EV ($bn) · run-rate $518mm 기준 · 보수/정상화 peer vs 역산 필요</a:t>
+              <a:t>풋볼필드 — 내재 EV ($bn) · run-rate $748mm 기준 · 보수/정상화 peer vs 역산 필요</a:t>
             </a:r>
             <a:endParaRPr lang="en-US" sz="850" dirty="0"/>
           </a:p>
@@ -14839,8 +14876,8 @@
         </p:nvSpPr>
         <p:spPr>
           <a:xfrm>
-            <a:off x="2345893" y="5394960"/>
-            <a:ext cx="3730066" cy="182880"/>
+            <a:off x="1913839" y="5394960"/>
+            <a:ext cx="4616806" cy="182880"/>
           </a:xfrm>
           <a:prstGeom prst="rect">
             <a:avLst/>
@@ -14864,8 +14901,8 @@
         </p:nvSpPr>
         <p:spPr>
           <a:xfrm>
-            <a:off x="2345893" y="5605272"/>
-            <a:ext cx="3730066" cy="182880"/>
+            <a:off x="1913839" y="5605272"/>
+            <a:ext cx="4616806" cy="182880"/>
           </a:xfrm>
           <a:prstGeom prst="rect">
             <a:avLst/>
@@ -14889,7 +14926,7 @@
                 <a:ea typeface="IBM Plex Mono" pitchFamily="34" charset="-122"/>
                 <a:cs typeface="IBM Plex Mono" pitchFamily="34" charset="-120"/>
               </a:rPr>
-              <a:t>보수 8~13x  $4.1~6.7bn</a:t>
+              <a:t>보수 8~13x  $6.0~9.7bn</a:t>
             </a:r>
             <a:endParaRPr lang="en-US" sz="750" dirty="0"/>
           </a:p>
@@ -14903,8 +14940,8 @@
         </p:nvSpPr>
         <p:spPr>
           <a:xfrm>
-            <a:off x="6075959" y="5394960"/>
-            <a:ext cx="1497787" cy="182880"/>
+            <a:off x="6530645" y="5394960"/>
+            <a:ext cx="1851660" cy="182880"/>
           </a:xfrm>
           <a:prstGeom prst="rect">
             <a:avLst/>
@@ -14928,8 +14965,8 @@
         </p:nvSpPr>
         <p:spPr>
           <a:xfrm>
-            <a:off x="5801639" y="5175504"/>
-            <a:ext cx="2320747" cy="182880"/>
+            <a:off x="6256325" y="5175504"/>
+            <a:ext cx="2674620" cy="182880"/>
           </a:xfrm>
           <a:prstGeom prst="rect">
             <a:avLst/>
@@ -14953,7 +14990,7 @@
                 <a:ea typeface="IBM Plex Mono" pitchFamily="34" charset="-122"/>
                 <a:cs typeface="IBM Plex Mono" pitchFamily="34" charset="-120"/>
               </a:rPr>
-              <a:t>정상화 13~15x  $6.7~7.8bn</a:t>
+              <a:t>정상화 13~15x  $9.7~11.2bn</a:t>
             </a:r>
             <a:endParaRPr lang="en-US" sz="750" dirty="0"/>
           </a:p>
@@ -14967,8 +15004,8 @@
         </p:nvSpPr>
         <p:spPr>
           <a:xfrm>
-            <a:off x="6450406" y="5212080"/>
-            <a:ext cx="2246681" cy="0"/>
+            <a:off x="3123590" y="5212080"/>
+            <a:ext cx="1938071" cy="0"/>
           </a:xfrm>
           <a:prstGeom prst="line">
             <a:avLst/>
@@ -14990,8 +15027,8 @@
         </p:nvSpPr>
         <p:spPr>
           <a:xfrm>
-            <a:off x="6176086" y="5010912"/>
-            <a:ext cx="3069641" cy="182880"/>
+            <a:off x="2849270" y="5010912"/>
+            <a:ext cx="2761031" cy="182880"/>
           </a:xfrm>
           <a:prstGeom prst="rect">
             <a:avLst/>
@@ -15015,7 +15052,7 @@
                 <a:ea typeface="IBM Plex Mono" pitchFamily="34" charset="-122"/>
                 <a:cs typeface="IBM Plex Mono" pitchFamily="34" charset="-120"/>
               </a:rPr>
-              <a:t>역산 필요 13.5~16.5x</a:t>
+              <a:t>역산 필요 9.3~11.4x</a:t>
             </a:r>
             <a:endParaRPr lang="en-US" sz="750" dirty="0"/>
           </a:p>
@@ -15029,7 +15066,7 @@
         </p:nvSpPr>
         <p:spPr>
           <a:xfrm>
-            <a:off x="5600700" y="5340096"/>
+            <a:off x="2432304" y="5340096"/>
             <a:ext cx="0" cy="292608"/>
           </a:xfrm>
           <a:prstGeom prst="line">
@@ -15052,7 +15089,7 @@
         </p:nvSpPr>
         <p:spPr>
           <a:xfrm>
-            <a:off x="4869180" y="5760720"/>
+            <a:off x="1700784" y="5760720"/>
             <a:ext cx="1463040" cy="164592"/>
           </a:xfrm>
           <a:prstGeom prst="rect">
@@ -15091,7 +15128,7 @@
         </p:nvSpPr>
         <p:spPr>
           <a:xfrm>
-            <a:off x="2679878" y="5431536"/>
+            <a:off x="1920697" y="5431536"/>
             <a:ext cx="109728" cy="109728"/>
           </a:xfrm>
           <a:prstGeom prst="ellipse">
@@ -15111,7 +15148,7 @@
         </p:nvSpPr>
         <p:spPr>
           <a:xfrm>
-            <a:off x="1957502" y="5175504"/>
+            <a:off x="1198321" y="5175504"/>
             <a:ext cx="1554480" cy="182880"/>
           </a:xfrm>
           <a:prstGeom prst="rect">
@@ -15136,7 +15173,7 @@
                 <a:ea typeface="IBM Plex Mono" pitchFamily="34" charset="-122"/>
                 <a:cs typeface="IBM Plex Mono" pitchFamily="34" charset="-120"/>
               </a:rPr>
-              <a:t>DCF $4.4bn·8.5x</a:t>
+              <a:t>DCF $6.0bn·8.1x</a:t>
             </a:r>
             <a:endParaRPr lang="en-US" sz="750" dirty="0"/>
           </a:p>
@@ -15175,7 +15212,7 @@
                 <a:ea typeface="IBM Plex Mono" pitchFamily="34" charset="-122"/>
                 <a:cs typeface="IBM Plex Mono" pitchFamily="34" charset="-120"/>
               </a:rPr>
-              <a:t>$3bn</a:t>
+              <a:t>$5bn</a:t>
             </a:r>
             <a:endParaRPr lang="en-US" sz="650" dirty="0"/>
           </a:p>
@@ -15189,7 +15226,7 @@
         </p:nvSpPr>
         <p:spPr>
           <a:xfrm>
-            <a:off x="1869948" y="5888736"/>
+            <a:off x="1664208" y="5888736"/>
             <a:ext cx="548640" cy="146304"/>
           </a:xfrm>
           <a:prstGeom prst="rect">
@@ -15214,7 +15251,7 @@
                 <a:ea typeface="IBM Plex Mono" pitchFamily="34" charset="-122"/>
                 <a:cs typeface="IBM Plex Mono" pitchFamily="34" charset="-120"/>
               </a:rPr>
-              <a:t>$4bn</a:t>
+              <a:t>$6bn</a:t>
             </a:r>
             <a:endParaRPr lang="en-US" sz="650" dirty="0"/>
           </a:p>
@@ -15228,7 +15265,7 @@
         </p:nvSpPr>
         <p:spPr>
           <a:xfrm>
-            <a:off x="3310128" y="5888736"/>
+            <a:off x="2898648" y="5888736"/>
             <a:ext cx="548640" cy="146304"/>
           </a:xfrm>
           <a:prstGeom prst="rect">
@@ -15253,7 +15290,7 @@
                 <a:ea typeface="IBM Plex Mono" pitchFamily="34" charset="-122"/>
                 <a:cs typeface="IBM Plex Mono" pitchFamily="34" charset="-120"/>
               </a:rPr>
-              <a:t>$5bn</a:t>
+              <a:t>$7bn</a:t>
             </a:r>
             <a:endParaRPr lang="en-US" sz="650" dirty="0"/>
           </a:p>
@@ -15267,7 +15304,7 @@
         </p:nvSpPr>
         <p:spPr>
           <a:xfrm>
-            <a:off x="4750308" y="5888736"/>
+            <a:off x="4133088" y="5888736"/>
             <a:ext cx="548640" cy="146304"/>
           </a:xfrm>
           <a:prstGeom prst="rect">
@@ -15292,7 +15329,7 @@
                 <a:ea typeface="IBM Plex Mono" pitchFamily="34" charset="-122"/>
                 <a:cs typeface="IBM Plex Mono" pitchFamily="34" charset="-120"/>
               </a:rPr>
-              <a:t>$6bn</a:t>
+              <a:t>$8bn</a:t>
             </a:r>
             <a:endParaRPr lang="en-US" sz="650" dirty="0"/>
           </a:p>
@@ -15306,7 +15343,7 @@
         </p:nvSpPr>
         <p:spPr>
           <a:xfrm>
-            <a:off x="6190488" y="5888736"/>
+            <a:off x="5367528" y="5888736"/>
             <a:ext cx="548640" cy="146304"/>
           </a:xfrm>
           <a:prstGeom prst="rect">
@@ -15331,7 +15368,7 @@
                 <a:ea typeface="IBM Plex Mono" pitchFamily="34" charset="-122"/>
                 <a:cs typeface="IBM Plex Mono" pitchFamily="34" charset="-120"/>
               </a:rPr>
-              <a:t>$7bn</a:t>
+              <a:t>$9bn</a:t>
             </a:r>
             <a:endParaRPr lang="en-US" sz="650" dirty="0"/>
           </a:p>
@@ -15345,7 +15382,7 @@
         </p:nvSpPr>
         <p:spPr>
           <a:xfrm>
-            <a:off x="7630668" y="5888736"/>
+            <a:off x="6601968" y="5888736"/>
             <a:ext cx="548640" cy="146304"/>
           </a:xfrm>
           <a:prstGeom prst="rect">
@@ -15370,7 +15407,7 @@
                 <a:ea typeface="IBM Plex Mono" pitchFamily="34" charset="-122"/>
                 <a:cs typeface="IBM Plex Mono" pitchFamily="34" charset="-120"/>
               </a:rPr>
-              <a:t>$8bn</a:t>
+              <a:t>$10bn</a:t>
             </a:r>
             <a:endParaRPr lang="en-US" sz="650" dirty="0"/>
           </a:p>
@@ -15384,7 +15421,7 @@
         </p:nvSpPr>
         <p:spPr>
           <a:xfrm>
-            <a:off x="9070848" y="5888736"/>
+            <a:off x="7836408" y="5888736"/>
             <a:ext cx="548640" cy="146304"/>
           </a:xfrm>
           <a:prstGeom prst="rect">
@@ -15409,7 +15446,7 @@
                 <a:ea typeface="IBM Plex Mono" pitchFamily="34" charset="-122"/>
                 <a:cs typeface="IBM Plex Mono" pitchFamily="34" charset="-120"/>
               </a:rPr>
-              <a:t>$9bn</a:t>
+              <a:t>$11bn</a:t>
             </a:r>
             <a:endParaRPr lang="en-US" sz="650" dirty="0"/>
           </a:p>
@@ -15417,7 +15454,46 @@
       </p:sp>
       <p:sp>
         <p:nvSpPr>
-          <p:cNvPr id="34" name="Shape 30"/>
+          <p:cNvPr id="34" name="Text 30"/>
+          <p:cNvSpPr/>
+          <p:nvPr/>
+        </p:nvSpPr>
+        <p:spPr>
+          <a:xfrm>
+            <a:off x="9070848" y="5888736"/>
+            <a:ext cx="548640" cy="146304"/>
+          </a:xfrm>
+          <a:prstGeom prst="rect">
+            <a:avLst/>
+          </a:prstGeom>
+          <a:noFill/>
+          <a:ln/>
+        </p:spPr>
+        <p:txBody>
+          <a:bodyPr wrap="square" lIns="0" tIns="0" rIns="0" bIns="0" rtlCol="0" anchor="ctr"/>
+          <a:lstStyle/>
+          <a:p>
+            <a:pPr algn="ctr" indent="0" marL="0">
+              <a:buNone/>
+            </a:pPr>
+            <a:r>
+              <a:rPr lang="en-US" sz="650" dirty="0">
+                <a:solidFill>
+                  <a:srgbClr val="9A847C"/>
+                </a:solidFill>
+                <a:latin typeface="IBM Plex Mono" pitchFamily="34" charset="0"/>
+                <a:ea typeface="IBM Plex Mono" pitchFamily="34" charset="-122"/>
+                <a:cs typeface="IBM Plex Mono" pitchFamily="34" charset="-120"/>
+              </a:rPr>
+              <a:t>$12bn</a:t>
+            </a:r>
+            <a:endParaRPr lang="en-US" sz="650" dirty="0"/>
+          </a:p>
+        </p:txBody>
+      </p:sp>
+      <p:sp>
+        <p:nvSpPr>
+          <p:cNvPr id="35" name="Shape 31"/>
           <p:cNvSpPr/>
           <p:nvPr/>
         </p:nvSpPr>
@@ -15439,7 +15515,7 @@
       </p:sp>
       <p:sp>
         <p:nvSpPr>
-          <p:cNvPr id="35" name="Text 31"/>
+          <p:cNvPr id="36" name="Text 32"/>
           <p:cNvSpPr/>
           <p:nvPr/>
         </p:nvSpPr>
@@ -15490,7 +15566,7 @@
                 <a:ea typeface="IBM Plex Sans KR" pitchFamily="34" charset="-122"/>
                 <a:cs typeface="IBM Plex Sans KR" pitchFamily="34" charset="-120"/>
               </a:rPr>
-              <a:t>BA 18GW 축소로 run-rate ex-AMPC EBITDA </a:t>
+              <a:t>ex-AMPC EBITDA 마진 9%→13% 시 run-rate EBITDA </a:t>
             </a:r>
             <a:pPr indent="0" marL="0">
               <a:lnSpc>
@@ -15501,13 +15577,13 @@
             <a:r>
               <a:rPr lang="en-US" sz="900" b="1" dirty="0">
                 <a:solidFill>
-                  <a:srgbClr val="C1121F"/>
+                  <a:srgbClr val="1E7A4D"/>
                 </a:solidFill>
                 <a:latin typeface="IBM Plex Sans KR" pitchFamily="34" charset="0"/>
                 <a:ea typeface="IBM Plex Sans KR" pitchFamily="34" charset="-122"/>
                 <a:cs typeface="IBM Plex Sans KR" pitchFamily="34" charset="-120"/>
               </a:rPr>
-              <a:t>$554→$518mm</a:t>
+              <a:t>$518→$748mm</a:t>
             </a:r>
             <a:pPr indent="0" marL="0">
               <a:lnSpc>
@@ -15535,13 +15611,13 @@
             <a:r>
               <a:rPr lang="en-US" sz="900" b="1" dirty="0">
                 <a:solidFill>
-                  <a:srgbClr val="C1121F"/>
+                  <a:srgbClr val="1E7A4D"/>
                 </a:solidFill>
                 <a:latin typeface="IBM Plex Sans KR" pitchFamily="34" charset="0"/>
                 <a:ea typeface="IBM Plex Sans KR" pitchFamily="34" charset="-122"/>
                 <a:cs typeface="IBM Plex Sans KR" pitchFamily="34" charset="-120"/>
               </a:rPr>
-              <a:t>13.5~16.5x — 최대결합 13.5x만 정상화 peer(13~15x) 하단 진입, BASE 16.5x는 초과</a:t>
+              <a:t>9.3~11.4x로 전 시나리오가 peer 밴드(8~13x) 진입</a:t>
             </a:r>
             <a:pPr indent="0" marL="0">
               <a:lnSpc>
@@ -15558,7 +15634,7 @@
                 <a:ea typeface="IBM Plex Sans KR" pitchFamily="34" charset="-122"/>
                 <a:cs typeface="IBM Plex Sans KR" pitchFamily="34" charset="-120"/>
               </a:rPr>
-              <a:t>(2029E 분모면 16.6~20.3x). DCF 내재 </a:t>
+              <a:t>(2029E 분모면 11.5~14.0x). DCF 내재 </a:t>
             </a:r>
             <a:pPr indent="0" marL="0">
               <a:lnSpc>
@@ -15575,7 +15651,7 @@
                 <a:ea typeface="IBM Plex Sans KR" pitchFamily="34" charset="-122"/>
                 <a:cs typeface="IBM Plex Sans KR" pitchFamily="34" charset="-120"/>
               </a:rPr>
-              <a:t>8.5x는 여전히 할인</a:t>
+              <a:t>8.1x</a:t>
             </a:r>
             <a:pPr indent="0" marL="0">
               <a:lnSpc>
@@ -15592,7 +15668,7 @@
                 <a:ea typeface="IBM Plex Sans KR" pitchFamily="34" charset="-122"/>
                 <a:cs typeface="IBM Plex Sans KR" pitchFamily="34" charset="-120"/>
               </a:rPr>
-              <a:t>이나, 규모 축소가 지분조달 여력을 악화 → 마진 개선(</a:t>
+              <a:t>. AMPC 비중 </a:t>
             </a:r>
             <a:pPr indent="0" marL="0">
               <a:lnSpc>
@@ -15603,13 +15679,13 @@
             <a:r>
               <a:rPr lang="en-US" sz="900" b="1" dirty="0">
                 <a:solidFill>
-                  <a:srgbClr val="C1121F"/>
+                  <a:srgbClr val="1E7A4D"/>
                 </a:solidFill>
                 <a:latin typeface="IBM Plex Sans KR" pitchFamily="34" charset="0"/>
                 <a:ea typeface="IBM Plex Sans KR" pitchFamily="34" charset="-122"/>
                 <a:cs typeface="IBM Plex Sans KR" pitchFamily="34" charset="-120"/>
               </a:rPr>
-              <a:t>필요 EBITDA% 9.3~11.4%</a:t>
+              <a:t>76→55%</a:t>
             </a:r>
             <a:pPr indent="0" marL="0">
               <a:lnSpc>
@@ -15626,7 +15702,7 @@
                 <a:ea typeface="IBM Plex Sans KR" pitchFamily="34" charset="-122"/>
                 <a:cs typeface="IBM Plex Sans KR" pitchFamily="34" charset="-120"/>
               </a:rPr>
-              <a:t>)·프리미엄 멀티플이 관건. peer는 자체보조금 포함(우리 ex-AMPC, 보수적).</a:t>
+              <a:t>로 사업 자생력↑ — 규모(GWh)보다 마진(%)이 밸류를 좌우. peer는 자체보조금 포함(우리 ex-AMPC, 보수적).</a:t>
             </a:r>
             <a:endParaRPr lang="en-US" sz="900" dirty="0"/>
           </a:p>
@@ -15634,7 +15710,7 @@
       </p:sp>
       <p:sp>
         <p:nvSpPr>
-          <p:cNvPr id="36" name="Shape 32"/>
+          <p:cNvPr id="37" name="Shape 33"/>
           <p:cNvSpPr/>
           <p:nvPr/>
         </p:nvSpPr>
@@ -15657,7 +15733,7 @@
       </p:sp>
       <p:sp>
         <p:nvSpPr>
-          <p:cNvPr id="37" name="Text 33"/>
+          <p:cNvPr id="38" name="Text 34"/>
           <p:cNvSpPr/>
           <p:nvPr/>
         </p:nvSpPr>
@@ -15696,7 +15772,7 @@
       </p:sp>
       <p:sp>
         <p:nvSpPr>
-          <p:cNvPr id="38" name="Text 34"/>
+          <p:cNvPr id="39" name="Text 35"/>
           <p:cNvSpPr/>
           <p:nvPr/>
         </p:nvSpPr>

</xml_diff>